<commit_message>
Implement the Director's full counter-move set and verify it
The documented four counter-moves were not all wired up: rewire() and seal_door()
existed but were never called, choose_sabotage() was never called in any measured
experiment, and the confidence gate defaulted to off. The report also claimed unit
tests that did not exist.

- FullDirector: intercept, seal, rewire, poison, scored by expected disruption x
  confidence, with the fairness rules enforced in code rather than documented
- HabitualBot rewritten to navigate by shortest path so world edits actually bite
- E5: world editing raises objective cost by 60% (15.7 -> 25.2 moves per lap)
- E6: targeted sabotage shows NO advantage under uniform reliance, 12% under
  uneven reliance -- reported as a conditional result
- test_invariants.py: 9 invariants over 25 facilities, all passing
- Demo gains all four counter-moves with live counters
- All figures, report and deck regenerated from metrics.json
</commit_message>
<xml_diff>
--- a/docs/PARITY-review-deck.pptx
+++ b/docs/PARITY-review-deck.pptx
@@ -27,6 +27,9 @@
     <p:sldId id="275" r:id="rId26"/>
     <p:sldId id="276" r:id="rId27"/>
     <p:sldId id="277" r:id="rId28"/>
+    <p:sldId id="278" r:id="rId29"/>
+    <p:sldId id="279" r:id="rId30"/>
+    <p:sldId id="280" r:id="rId31"/>
   </p:sldIdLst>
   <p:sldSz cx="12191695" cy="6858000" type="screen4x3"/>
   <p:notesSz cx="6858000" cy="9144000"/>
@@ -4581,8 +4584,9 @@
                 <a:tableStyleId>{5C22544A-7EE6-4342-B048-85BDC9FD1C3A}</a:tableStyleId>
               </a:tblPr>
               <a:tblGrid>
-                <a:gridCol w="3200400"/>
-                <a:gridCol w="7680960"/>
+                <a:gridCol w="2560320"/>
+                <a:gridCol w="6309360"/>
+                <a:gridCol w="2011680"/>
               </a:tblGrid>
               <a:tr h="384048">
                 <a:tc>
@@ -4639,6 +4643,33 @@
                     </a:solidFill>
                   </a:tcPr>
                 </a:tc>
+                <a:tc>
+                  <a:txBody>
+                    <a:bodyPr/>
+                    <a:lstStyle/>
+                    <a:p>
+                      <a:pPr>
+                        <a:lnSpc>
+                          <a:spcPct val="115000"/>
+                        </a:lnSpc>
+                      </a:pPr>
+                      <a:r>
+                        <a:rPr sz="950" b="1">
+                          <a:solidFill>
+                            <a:srgbClr val="6B7178"/>
+                          </a:solidFill>
+                          <a:latin typeface="Arial"/>
+                        </a:rPr>
+                        <a:t>Status</a:t>
+                      </a:r>
+                    </a:p>
+                  </a:txBody>
+                  <a:tcPr marL="73152" marR="73152" marT="36576" marB="36576">
+                    <a:solidFill>
+                      <a:srgbClr val="F4F6F8"/>
+                    </a:solidFill>
+                  </a:tcPr>
+                </a:tc>
               </a:tr>
               <a:tr h="384048">
                 <a:tc>
@@ -4652,7 +4683,7 @@
                         </a:lnSpc>
                       </a:pPr>
                       <a:r>
-                        <a:rPr sz="1300" b="0">
+                        <a:rPr sz="1250" b="0">
                           <a:solidFill>
                             <a:srgbClr val="16181A"/>
                           </a:solidFill>
@@ -4679,13 +4710,40 @@
                         </a:lnSpc>
                       </a:pPr>
                       <a:r>
-                        <a:rPr sz="1300" b="0">
+                        <a:rPr sz="1250" b="0">
                           <a:solidFill>
                             <a:srgbClr val="16181A"/>
                           </a:solidFill>
                           <a:latin typeface="Arial"/>
                         </a:rPr>
                         <a:t>High confidence on a specific room — move to meet the player there</a:t>
+                      </a:r>
+                    </a:p>
+                  </a:txBody>
+                  <a:tcPr marL="73152" marR="73152" marT="36576" marB="36576">
+                    <a:solidFill>
+                      <a:srgbClr val="FCFCFB"/>
+                    </a:solidFill>
+                  </a:tcPr>
+                </a:tc>
+                <a:tc>
+                  <a:txBody>
+                    <a:bodyPr/>
+                    <a:lstStyle/>
+                    <a:p>
+                      <a:pPr>
+                        <a:lnSpc>
+                          <a:spcPct val="115000"/>
+                        </a:lnSpc>
+                      </a:pPr>
+                      <a:r>
+                        <a:rPr sz="1250" b="0">
+                          <a:solidFill>
+                            <a:srgbClr val="16181A"/>
+                          </a:solidFill>
+                          <a:latin typeface="Arial"/>
+                        </a:rPr>
+                        <a:t>Measured (§14, 16)</a:t>
                       </a:r>
                     </a:p>
                   </a:txBody>
@@ -4708,40 +4766,67 @@
                         </a:lnSpc>
                       </a:pPr>
                       <a:r>
-                        <a:rPr sz="1300" b="0">
-                          <a:solidFill>
-                            <a:srgbClr val="16181A"/>
-                          </a:solidFill>
-                          <a:latin typeface="Arial"/>
-                        </a:rPr>
-                        <a:t>Rewire / rotate a room</a:t>
-                      </a:r>
-                    </a:p>
-                  </a:txBody>
-                  <a:tcPr marL="73152" marR="73152" marT="36576" marB="36576">
-                    <a:solidFill>
-                      <a:srgbClr val="FCFCFB"/>
-                    </a:solidFill>
-                  </a:tcPr>
-                </a:tc>
-                <a:tc>
-                  <a:txBody>
-                    <a:bodyPr/>
-                    <a:lstStyle/>
-                    <a:p>
-                      <a:pPr>
-                        <a:lnSpc>
-                          <a:spcPct val="115000"/>
-                        </a:lnSpc>
-                      </a:pPr>
-                      <a:r>
-                        <a:rPr sz="1300" b="0">
-                          <a:solidFill>
-                            <a:srgbClr val="16181A"/>
-                          </a:solidFill>
-                          <a:latin typeface="Arial"/>
-                        </a:rPr>
-                        <a:t>High confidence on a transit route — change it before they arrive</a:t>
+                        <a:rPr sz="1250" b="0">
+                          <a:solidFill>
+                            <a:srgbClr val="16181A"/>
+                          </a:solidFill>
+                          <a:latin typeface="Arial"/>
+                        </a:rPr>
+                        <a:t>Rewire a room ahead</a:t>
+                      </a:r>
+                    </a:p>
+                  </a:txBody>
+                  <a:tcPr marL="73152" marR="73152" marT="36576" marB="36576">
+                    <a:solidFill>
+                      <a:srgbClr val="FCFCFB"/>
+                    </a:solidFill>
+                  </a:tcPr>
+                </a:tc>
+                <a:tc>
+                  <a:txBody>
+                    <a:bodyPr/>
+                    <a:lstStyle/>
+                    <a:p>
+                      <a:pPr>
+                        <a:lnSpc>
+                          <a:spcPct val="115000"/>
+                        </a:lnSpc>
+                      </a:pPr>
+                      <a:r>
+                        <a:rPr sz="1250" b="0">
+                          <a:solidFill>
+                            <a:srgbClr val="16181A"/>
+                          </a:solidFill>
+                          <a:latin typeface="Arial"/>
+                        </a:rPr>
+                        <a:t>High confidence on a route — change it before they arrive</a:t>
+                      </a:r>
+                    </a:p>
+                  </a:txBody>
+                  <a:tcPr marL="73152" marR="73152" marT="36576" marB="36576">
+                    <a:solidFill>
+                      <a:srgbClr val="FCFCFB"/>
+                    </a:solidFill>
+                  </a:tcPr>
+                </a:tc>
+                <a:tc>
+                  <a:txBody>
+                    <a:bodyPr/>
+                    <a:lstStyle/>
+                    <a:p>
+                      <a:pPr>
+                        <a:lnSpc>
+                          <a:spcPct val="115000"/>
+                        </a:lnSpc>
+                      </a:pPr>
+                      <a:r>
+                        <a:rPr sz="1250" b="0">
+                          <a:solidFill>
+                            <a:srgbClr val="16181A"/>
+                          </a:solidFill>
+                          <a:latin typeface="Arial"/>
+                        </a:rPr>
+                        <a:t>Measured (§17)</a:t>
                       </a:r>
                     </a:p>
                   </a:txBody>
@@ -4764,40 +4849,67 @@
                         </a:lnSpc>
                       </a:pPr>
                       <a:r>
-                        <a:rPr sz="1300" b="0">
-                          <a:solidFill>
-                            <a:srgbClr val="16181A"/>
-                          </a:solidFill>
-                          <a:latin typeface="Arial"/>
-                        </a:rPr>
-                        <a:t>Poison a codebook</a:t>
-                      </a:r>
-                    </a:p>
-                  </a:txBody>
-                  <a:tcPr marL="73152" marR="73152" marT="36576" marB="36576">
-                    <a:solidFill>
-                      <a:srgbClr val="FCFCFB"/>
-                    </a:solidFill>
-                  </a:tcPr>
-                </a:tc>
-                <a:tc>
-                  <a:txBody>
-                    <a:bodyPr/>
-                    <a:lstStyle/>
-                    <a:p>
-                      <a:pPr>
-                        <a:lnSpc>
-                          <a:spcPct val="115000"/>
-                        </a:lnSpc>
-                      </a:pPr>
-                      <a:r>
-                        <a:rPr sz="1300" b="0">
-                          <a:solidFill>
-                            <a:srgbClr val="16181A"/>
-                          </a:solidFill>
-                          <a:latin typeface="Arial"/>
-                        </a:rPr>
-                        <a:t>A recorded entry the player is predicted to need again</a:t>
+                        <a:rPr sz="1250" b="0">
+                          <a:solidFill>
+                            <a:srgbClr val="16181A"/>
+                          </a:solidFill>
+                          <a:latin typeface="Arial"/>
+                        </a:rPr>
+                        <a:t>Seal a shortcut</a:t>
+                      </a:r>
+                    </a:p>
+                  </a:txBody>
+                  <a:tcPr marL="73152" marR="73152" marT="36576" marB="36576">
+                    <a:solidFill>
+                      <a:srgbClr val="FCFCFB"/>
+                    </a:solidFill>
+                  </a:tcPr>
+                </a:tc>
+                <a:tc>
+                  <a:txBody>
+                    <a:bodyPr/>
+                    <a:lstStyle/>
+                    <a:p>
+                      <a:pPr>
+                        <a:lnSpc>
+                          <a:spcPct val="115000"/>
+                        </a:lnSpc>
+                      </a:pPr>
+                      <a:r>
+                        <a:rPr sz="1250" b="0">
+                          <a:solidFill>
+                            <a:srgbClr val="16181A"/>
+                          </a:solidFill>
+                          <a:latin typeface="Arial"/>
+                        </a:rPr>
+                        <a:t>An edge with high traversal frequency</a:t>
+                      </a:r>
+                    </a:p>
+                  </a:txBody>
+                  <a:tcPr marL="73152" marR="73152" marT="36576" marB="36576">
+                    <a:solidFill>
+                      <a:srgbClr val="FCFCFB"/>
+                    </a:solidFill>
+                  </a:tcPr>
+                </a:tc>
+                <a:tc>
+                  <a:txBody>
+                    <a:bodyPr/>
+                    <a:lstStyle/>
+                    <a:p>
+                      <a:pPr>
+                        <a:lnSpc>
+                          <a:spcPct val="115000"/>
+                        </a:lnSpc>
+                      </a:pPr>
+                      <a:r>
+                        <a:rPr sz="1250" b="0">
+                          <a:solidFill>
+                            <a:srgbClr val="16181A"/>
+                          </a:solidFill>
+                          <a:latin typeface="Arial"/>
+                        </a:rPr>
+                        <a:t>Measured (§17)</a:t>
                       </a:r>
                     </a:p>
                   </a:txBody>
@@ -4820,40 +4932,67 @@
                         </a:lnSpc>
                       </a:pPr>
                       <a:r>
-                        <a:rPr sz="1300" b="0">
-                          <a:solidFill>
-                            <a:srgbClr val="16181A"/>
-                          </a:solidFill>
-                          <a:latin typeface="Arial"/>
-                        </a:rPr>
-                        <a:t>Seal a shortcut</a:t>
-                      </a:r>
-                    </a:p>
-                  </a:txBody>
-                  <a:tcPr marL="73152" marR="73152" marT="36576" marB="36576">
-                    <a:solidFill>
-                      <a:srgbClr val="FCFCFB"/>
-                    </a:solidFill>
-                  </a:tcPr>
-                </a:tc>
-                <a:tc>
-                  <a:txBody>
-                    <a:bodyPr/>
-                    <a:lstStyle/>
-                    <a:p>
-                      <a:pPr>
-                        <a:lnSpc>
-                          <a:spcPct val="115000"/>
-                        </a:lnSpc>
-                      </a:pPr>
-                      <a:r>
-                        <a:rPr sz="1300" b="0">
-                          <a:solidFill>
-                            <a:srgbClr val="16181A"/>
-                          </a:solidFill>
-                          <a:latin typeface="Arial"/>
-                        </a:rPr>
-                        <a:t>An edge with high traversal frequency</a:t>
+                        <a:rPr sz="1250" b="0">
+                          <a:solidFill>
+                            <a:srgbClr val="16181A"/>
+                          </a:solidFill>
+                          <a:latin typeface="Arial"/>
+                        </a:rPr>
+                        <a:t>Poison a codebook</a:t>
+                      </a:r>
+                    </a:p>
+                  </a:txBody>
+                  <a:tcPr marL="73152" marR="73152" marT="36576" marB="36576">
+                    <a:solidFill>
+                      <a:srgbClr val="FCFCFB"/>
+                    </a:solidFill>
+                  </a:tcPr>
+                </a:tc>
+                <a:tc>
+                  <a:txBody>
+                    <a:bodyPr/>
+                    <a:lstStyle/>
+                    <a:p>
+                      <a:pPr>
+                        <a:lnSpc>
+                          <a:spcPct val="115000"/>
+                        </a:lnSpc>
+                      </a:pPr>
+                      <a:r>
+                        <a:rPr sz="1250" b="0">
+                          <a:solidFill>
+                            <a:srgbClr val="16181A"/>
+                          </a:solidFill>
+                          <a:latin typeface="Arial"/>
+                        </a:rPr>
+                        <a:t>A recorded entry the player is predicted to need again</a:t>
+                      </a:r>
+                    </a:p>
+                  </a:txBody>
+                  <a:tcPr marL="73152" marR="73152" marT="36576" marB="36576">
+                    <a:solidFill>
+                      <a:srgbClr val="FCFCFB"/>
+                    </a:solidFill>
+                  </a:tcPr>
+                </a:tc>
+                <a:tc>
+                  <a:txBody>
+                    <a:bodyPr/>
+                    <a:lstStyle/>
+                    <a:p>
+                      <a:pPr>
+                        <a:lnSpc>
+                          <a:spcPct val="115000"/>
+                        </a:lnSpc>
+                      </a:pPr>
+                      <a:r>
+                        <a:rPr sz="1250" b="0">
+                          <a:solidFill>
+                            <a:srgbClr val="16181A"/>
+                          </a:solidFill>
+                          <a:latin typeface="Arial"/>
+                        </a:rPr>
+                        <a:t>Measured (§18)</a:t>
                       </a:r>
                     </a:p>
                   </a:txBody>
@@ -7262,7 +7401,7 @@
                 </a:solidFill>
                 <a:latin typeface="Arial"/>
               </a:rPr>
-              <a:t>Rolling top-1 accuracy rises from 48% to 87% within roughly 60 observed moves — under a minute of play.</a:t>
+              <a:t>Rolling top-1 accuracy rises from 45% to 89% within roughly 60 observed moves — under a minute of play.</a:t>
             </a:r>
           </a:p>
         </p:txBody>
@@ -7482,7 +7621,7 @@
                 </a:solidFill>
                 <a:latin typeface="Arial"/>
               </a:rPr>
-              <a:t>The hub-camping baseline is included deliberately: a model that cannot beat 'sit in the busiest room' has not earned its complexity. The proposed director achieves 4.3× the control and 1.7× the strongest non-learning heuristic.</a:t>
+              <a:t>The hub-camping baseline is included deliberately: a model that cannot beat 'sit in the busiest room' has not earned its complexity. The proposed director achieves 3.7× the control and 1.2× the strongest non-learning heuristic.</a:t>
             </a:r>
           </a:p>
         </p:txBody>
@@ -7550,7 +7689,7 @@
                 </a:solidFill>
                 <a:latin typeface="Arial"/>
               </a:rPr>
-              <a:t>17 · LIVE DEMONSTRATION</a:t>
+              <a:t>17 · RESULTS — DO THE WORLD EDITS MATTER?</a:t>
             </a:r>
           </a:p>
         </p:txBody>
@@ -7592,7 +7731,7 @@
                 </a:solidFill>
                 <a:latin typeface="Arial"/>
               </a:rPr>
-              <a:t>The full loop, running</a:t>
+              <a:t>Interception is only one of four counter-moves</a:t>
             </a:r>
           </a:p>
         </p:txBody>
@@ -7641,6 +7780,2348 @@
           </a:p>
         </p:txBody>
       </p:sp>
+      <p:pic>
+        <p:nvPicPr>
+          <p:cNvPr id="5" name="Picture 4" descr="fig_disruption.png"/>
+          <p:cNvPicPr>
+            <a:picLocks noChangeAspect="1"/>
+          </p:cNvPicPr>
+          <p:nvPr/>
+        </p:nvPicPr>
+        <p:blipFill>
+          <a:blip r:embed="rId2"/>
+          <a:stretch>
+            <a:fillRect/>
+          </a:stretch>
+        </p:blipFill>
+        <p:spPr>
+          <a:xfrm>
+            <a:off x="2286000" y="1737360"/>
+            <a:ext cx="7680960" cy="3653140"/>
+          </a:xfrm>
+          <a:prstGeom prst="rect">
+            <a:avLst/>
+          </a:prstGeom>
+        </p:spPr>
+      </p:pic>
+      <p:sp>
+        <p:nvSpPr>
+          <p:cNvPr id="6" name="TextBox 5"/>
+          <p:cNvSpPr txBox="1"/>
+          <p:nvPr/>
+        </p:nvSpPr>
+        <p:spPr>
+          <a:xfrm>
+            <a:off x="658368" y="5532120"/>
+            <a:ext cx="10881360" cy="1005840"/>
+          </a:xfrm>
+          <a:prstGeom prst="rect">
+            <a:avLst/>
+          </a:prstGeom>
+          <a:noFill/>
+        </p:spPr>
+        <p:txBody>
+          <a:bodyPr wrap="square" lIns="0" rIns="0" tIns="0" bIns="0">
+            <a:spAutoFit/>
+          </a:bodyPr>
+          <a:lstStyle/>
+          <a:p>
+            <a:pPr algn="l">
+              <a:lnSpc>
+                <a:spcPct val="130000"/>
+              </a:lnSpc>
+              <a:spcAft>
+                <a:spcPts val="600"/>
+              </a:spcAft>
+            </a:pPr>
+            <a:r>
+              <a:rPr sz="1300" b="0">
+                <a:solidFill>
+                  <a:srgbClr val="6B7178"/>
+                </a:solidFill>
+                <a:latin typeface="Arial"/>
+              </a:rPr>
+              <a:t>The entity is removed entirely here, isolating topology mutation. Sealing and rewiring ahead of the player raises the cost of completing an objective by 60% (15.7 to 25.2 moves per lap). Every one of the 350 rewires and 55 seals passed the reachability check — no run was ever soft-locked.</a:t>
+            </a:r>
+          </a:p>
+        </p:txBody>
+      </p:sp>
+    </p:spTree>
+  </p:cSld>
+  <p:clrMapOvr>
+    <a:masterClrMapping/>
+  </p:clrMapOvr>
+</p:sld>
+</file>
+
+<file path=ppt/slides/slide2.xml><?xml version="1.0" encoding="utf-8"?>
+<p:sld xmlns:a="http://schemas.openxmlformats.org/drawingml/2006/main" xmlns:p="http://schemas.openxmlformats.org/presentationml/2006/main" xmlns:r="http://schemas.openxmlformats.org/officeDocument/2006/relationships">
+  <p:cSld>
+    <p:bg>
+      <p:bgPr>
+        <a:solidFill>
+          <a:srgbClr val="FCFCFB"/>
+        </a:solidFill>
+        <a:effectLst/>
+      </p:bgPr>
+    </p:bg>
+    <p:spTree>
+      <p:nvGrpSpPr>
+        <p:cNvPr id="1" name=""/>
+        <p:cNvGrpSpPr/>
+        <p:nvPr/>
+      </p:nvGrpSpPr>
+      <p:grpSpPr/>
+      <p:sp>
+        <p:nvSpPr>
+          <p:cNvPr id="2" name="TextBox 1"/>
+          <p:cNvSpPr txBox="1"/>
+          <p:nvPr/>
+        </p:nvSpPr>
+        <p:spPr>
+          <a:xfrm>
+            <a:off x="658368" y="420624"/>
+            <a:ext cx="10881360" cy="274320"/>
+          </a:xfrm>
+          <a:prstGeom prst="rect">
+            <a:avLst/>
+          </a:prstGeom>
+          <a:noFill/>
+        </p:spPr>
+        <p:txBody>
+          <a:bodyPr wrap="square" lIns="0" rIns="0" tIns="0" bIns="0">
+            <a:spAutoFit/>
+          </a:bodyPr>
+          <a:lstStyle/>
+          <a:p>
+            <a:pPr algn="l">
+              <a:lnSpc>
+                <a:spcPct val="125000"/>
+              </a:lnSpc>
+              <a:spcAft>
+                <a:spcPts val="600"/>
+              </a:spcAft>
+            </a:pPr>
+            <a:r>
+              <a:rPr sz="1050" b="1">
+                <a:solidFill>
+                  <a:srgbClr val="2A78D6"/>
+                </a:solidFill>
+                <a:latin typeface="Arial"/>
+              </a:rPr>
+              <a:t>WHAT THIS REVIEW COVERS</a:t>
+            </a:r>
+          </a:p>
+        </p:txBody>
+      </p:sp>
+      <p:sp>
+        <p:nvSpPr>
+          <p:cNvPr id="3" name="TextBox 2"/>
+          <p:cNvSpPr txBox="1"/>
+          <p:nvPr/>
+        </p:nvSpPr>
+        <p:spPr>
+          <a:xfrm>
+            <a:off x="658368" y="749808"/>
+            <a:ext cx="10881360" cy="822960"/>
+          </a:xfrm>
+          <a:prstGeom prst="rect">
+            <a:avLst/>
+          </a:prstGeom>
+          <a:noFill/>
+        </p:spPr>
+        <p:txBody>
+          <a:bodyPr wrap="square" lIns="0" rIns="0" tIns="0" bIns="0">
+            <a:spAutoFit/>
+          </a:bodyPr>
+          <a:lstStyle/>
+          <a:p>
+            <a:pPr algn="l">
+              <a:lnSpc>
+                <a:spcPct val="125000"/>
+              </a:lnSpc>
+              <a:spcAft>
+                <a:spcPts val="600"/>
+              </a:spcAft>
+            </a:pPr>
+            <a:r>
+              <a:rPr sz="2800" b="1">
+                <a:solidFill>
+                  <a:srgbClr val="16181A"/>
+                </a:solidFill>
+                <a:latin typeface="Arial"/>
+              </a:rPr>
+              <a:t>Mapped to the marking rubric</a:t>
+            </a:r>
+          </a:p>
+        </p:txBody>
+      </p:sp>
+      <p:sp>
+        <p:nvSpPr>
+          <p:cNvPr id="4" name="Rectangle 3"/>
+          <p:cNvSpPr/>
+          <p:nvPr/>
+        </p:nvSpPr>
+        <p:spPr>
+          <a:xfrm>
+            <a:off x="658368" y="1481328"/>
+            <a:ext cx="10881360" cy="18288"/>
+          </a:xfrm>
+          <a:prstGeom prst="rect">
+            <a:avLst/>
+          </a:prstGeom>
+          <a:solidFill>
+            <a:srgbClr val="D8DCE0"/>
+          </a:solidFill>
+          <a:ln>
+            <a:noFill/>
+          </a:ln>
+          <a:effectLst/>
+        </p:spPr>
+        <p:style>
+          <a:lnRef idx="1">
+            <a:schemeClr val="accent1"/>
+          </a:lnRef>
+          <a:fillRef idx="3">
+            <a:schemeClr val="accent1"/>
+          </a:fillRef>
+          <a:effectRef idx="2">
+            <a:schemeClr val="accent1"/>
+          </a:effectRef>
+          <a:fontRef idx="minor">
+            <a:schemeClr val="lt1"/>
+          </a:fontRef>
+        </p:style>
+        <p:txBody>
+          <a:bodyPr rtlCol="0" anchor="ctr"/>
+          <a:lstStyle/>
+          <a:p>
+            <a:pPr algn="ctr"/>
+          </a:p>
+        </p:txBody>
+      </p:sp>
+      <p:graphicFrame>
+        <p:nvGraphicFramePr>
+          <p:cNvPr id="5" name="Table 4"/>
+          <p:cNvGraphicFramePr>
+            <a:graphicFrameLocks noGrp="1"/>
+          </p:cNvGraphicFramePr>
+          <p:nvPr/>
+        </p:nvGraphicFramePr>
+        <p:xfrm>
+          <a:off x="658368" y="1783080"/>
+          <a:ext cx="10881360" cy="2304288"/>
+        </p:xfrm>
+        <a:graphic>
+          <a:graphicData uri="http://schemas.openxmlformats.org/drawingml/2006/table">
+            <a:tbl>
+              <a:tblPr firstRow="1" bandRow="1">
+                <a:tableStyleId>{5C22544A-7EE6-4342-B048-85BDC9FD1C3A}</a:tableStyleId>
+              </a:tblPr>
+              <a:tblGrid>
+                <a:gridCol w="3931920"/>
+                <a:gridCol w="3657600"/>
+                <a:gridCol w="3291840"/>
+              </a:tblGrid>
+              <a:tr h="384048">
+                <a:tc>
+                  <a:txBody>
+                    <a:bodyPr/>
+                    <a:lstStyle/>
+                    <a:p>
+                      <a:pPr>
+                        <a:lnSpc>
+                          <a:spcPct val="115000"/>
+                        </a:lnSpc>
+                      </a:pPr>
+                      <a:r>
+                        <a:rPr sz="950" b="1">
+                          <a:solidFill>
+                            <a:srgbClr val="6B7178"/>
+                          </a:solidFill>
+                          <a:latin typeface="Arial"/>
+                        </a:rPr>
+                        <a:t>Rubric</a:t>
+                      </a:r>
+                    </a:p>
+                  </a:txBody>
+                  <a:tcPr marL="73152" marR="73152" marT="36576" marB="36576">
+                    <a:solidFill>
+                      <a:srgbClr val="F4F6F8"/>
+                    </a:solidFill>
+                  </a:tcPr>
+                </a:tc>
+                <a:tc>
+                  <a:txBody>
+                    <a:bodyPr/>
+                    <a:lstStyle/>
+                    <a:p>
+                      <a:pPr>
+                        <a:lnSpc>
+                          <a:spcPct val="115000"/>
+                        </a:lnSpc>
+                      </a:pPr>
+                      <a:r>
+                        <a:rPr sz="950" b="1">
+                          <a:solidFill>
+                            <a:srgbClr val="6B7178"/>
+                          </a:solidFill>
+                          <a:latin typeface="Arial"/>
+                        </a:rPr>
+                        <a:t>Where it is answered</a:t>
+                      </a:r>
+                    </a:p>
+                  </a:txBody>
+                  <a:tcPr marL="73152" marR="73152" marT="36576" marB="36576">
+                    <a:solidFill>
+                      <a:srgbClr val="F4F6F8"/>
+                    </a:solidFill>
+                  </a:tcPr>
+                </a:tc>
+                <a:tc>
+                  <a:txBody>
+                    <a:bodyPr/>
+                    <a:lstStyle/>
+                    <a:p>
+                      <a:pPr>
+                        <a:lnSpc>
+                          <a:spcPct val="115000"/>
+                        </a:lnSpc>
+                      </a:pPr>
+                      <a:r>
+                        <a:rPr sz="950" b="1">
+                          <a:solidFill>
+                            <a:srgbClr val="6B7178"/>
+                          </a:solidFill>
+                          <a:latin typeface="Arial"/>
+                        </a:rPr>
+                        <a:t>Evidence</a:t>
+                      </a:r>
+                    </a:p>
+                  </a:txBody>
+                  <a:tcPr marL="73152" marR="73152" marT="36576" marB="36576">
+                    <a:solidFill>
+                      <a:srgbClr val="F4F6F8"/>
+                    </a:solidFill>
+                  </a:tcPr>
+                </a:tc>
+              </a:tr>
+              <a:tr h="384048">
+                <a:tc>
+                  <a:txBody>
+                    <a:bodyPr/>
+                    <a:lstStyle/>
+                    <a:p>
+                      <a:pPr>
+                        <a:lnSpc>
+                          <a:spcPct val="115000"/>
+                        </a:lnSpc>
+                      </a:pPr>
+                      <a:r>
+                        <a:rPr sz="1250" b="0">
+                          <a:solidFill>
+                            <a:srgbClr val="16181A"/>
+                          </a:solidFill>
+                          <a:latin typeface="Arial"/>
+                        </a:rPr>
+                        <a:t>Knowledge on domain / problem statement</a:t>
+                      </a:r>
+                    </a:p>
+                  </a:txBody>
+                  <a:tcPr marL="73152" marR="73152" marT="36576" marB="36576">
+                    <a:solidFill>
+                      <a:srgbClr val="FCFCFB"/>
+                    </a:solidFill>
+                  </a:tcPr>
+                </a:tc>
+                <a:tc>
+                  <a:txBody>
+                    <a:bodyPr/>
+                    <a:lstStyle/>
+                    <a:p>
+                      <a:pPr>
+                        <a:lnSpc>
+                          <a:spcPct val="115000"/>
+                        </a:lnSpc>
+                      </a:pPr>
+                      <a:r>
+                        <a:rPr sz="1250" b="0">
+                          <a:solidFill>
+                            <a:srgbClr val="16181A"/>
+                          </a:solidFill>
+                          <a:latin typeface="Arial"/>
+                        </a:rPr>
+                        <a:t>Sections 1–3 of this deck</a:t>
+                      </a:r>
+                    </a:p>
+                  </a:txBody>
+                  <a:tcPr marL="73152" marR="73152" marT="36576" marB="36576">
+                    <a:solidFill>
+                      <a:srgbClr val="FCFCFB"/>
+                    </a:solidFill>
+                  </a:tcPr>
+                </a:tc>
+                <a:tc>
+                  <a:txBody>
+                    <a:bodyPr/>
+                    <a:lstStyle/>
+                    <a:p>
+                      <a:pPr>
+                        <a:lnSpc>
+                          <a:spcPct val="115000"/>
+                        </a:lnSpc>
+                      </a:pPr>
+                      <a:r>
+                        <a:rPr sz="1250" b="0">
+                          <a:solidFill>
+                            <a:srgbClr val="16181A"/>
+                          </a:solidFill>
+                          <a:latin typeface="Arial"/>
+                        </a:rPr>
+                        <a:t>Gap analysis over 22 works</a:t>
+                      </a:r>
+                    </a:p>
+                  </a:txBody>
+                  <a:tcPr marL="73152" marR="73152" marT="36576" marB="36576">
+                    <a:solidFill>
+                      <a:srgbClr val="FCFCFB"/>
+                    </a:solidFill>
+                  </a:tcPr>
+                </a:tc>
+              </a:tr>
+              <a:tr h="384048">
+                <a:tc>
+                  <a:txBody>
+                    <a:bodyPr/>
+                    <a:lstStyle/>
+                    <a:p>
+                      <a:pPr>
+                        <a:lnSpc>
+                          <a:spcPct val="115000"/>
+                        </a:lnSpc>
+                      </a:pPr>
+                      <a:r>
+                        <a:rPr sz="1250" b="0">
+                          <a:solidFill>
+                            <a:srgbClr val="16181A"/>
+                          </a:solidFill>
+                          <a:latin typeface="Arial"/>
+                        </a:rPr>
+                        <a:t>Literature review (min. 15 recent papers)</a:t>
+                      </a:r>
+                    </a:p>
+                  </a:txBody>
+                  <a:tcPr marL="73152" marR="73152" marT="36576" marB="36576">
+                    <a:solidFill>
+                      <a:srgbClr val="FCFCFB"/>
+                    </a:solidFill>
+                  </a:tcPr>
+                </a:tc>
+                <a:tc>
+                  <a:txBody>
+                    <a:bodyPr/>
+                    <a:lstStyle/>
+                    <a:p>
+                      <a:pPr>
+                        <a:lnSpc>
+                          <a:spcPct val="115000"/>
+                        </a:lnSpc>
+                      </a:pPr>
+                      <a:r>
+                        <a:rPr sz="1250" b="0">
+                          <a:solidFill>
+                            <a:srgbClr val="16181A"/>
+                          </a:solidFill>
+                          <a:latin typeface="Arial"/>
+                        </a:rPr>
+                        <a:t>Sections 4–7</a:t>
+                      </a:r>
+                    </a:p>
+                  </a:txBody>
+                  <a:tcPr marL="73152" marR="73152" marT="36576" marB="36576">
+                    <a:solidFill>
+                      <a:srgbClr val="FCFCFB"/>
+                    </a:solidFill>
+                  </a:tcPr>
+                </a:tc>
+                <a:tc>
+                  <a:txBody>
+                    <a:bodyPr/>
+                    <a:lstStyle/>
+                    <a:p>
+                      <a:pPr>
+                        <a:lnSpc>
+                          <a:spcPct val="115000"/>
+                        </a:lnSpc>
+                      </a:pPr>
+                      <a:r>
+                        <a:rPr sz="1250" b="0">
+                          <a:solidFill>
+                            <a:srgbClr val="16181A"/>
+                          </a:solidFill>
+                          <a:latin typeface="Arial"/>
+                        </a:rPr>
+                        <a:t>22 works, 20 from 2023 or later</a:t>
+                      </a:r>
+                    </a:p>
+                  </a:txBody>
+                  <a:tcPr marL="73152" marR="73152" marT="36576" marB="36576">
+                    <a:solidFill>
+                      <a:srgbClr val="FCFCFB"/>
+                    </a:solidFill>
+                  </a:tcPr>
+                </a:tc>
+              </a:tr>
+              <a:tr h="384048">
+                <a:tc>
+                  <a:txBody>
+                    <a:bodyPr/>
+                    <a:lstStyle/>
+                    <a:p>
+                      <a:pPr>
+                        <a:lnSpc>
+                          <a:spcPct val="115000"/>
+                        </a:lnSpc>
+                      </a:pPr>
+                      <a:r>
+                        <a:rPr sz="1250" b="0">
+                          <a:solidFill>
+                            <a:srgbClr val="16181A"/>
+                          </a:solidFill>
+                          <a:latin typeface="Arial"/>
+                        </a:rPr>
+                        <a:t>Design of proposed methodology</a:t>
+                      </a:r>
+                    </a:p>
+                  </a:txBody>
+                  <a:tcPr marL="73152" marR="73152" marT="36576" marB="36576">
+                    <a:solidFill>
+                      <a:srgbClr val="FCFCFB"/>
+                    </a:solidFill>
+                  </a:tcPr>
+                </a:tc>
+                <a:tc>
+                  <a:txBody>
+                    <a:bodyPr/>
+                    <a:lstStyle/>
+                    <a:p>
+                      <a:pPr>
+                        <a:lnSpc>
+                          <a:spcPct val="115000"/>
+                        </a:lnSpc>
+                      </a:pPr>
+                      <a:r>
+                        <a:rPr sz="1250" b="0">
+                          <a:solidFill>
+                            <a:srgbClr val="16181A"/>
+                          </a:solidFill>
+                          <a:latin typeface="Arial"/>
+                        </a:rPr>
+                        <a:t>Sections 8–11</a:t>
+                      </a:r>
+                    </a:p>
+                  </a:txBody>
+                  <a:tcPr marL="73152" marR="73152" marT="36576" marB="36576">
+                    <a:solidFill>
+                      <a:srgbClr val="FCFCFB"/>
+                    </a:solidFill>
+                  </a:tcPr>
+                </a:tc>
+                <a:tc>
+                  <a:txBody>
+                    <a:bodyPr/>
+                    <a:lstStyle/>
+                    <a:p>
+                      <a:pPr>
+                        <a:lnSpc>
+                          <a:spcPct val="115000"/>
+                        </a:lnSpc>
+                      </a:pPr>
+                      <a:r>
+                        <a:rPr sz="1250" b="0">
+                          <a:solidFill>
+                            <a:srgbClr val="16181A"/>
+                          </a:solidFill>
+                          <a:latin typeface="Arial"/>
+                        </a:rPr>
+                        <a:t>Formal model + evaluation protocol</a:t>
+                      </a:r>
+                    </a:p>
+                  </a:txBody>
+                  <a:tcPr marL="73152" marR="73152" marT="36576" marB="36576">
+                    <a:solidFill>
+                      <a:srgbClr val="FCFCFB"/>
+                    </a:solidFill>
+                  </a:tcPr>
+                </a:tc>
+              </a:tr>
+              <a:tr h="384048">
+                <a:tc>
+                  <a:txBody>
+                    <a:bodyPr/>
+                    <a:lstStyle/>
+                    <a:p>
+                      <a:pPr>
+                        <a:lnSpc>
+                          <a:spcPct val="115000"/>
+                        </a:lnSpc>
+                      </a:pPr>
+                      <a:r>
+                        <a:rPr sz="1250" b="0">
+                          <a:solidFill>
+                            <a:srgbClr val="16181A"/>
+                          </a:solidFill>
+                          <a:latin typeface="Arial"/>
+                        </a:rPr>
+                        <a:t>Module description / system design</a:t>
+                      </a:r>
+                    </a:p>
+                  </a:txBody>
+                  <a:tcPr marL="73152" marR="73152" marT="36576" marB="36576">
+                    <a:solidFill>
+                      <a:srgbClr val="FCFCFB"/>
+                    </a:solidFill>
+                  </a:tcPr>
+                </a:tc>
+                <a:tc>
+                  <a:txBody>
+                    <a:bodyPr/>
+                    <a:lstStyle/>
+                    <a:p>
+                      <a:pPr>
+                        <a:lnSpc>
+                          <a:spcPct val="115000"/>
+                        </a:lnSpc>
+                      </a:pPr>
+                      <a:r>
+                        <a:rPr sz="1250" b="0">
+                          <a:solidFill>
+                            <a:srgbClr val="16181A"/>
+                          </a:solidFill>
+                          <a:latin typeface="Arial"/>
+                        </a:rPr>
+                        <a:t>Sections 12–13</a:t>
+                      </a:r>
+                    </a:p>
+                  </a:txBody>
+                  <a:tcPr marL="73152" marR="73152" marT="36576" marB="36576">
+                    <a:solidFill>
+                      <a:srgbClr val="FCFCFB"/>
+                    </a:solidFill>
+                  </a:tcPr>
+                </a:tc>
+                <a:tc>
+                  <a:txBody>
+                    <a:bodyPr/>
+                    <a:lstStyle/>
+                    <a:p>
+                      <a:pPr>
+                        <a:lnSpc>
+                          <a:spcPct val="115000"/>
+                        </a:lnSpc>
+                      </a:pPr>
+                      <a:r>
+                        <a:rPr sz="1250" b="0">
+                          <a:solidFill>
+                            <a:srgbClr val="16181A"/>
+                          </a:solidFill>
+                          <a:latin typeface="Arial"/>
+                        </a:rPr>
+                        <a:t>8 modules, implemented and tested</a:t>
+                      </a:r>
+                    </a:p>
+                  </a:txBody>
+                  <a:tcPr marL="73152" marR="73152" marT="36576" marB="36576">
+                    <a:solidFill>
+                      <a:srgbClr val="FCFCFB"/>
+                    </a:solidFill>
+                  </a:tcPr>
+                </a:tc>
+              </a:tr>
+              <a:tr h="384048">
+                <a:tc>
+                  <a:txBody>
+                    <a:bodyPr/>
+                    <a:lstStyle/>
+                    <a:p>
+                      <a:pPr>
+                        <a:lnSpc>
+                          <a:spcPct val="115000"/>
+                        </a:lnSpc>
+                      </a:pPr>
+                      <a:r>
+                        <a:rPr sz="1250" b="0">
+                          <a:solidFill>
+                            <a:srgbClr val="16181A"/>
+                          </a:solidFill>
+                          <a:latin typeface="Arial"/>
+                        </a:rPr>
+                        <a:t>Beyond the rubric</a:t>
+                      </a:r>
+                    </a:p>
+                  </a:txBody>
+                  <a:tcPr marL="73152" marR="73152" marT="36576" marB="36576">
+                    <a:solidFill>
+                      <a:srgbClr val="FCFCFB"/>
+                    </a:solidFill>
+                  </a:tcPr>
+                </a:tc>
+                <a:tc>
+                  <a:txBody>
+                    <a:bodyPr/>
+                    <a:lstStyle/>
+                    <a:p>
+                      <a:pPr>
+                        <a:lnSpc>
+                          <a:spcPct val="115000"/>
+                        </a:lnSpc>
+                      </a:pPr>
+                      <a:r>
+                        <a:rPr sz="1250" b="0">
+                          <a:solidFill>
+                            <a:srgbClr val="16181A"/>
+                          </a:solidFill>
+                          <a:latin typeface="Arial"/>
+                        </a:rPr>
+                        <a:t>Sections 14–21</a:t>
+                      </a:r>
+                    </a:p>
+                  </a:txBody>
+                  <a:tcPr marL="73152" marR="73152" marT="36576" marB="36576">
+                    <a:solidFill>
+                      <a:srgbClr val="FCFCFB"/>
+                    </a:solidFill>
+                  </a:tcPr>
+                </a:tc>
+                <a:tc>
+                  <a:txBody>
+                    <a:bodyPr/>
+                    <a:lstStyle/>
+                    <a:p>
+                      <a:pPr>
+                        <a:lnSpc>
+                          <a:spcPct val="115000"/>
+                        </a:lnSpc>
+                      </a:pPr>
+                      <a:r>
+                        <a:rPr sz="1250" b="0">
+                          <a:solidFill>
+                            <a:srgbClr val="16181A"/>
+                          </a:solidFill>
+                          <a:latin typeface="Arial"/>
+                        </a:rPr>
+                        <a:t>Six experiments, 9 invariants, a live demo</a:t>
+                      </a:r>
+                    </a:p>
+                  </a:txBody>
+                  <a:tcPr marL="73152" marR="73152" marT="36576" marB="36576">
+                    <a:solidFill>
+                      <a:srgbClr val="FCFCFB"/>
+                    </a:solidFill>
+                  </a:tcPr>
+                </a:tc>
+              </a:tr>
+            </a:tbl>
+          </a:graphicData>
+        </a:graphic>
+      </p:graphicFrame>
+    </p:spTree>
+  </p:cSld>
+  <p:clrMapOvr>
+    <a:masterClrMapping/>
+  </p:clrMapOvr>
+</p:sld>
+</file>
+
+<file path=ppt/slides/slide20.xml><?xml version="1.0" encoding="utf-8"?>
+<p:sld xmlns:a="http://schemas.openxmlformats.org/drawingml/2006/main" xmlns:p="http://schemas.openxmlformats.org/presentationml/2006/main" xmlns:r="http://schemas.openxmlformats.org/officeDocument/2006/relationships">
+  <p:cSld>
+    <p:bg>
+      <p:bgPr>
+        <a:solidFill>
+          <a:srgbClr val="FCFCFB"/>
+        </a:solidFill>
+        <a:effectLst/>
+      </p:bgPr>
+    </p:bg>
+    <p:spTree>
+      <p:nvGrpSpPr>
+        <p:cNvPr id="1" name=""/>
+        <p:cNvGrpSpPr/>
+        <p:nvPr/>
+      </p:nvGrpSpPr>
+      <p:grpSpPr/>
+      <p:sp>
+        <p:nvSpPr>
+          <p:cNvPr id="2" name="TextBox 1"/>
+          <p:cNvSpPr txBox="1"/>
+          <p:nvPr/>
+        </p:nvSpPr>
+        <p:spPr>
+          <a:xfrm>
+            <a:off x="658368" y="420624"/>
+            <a:ext cx="10881360" cy="274320"/>
+          </a:xfrm>
+          <a:prstGeom prst="rect">
+            <a:avLst/>
+          </a:prstGeom>
+          <a:noFill/>
+        </p:spPr>
+        <p:txBody>
+          <a:bodyPr wrap="square" lIns="0" rIns="0" tIns="0" bIns="0">
+            <a:spAutoFit/>
+          </a:bodyPr>
+          <a:lstStyle/>
+          <a:p>
+            <a:pPr algn="l">
+              <a:lnSpc>
+                <a:spcPct val="125000"/>
+              </a:lnSpc>
+              <a:spcAft>
+                <a:spcPts val="600"/>
+              </a:spcAft>
+            </a:pPr>
+            <a:r>
+              <a:rPr sz="1050" b="1">
+                <a:solidFill>
+                  <a:srgbClr val="2A78D6"/>
+                </a:solidFill>
+                <a:latin typeface="Arial"/>
+              </a:rPr>
+              <a:t>18 · RESULTS — IS THE SABOTAGE AIMED?</a:t>
+            </a:r>
+          </a:p>
+        </p:txBody>
+      </p:sp>
+      <p:sp>
+        <p:nvSpPr>
+          <p:cNvPr id="3" name="TextBox 2"/>
+          <p:cNvSpPr txBox="1"/>
+          <p:nvPr/>
+        </p:nvSpPr>
+        <p:spPr>
+          <a:xfrm>
+            <a:off x="658368" y="749808"/>
+            <a:ext cx="10881360" cy="822960"/>
+          </a:xfrm>
+          <a:prstGeom prst="rect">
+            <a:avLst/>
+          </a:prstGeom>
+          <a:noFill/>
+        </p:spPr>
+        <p:txBody>
+          <a:bodyPr wrap="square" lIns="0" rIns="0" tIns="0" bIns="0">
+            <a:spAutoFit/>
+          </a:bodyPr>
+          <a:lstStyle/>
+          <a:p>
+            <a:pPr algn="l">
+              <a:lnSpc>
+                <a:spcPct val="125000"/>
+              </a:lnSpc>
+              <a:spcAft>
+                <a:spcPts val="600"/>
+              </a:spcAft>
+            </a:pPr>
+            <a:r>
+              <a:rPr sz="2800" b="1">
+                <a:solidFill>
+                  <a:srgbClr val="16181A"/>
+                </a:solidFill>
+                <a:latin typeface="Arial"/>
+              </a:rPr>
+              <a:t>A conditional result, reported as such</a:t>
+            </a:r>
+          </a:p>
+        </p:txBody>
+      </p:sp>
+      <p:sp>
+        <p:nvSpPr>
+          <p:cNvPr id="4" name="Rectangle 3"/>
+          <p:cNvSpPr/>
+          <p:nvPr/>
+        </p:nvSpPr>
+        <p:spPr>
+          <a:xfrm>
+            <a:off x="658368" y="1481328"/>
+            <a:ext cx="10881360" cy="18288"/>
+          </a:xfrm>
+          <a:prstGeom prst="rect">
+            <a:avLst/>
+          </a:prstGeom>
+          <a:solidFill>
+            <a:srgbClr val="D8DCE0"/>
+          </a:solidFill>
+          <a:ln>
+            <a:noFill/>
+          </a:ln>
+          <a:effectLst/>
+        </p:spPr>
+        <p:style>
+          <a:lnRef idx="1">
+            <a:schemeClr val="accent1"/>
+          </a:lnRef>
+          <a:fillRef idx="3">
+            <a:schemeClr val="accent1"/>
+          </a:fillRef>
+          <a:effectRef idx="2">
+            <a:schemeClr val="accent1"/>
+          </a:effectRef>
+          <a:fontRef idx="minor">
+            <a:schemeClr val="lt1"/>
+          </a:fontRef>
+        </p:style>
+        <p:txBody>
+          <a:bodyPr rtlCol="0" anchor="ctr"/>
+          <a:lstStyle/>
+          <a:p>
+            <a:pPr algn="ctr"/>
+          </a:p>
+        </p:txBody>
+      </p:sp>
+      <p:sp>
+        <p:nvSpPr>
+          <p:cNvPr id="5" name="TextBox 4"/>
+          <p:cNvSpPr txBox="1"/>
+          <p:nvPr/>
+        </p:nvSpPr>
+        <p:spPr>
+          <a:xfrm>
+            <a:off x="658368" y="1783080"/>
+            <a:ext cx="10881360" cy="548640"/>
+          </a:xfrm>
+          <a:prstGeom prst="rect">
+            <a:avLst/>
+          </a:prstGeom>
+          <a:noFill/>
+        </p:spPr>
+        <p:txBody>
+          <a:bodyPr wrap="square" lIns="0" rIns="0" tIns="0" bIns="0">
+            <a:spAutoFit/>
+          </a:bodyPr>
+          <a:lstStyle/>
+          <a:p>
+            <a:pPr algn="l">
+              <a:lnSpc>
+                <a:spcPct val="130000"/>
+              </a:lnSpc>
+              <a:spcAft>
+                <a:spcPts val="600"/>
+              </a:spcAft>
+            </a:pPr>
+            <a:r>
+              <a:rPr sz="1400" b="0">
+                <a:solidFill>
+                  <a:srgbClr val="6B7178"/>
+                </a:solidFill>
+                <a:latin typeface="Arial"/>
+              </a:rPr>
+              <a:t>A poisoned codebook only costs the player if they return to it, and costs more the sooner they do. Lower is better-aimed. Control: poison a recorded room at random.</a:t>
+            </a:r>
+          </a:p>
+        </p:txBody>
+      </p:sp>
+      <p:graphicFrame>
+        <p:nvGraphicFramePr>
+          <p:cNvPr id="6" name="Table 5"/>
+          <p:cNvGraphicFramePr>
+            <a:graphicFrameLocks noGrp="1"/>
+          </p:cNvGraphicFramePr>
+          <p:nvPr/>
+        </p:nvGraphicFramePr>
+        <p:xfrm>
+          <a:off x="658368" y="2606040"/>
+          <a:ext cx="10881360" cy="1152144"/>
+        </p:xfrm>
+        <a:graphic>
+          <a:graphicData uri="http://schemas.openxmlformats.org/drawingml/2006/table">
+            <a:tbl>
+              <a:tblPr firstRow="1" bandRow="1">
+                <a:tableStyleId>{5C22544A-7EE6-4342-B048-85BDC9FD1C3A}</a:tableStyleId>
+              </a:tblPr>
+              <a:tblGrid>
+                <a:gridCol w="4572000"/>
+                <a:gridCol w="2194560"/>
+                <a:gridCol w="2103120"/>
+                <a:gridCol w="2011680"/>
+              </a:tblGrid>
+              <a:tr h="384048">
+                <a:tc>
+                  <a:txBody>
+                    <a:bodyPr/>
+                    <a:lstStyle/>
+                    <a:p>
+                      <a:pPr>
+                        <a:lnSpc>
+                          <a:spcPct val="115000"/>
+                        </a:lnSpc>
+                      </a:pPr>
+                      <a:r>
+                        <a:rPr sz="950" b="1">
+                          <a:solidFill>
+                            <a:srgbClr val="6B7178"/>
+                          </a:solidFill>
+                          <a:latin typeface="Arial"/>
+                        </a:rPr>
+                        <a:t>Player's reliance on rooms</a:t>
+                      </a:r>
+                    </a:p>
+                  </a:txBody>
+                  <a:tcPr marL="73152" marR="73152" marT="36576" marB="36576">
+                    <a:solidFill>
+                      <a:srgbClr val="F4F6F8"/>
+                    </a:solidFill>
+                  </a:tcPr>
+                </a:tc>
+                <a:tc>
+                  <a:txBody>
+                    <a:bodyPr/>
+                    <a:lstStyle/>
+                    <a:p>
+                      <a:pPr>
+                        <a:lnSpc>
+                          <a:spcPct val="115000"/>
+                        </a:lnSpc>
+                      </a:pPr>
+                      <a:r>
+                        <a:rPr sz="950" b="1">
+                          <a:solidFill>
+                            <a:srgbClr val="6B7178"/>
+                          </a:solidFill>
+                          <a:latin typeface="Arial"/>
+                        </a:rPr>
+                        <a:t>Random targeting</a:t>
+                      </a:r>
+                    </a:p>
+                  </a:txBody>
+                  <a:tcPr marL="73152" marR="73152" marT="36576" marB="36576">
+                    <a:solidFill>
+                      <a:srgbClr val="F4F6F8"/>
+                    </a:solidFill>
+                  </a:tcPr>
+                </a:tc>
+                <a:tc>
+                  <a:txBody>
+                    <a:bodyPr/>
+                    <a:lstStyle/>
+                    <a:p>
+                      <a:pPr>
+                        <a:lnSpc>
+                          <a:spcPct val="115000"/>
+                        </a:lnSpc>
+                      </a:pPr>
+                      <a:r>
+                        <a:rPr sz="950" b="1">
+                          <a:solidFill>
+                            <a:srgbClr val="6B7178"/>
+                          </a:solidFill>
+                          <a:latin typeface="Arial"/>
+                        </a:rPr>
+                        <a:t>Model targeting</a:t>
+                      </a:r>
+                    </a:p>
+                  </a:txBody>
+                  <a:tcPr marL="73152" marR="73152" marT="36576" marB="36576">
+                    <a:solidFill>
+                      <a:srgbClr val="F4F6F8"/>
+                    </a:solidFill>
+                  </a:tcPr>
+                </a:tc>
+                <a:tc>
+                  <a:txBody>
+                    <a:bodyPr/>
+                    <a:lstStyle/>
+                    <a:p>
+                      <a:pPr>
+                        <a:lnSpc>
+                          <a:spcPct val="115000"/>
+                        </a:lnSpc>
+                      </a:pPr>
+                      <a:r>
+                        <a:rPr sz="950" b="1">
+                          <a:solidFill>
+                            <a:srgbClr val="6B7178"/>
+                          </a:solidFill>
+                          <a:latin typeface="Arial"/>
+                        </a:rPr>
+                        <a:t>Advantage</a:t>
+                      </a:r>
+                    </a:p>
+                  </a:txBody>
+                  <a:tcPr marL="73152" marR="73152" marT="36576" marB="36576">
+                    <a:solidFill>
+                      <a:srgbClr val="F4F6F8"/>
+                    </a:solidFill>
+                  </a:tcPr>
+                </a:tc>
+              </a:tr>
+              <a:tr h="384048">
+                <a:tc>
+                  <a:txBody>
+                    <a:bodyPr/>
+                    <a:lstStyle/>
+                    <a:p>
+                      <a:pPr>
+                        <a:lnSpc>
+                          <a:spcPct val="115000"/>
+                        </a:lnSpc>
+                      </a:pPr>
+                      <a:r>
+                        <a:rPr sz="1300" b="0">
+                          <a:solidFill>
+                            <a:srgbClr val="16181A"/>
+                          </a:solidFill>
+                          <a:latin typeface="Arial"/>
+                        </a:rPr>
+                        <a:t>Uniform — visits every codebook each lap</a:t>
+                      </a:r>
+                    </a:p>
+                  </a:txBody>
+                  <a:tcPr marL="73152" marR="73152" marT="36576" marB="36576">
+                    <a:solidFill>
+                      <a:srgbClr val="FCFCFB"/>
+                    </a:solidFill>
+                  </a:tcPr>
+                </a:tc>
+                <a:tc>
+                  <a:txBody>
+                    <a:bodyPr/>
+                    <a:lstStyle/>
+                    <a:p>
+                      <a:pPr>
+                        <a:lnSpc>
+                          <a:spcPct val="115000"/>
+                        </a:lnSpc>
+                      </a:pPr>
+                      <a:r>
+                        <a:rPr sz="1300" b="0">
+                          <a:solidFill>
+                            <a:srgbClr val="16181A"/>
+                          </a:solidFill>
+                          <a:latin typeface="Arial"/>
+                        </a:rPr>
+                        <a:t>6.8</a:t>
+                      </a:r>
+                    </a:p>
+                  </a:txBody>
+                  <a:tcPr marL="73152" marR="73152" marT="36576" marB="36576">
+                    <a:solidFill>
+                      <a:srgbClr val="FCFCFB"/>
+                    </a:solidFill>
+                  </a:tcPr>
+                </a:tc>
+                <a:tc>
+                  <a:txBody>
+                    <a:bodyPr/>
+                    <a:lstStyle/>
+                    <a:p>
+                      <a:pPr>
+                        <a:lnSpc>
+                          <a:spcPct val="115000"/>
+                        </a:lnSpc>
+                      </a:pPr>
+                      <a:r>
+                        <a:rPr sz="1300" b="0">
+                          <a:solidFill>
+                            <a:srgbClr val="16181A"/>
+                          </a:solidFill>
+                          <a:latin typeface="Arial"/>
+                        </a:rPr>
+                        <a:t>6.8</a:t>
+                      </a:r>
+                    </a:p>
+                  </a:txBody>
+                  <a:tcPr marL="73152" marR="73152" marT="36576" marB="36576">
+                    <a:solidFill>
+                      <a:srgbClr val="FCFCFB"/>
+                    </a:solidFill>
+                  </a:tcPr>
+                </a:tc>
+                <a:tc>
+                  <a:txBody>
+                    <a:bodyPr/>
+                    <a:lstStyle/>
+                    <a:p>
+                      <a:pPr>
+                        <a:lnSpc>
+                          <a:spcPct val="115000"/>
+                        </a:lnSpc>
+                      </a:pPr>
+                      <a:r>
+                        <a:rPr sz="1300" b="0">
+                          <a:solidFill>
+                            <a:srgbClr val="16181A"/>
+                          </a:solidFill>
+                          <a:latin typeface="Arial"/>
+                        </a:rPr>
+                        <a:t>none (-0.5%)</a:t>
+                      </a:r>
+                    </a:p>
+                  </a:txBody>
+                  <a:tcPr marL="73152" marR="73152" marT="36576" marB="36576">
+                    <a:solidFill>
+                      <a:srgbClr val="FCFCFB"/>
+                    </a:solidFill>
+                  </a:tcPr>
+                </a:tc>
+              </a:tr>
+              <a:tr h="384048">
+                <a:tc>
+                  <a:txBody>
+                    <a:bodyPr/>
+                    <a:lstStyle/>
+                    <a:p>
+                      <a:pPr>
+                        <a:lnSpc>
+                          <a:spcPct val="115000"/>
+                        </a:lnSpc>
+                      </a:pPr>
+                      <a:r>
+                        <a:rPr sz="1300" b="0">
+                          <a:solidFill>
+                            <a:srgbClr val="16181A"/>
+                          </a:solidFill>
+                          <a:latin typeface="Arial"/>
+                        </a:rPr>
+                        <a:t>Uneven — leans on some rooms harder</a:t>
+                      </a:r>
+                    </a:p>
+                  </a:txBody>
+                  <a:tcPr marL="73152" marR="73152" marT="36576" marB="36576">
+                    <a:solidFill>
+                      <a:srgbClr val="FCFCFB"/>
+                    </a:solidFill>
+                  </a:tcPr>
+                </a:tc>
+                <a:tc>
+                  <a:txBody>
+                    <a:bodyPr/>
+                    <a:lstStyle/>
+                    <a:p>
+                      <a:pPr>
+                        <a:lnSpc>
+                          <a:spcPct val="115000"/>
+                        </a:lnSpc>
+                      </a:pPr>
+                      <a:r>
+                        <a:rPr sz="1300" b="0">
+                          <a:solidFill>
+                            <a:srgbClr val="16181A"/>
+                          </a:solidFill>
+                          <a:latin typeface="Arial"/>
+                        </a:rPr>
+                        <a:t>8.8</a:t>
+                      </a:r>
+                    </a:p>
+                  </a:txBody>
+                  <a:tcPr marL="73152" marR="73152" marT="36576" marB="36576">
+                    <a:solidFill>
+                      <a:srgbClr val="FCFCFB"/>
+                    </a:solidFill>
+                  </a:tcPr>
+                </a:tc>
+                <a:tc>
+                  <a:txBody>
+                    <a:bodyPr/>
+                    <a:lstStyle/>
+                    <a:p>
+                      <a:pPr>
+                        <a:lnSpc>
+                          <a:spcPct val="115000"/>
+                        </a:lnSpc>
+                      </a:pPr>
+                      <a:r>
+                        <a:rPr sz="1300" b="0">
+                          <a:solidFill>
+                            <a:srgbClr val="16181A"/>
+                          </a:solidFill>
+                          <a:latin typeface="Arial"/>
+                        </a:rPr>
+                        <a:t>7.8</a:t>
+                      </a:r>
+                    </a:p>
+                  </a:txBody>
+                  <a:tcPr marL="73152" marR="73152" marT="36576" marB="36576">
+                    <a:solidFill>
+                      <a:srgbClr val="FCFCFB"/>
+                    </a:solidFill>
+                  </a:tcPr>
+                </a:tc>
+                <a:tc>
+                  <a:txBody>
+                    <a:bodyPr/>
+                    <a:lstStyle/>
+                    <a:p>
+                      <a:pPr>
+                        <a:lnSpc>
+                          <a:spcPct val="115000"/>
+                        </a:lnSpc>
+                      </a:pPr>
+                      <a:r>
+                        <a:rPr sz="1300" b="0">
+                          <a:solidFill>
+                            <a:srgbClr val="16181A"/>
+                          </a:solidFill>
+                          <a:latin typeface="Arial"/>
+                        </a:rPr>
+                        <a:t>12% faster</a:t>
+                      </a:r>
+                    </a:p>
+                  </a:txBody>
+                  <a:tcPr marL="73152" marR="73152" marT="36576" marB="36576">
+                    <a:solidFill>
+                      <a:srgbClr val="FCFCFB"/>
+                    </a:solidFill>
+                  </a:tcPr>
+                </a:tc>
+              </a:tr>
+            </a:tbl>
+          </a:graphicData>
+        </a:graphic>
+      </p:graphicFrame>
+      <p:sp>
+        <p:nvSpPr>
+          <p:cNvPr id="7" name="Rectangle 6"/>
+          <p:cNvSpPr/>
+          <p:nvPr/>
+        </p:nvSpPr>
+        <p:spPr>
+          <a:xfrm>
+            <a:off x="658368" y="3931920"/>
+            <a:ext cx="10881360" cy="1600200"/>
+          </a:xfrm>
+          <a:prstGeom prst="rect">
+            <a:avLst/>
+          </a:prstGeom>
+          <a:solidFill>
+            <a:srgbClr val="FFF6F0"/>
+          </a:solidFill>
+          <a:ln w="12700">
+            <a:solidFill>
+              <a:srgbClr val="EB6834"/>
+            </a:solidFill>
+          </a:ln>
+          <a:effectLst/>
+        </p:spPr>
+        <p:style>
+          <a:lnRef idx="1">
+            <a:schemeClr val="accent1"/>
+          </a:lnRef>
+          <a:fillRef idx="3">
+            <a:schemeClr val="accent1"/>
+          </a:fillRef>
+          <a:effectRef idx="2">
+            <a:schemeClr val="accent1"/>
+          </a:effectRef>
+          <a:fontRef idx="minor">
+            <a:schemeClr val="lt1"/>
+          </a:fontRef>
+        </p:style>
+        <p:txBody>
+          <a:bodyPr rtlCol="0" anchor="ctr"/>
+          <a:lstStyle/>
+          <a:p>
+            <a:pPr algn="ctr"/>
+          </a:p>
+        </p:txBody>
+      </p:sp>
+      <p:sp>
+        <p:nvSpPr>
+          <p:cNvPr id="8" name="TextBox 7"/>
+          <p:cNvSpPr txBox="1"/>
+          <p:nvPr/>
+        </p:nvSpPr>
+        <p:spPr>
+          <a:xfrm>
+            <a:off x="960120" y="4160520"/>
+            <a:ext cx="10332720" cy="1234440"/>
+          </a:xfrm>
+          <a:prstGeom prst="rect">
+            <a:avLst/>
+          </a:prstGeom>
+          <a:noFill/>
+        </p:spPr>
+        <p:txBody>
+          <a:bodyPr wrap="square" lIns="0" rIns="0" tIns="0" bIns="0">
+            <a:spAutoFit/>
+          </a:bodyPr>
+          <a:lstStyle/>
+          <a:p>
+            <a:pPr algn="l">
+              <a:lnSpc>
+                <a:spcPct val="132000"/>
+              </a:lnSpc>
+              <a:spcAft>
+                <a:spcPts val="400"/>
+              </a:spcAft>
+            </a:pPr>
+            <a:r>
+              <a:rPr sz="1350" b="0">
+                <a:solidFill>
+                  <a:srgbClr val="16181A"/>
+                </a:solidFill>
+                <a:latin typeface="Arial"/>
+              </a:rPr>
+              <a:t>Reported as a negative result under the first condition.</a:t>
+            </a:r>
+          </a:p>
+          <a:p>
+            <a:pPr algn="l">
+              <a:lnSpc>
+                <a:spcPct val="132000"/>
+              </a:lnSpc>
+              <a:spcAft>
+                <a:spcPts val="400"/>
+              </a:spcAft>
+            </a:pPr>
+            <a:r>
+              <a:rPr sz="1350" b="0">
+                <a:solidFill>
+                  <a:srgbClr val="16181A"/>
+                </a:solidFill>
+                <a:latin typeface="Arial"/>
+              </a:rPr>
+              <a:t>When the player relies on every room equally there is nothing for targeted sabotage to exploit, and model targeting performs no better than random. The counter-move earns its place only against a player with uneven habits. That is the realistic case — but the claim is conditional and is not overstated.</a:t>
+            </a:r>
+          </a:p>
+        </p:txBody>
+      </p:sp>
+    </p:spTree>
+  </p:cSld>
+  <p:clrMapOvr>
+    <a:masterClrMapping/>
+  </p:clrMapOvr>
+</p:sld>
+</file>
+
+<file path=ppt/slides/slide21.xml><?xml version="1.0" encoding="utf-8"?>
+<p:sld xmlns:a="http://schemas.openxmlformats.org/drawingml/2006/main" xmlns:p="http://schemas.openxmlformats.org/presentationml/2006/main" xmlns:r="http://schemas.openxmlformats.org/officeDocument/2006/relationships">
+  <p:cSld>
+    <p:bg>
+      <p:bgPr>
+        <a:solidFill>
+          <a:srgbClr val="FCFCFB"/>
+        </a:solidFill>
+        <a:effectLst/>
+      </p:bgPr>
+    </p:bg>
+    <p:spTree>
+      <p:nvGrpSpPr>
+        <p:cNvPr id="1" name=""/>
+        <p:cNvGrpSpPr/>
+        <p:nvPr/>
+      </p:nvGrpSpPr>
+      <p:grpSpPr/>
+      <p:sp>
+        <p:nvSpPr>
+          <p:cNvPr id="2" name="TextBox 1"/>
+          <p:cNvSpPr txBox="1"/>
+          <p:nvPr/>
+        </p:nvSpPr>
+        <p:spPr>
+          <a:xfrm>
+            <a:off x="658368" y="420624"/>
+            <a:ext cx="10881360" cy="274320"/>
+          </a:xfrm>
+          <a:prstGeom prst="rect">
+            <a:avLst/>
+          </a:prstGeom>
+          <a:noFill/>
+        </p:spPr>
+        <p:txBody>
+          <a:bodyPr wrap="square" lIns="0" rIns="0" tIns="0" bIns="0">
+            <a:spAutoFit/>
+          </a:bodyPr>
+          <a:lstStyle/>
+          <a:p>
+            <a:pPr algn="l">
+              <a:lnSpc>
+                <a:spcPct val="125000"/>
+              </a:lnSpc>
+              <a:spcAft>
+                <a:spcPts val="600"/>
+              </a:spcAft>
+            </a:pPr>
+            <a:r>
+              <a:rPr sz="1050" b="1">
+                <a:solidFill>
+                  <a:srgbClr val="2A78D6"/>
+                </a:solidFill>
+                <a:latin typeface="Arial"/>
+              </a:rPr>
+              <a:t>19 · VERIFICATION</a:t>
+            </a:r>
+          </a:p>
+        </p:txBody>
+      </p:sp>
+      <p:sp>
+        <p:nvSpPr>
+          <p:cNvPr id="3" name="TextBox 2"/>
+          <p:cNvSpPr txBox="1"/>
+          <p:nvPr/>
+        </p:nvSpPr>
+        <p:spPr>
+          <a:xfrm>
+            <a:off x="658368" y="749808"/>
+            <a:ext cx="10881360" cy="822960"/>
+          </a:xfrm>
+          <a:prstGeom prst="rect">
+            <a:avLst/>
+          </a:prstGeom>
+          <a:noFill/>
+        </p:spPr>
+        <p:txBody>
+          <a:bodyPr wrap="square" lIns="0" rIns="0" tIns="0" bIns="0">
+            <a:spAutoFit/>
+          </a:bodyPr>
+          <a:lstStyle/>
+          <a:p>
+            <a:pPr algn="l">
+              <a:lnSpc>
+                <a:spcPct val="125000"/>
+              </a:lnSpc>
+              <a:spcAft>
+                <a:spcPts val="600"/>
+              </a:spcAft>
+            </a:pPr>
+            <a:r>
+              <a:rPr sz="2800" b="1">
+                <a:solidFill>
+                  <a:srgbClr val="16181A"/>
+                </a:solidFill>
+                <a:latin typeface="Arial"/>
+              </a:rPr>
+              <a:t>Nine invariants, asserted over 25 generated facilities</a:t>
+            </a:r>
+          </a:p>
+        </p:txBody>
+      </p:sp>
+      <p:sp>
+        <p:nvSpPr>
+          <p:cNvPr id="4" name="Rectangle 3"/>
+          <p:cNvSpPr/>
+          <p:nvPr/>
+        </p:nvSpPr>
+        <p:spPr>
+          <a:xfrm>
+            <a:off x="658368" y="1481328"/>
+            <a:ext cx="10881360" cy="18288"/>
+          </a:xfrm>
+          <a:prstGeom prst="rect">
+            <a:avLst/>
+          </a:prstGeom>
+          <a:solidFill>
+            <a:srgbClr val="D8DCE0"/>
+          </a:solidFill>
+          <a:ln>
+            <a:noFill/>
+          </a:ln>
+          <a:effectLst/>
+        </p:spPr>
+        <p:style>
+          <a:lnRef idx="1">
+            <a:schemeClr val="accent1"/>
+          </a:lnRef>
+          <a:fillRef idx="3">
+            <a:schemeClr val="accent1"/>
+          </a:fillRef>
+          <a:effectRef idx="2">
+            <a:schemeClr val="accent1"/>
+          </a:effectRef>
+          <a:fontRef idx="minor">
+            <a:schemeClr val="lt1"/>
+          </a:fontRef>
+        </p:style>
+        <p:txBody>
+          <a:bodyPr rtlCol="0" anchor="ctr"/>
+          <a:lstStyle/>
+          <a:p>
+            <a:pPr algn="ctr"/>
+          </a:p>
+        </p:txBody>
+      </p:sp>
+      <p:graphicFrame>
+        <p:nvGraphicFramePr>
+          <p:cNvPr id="5" name="Table 4"/>
+          <p:cNvGraphicFramePr>
+            <a:graphicFrameLocks noGrp="1"/>
+          </p:cNvGraphicFramePr>
+          <p:nvPr/>
+        </p:nvGraphicFramePr>
+        <p:xfrm>
+          <a:off x="658368" y="1783080"/>
+          <a:ext cx="10881360" cy="3840480"/>
+        </p:xfrm>
+        <a:graphic>
+          <a:graphicData uri="http://schemas.openxmlformats.org/drawingml/2006/table">
+            <a:tbl>
+              <a:tblPr firstRow="1" bandRow="1">
+                <a:tableStyleId>{5C22544A-7EE6-4342-B048-85BDC9FD1C3A}</a:tableStyleId>
+              </a:tblPr>
+              <a:tblGrid>
+                <a:gridCol w="5852160"/>
+                <a:gridCol w="5029200"/>
+              </a:tblGrid>
+              <a:tr h="384048">
+                <a:tc>
+                  <a:txBody>
+                    <a:bodyPr/>
+                    <a:lstStyle/>
+                    <a:p>
+                      <a:pPr>
+                        <a:lnSpc>
+                          <a:spcPct val="115000"/>
+                        </a:lnSpc>
+                      </a:pPr>
+                      <a:r>
+                        <a:rPr sz="900" b="1">
+                          <a:solidFill>
+                            <a:srgbClr val="6B7178"/>
+                          </a:solidFill>
+                          <a:latin typeface="Arial"/>
+                        </a:rPr>
+                        <a:t>Invariant</a:t>
+                      </a:r>
+                    </a:p>
+                  </a:txBody>
+                  <a:tcPr marL="73152" marR="73152" marT="36576" marB="36576">
+                    <a:solidFill>
+                      <a:srgbClr val="F4F6F8"/>
+                    </a:solidFill>
+                  </a:tcPr>
+                </a:tc>
+                <a:tc>
+                  <a:txBody>
+                    <a:bodyPr/>
+                    <a:lstStyle/>
+                    <a:p>
+                      <a:pPr>
+                        <a:lnSpc>
+                          <a:spcPct val="115000"/>
+                        </a:lnSpc>
+                      </a:pPr>
+                      <a:r>
+                        <a:rPr sz="900" b="1">
+                          <a:solidFill>
+                            <a:srgbClr val="6B7178"/>
+                          </a:solidFill>
+                          <a:latin typeface="Arial"/>
+                        </a:rPr>
+                        <a:t>Guards against</a:t>
+                      </a:r>
+                    </a:p>
+                  </a:txBody>
+                  <a:tcPr marL="73152" marR="73152" marT="36576" marB="36576">
+                    <a:solidFill>
+                      <a:srgbClr val="F4F6F8"/>
+                    </a:solidFill>
+                  </a:tcPr>
+                </a:tc>
+              </a:tr>
+              <a:tr h="384048">
+                <a:tc>
+                  <a:txBody>
+                    <a:bodyPr/>
+                    <a:lstStyle/>
+                    <a:p>
+                      <a:pPr>
+                        <a:lnSpc>
+                          <a:spcPct val="115000"/>
+                        </a:lnSpc>
+                      </a:pPr>
+                      <a:r>
+                        <a:rPr sz="1250" b="0">
+                          <a:solidFill>
+                            <a:srgbClr val="16181A"/>
+                          </a:solidFill>
+                          <a:latin typeface="Arial"/>
+                        </a:rPr>
+                        <a:t>Facility connected on construction</a:t>
+                      </a:r>
+                    </a:p>
+                  </a:txBody>
+                  <a:tcPr marL="73152" marR="73152" marT="36576" marB="36576">
+                    <a:solidFill>
+                      <a:srgbClr val="FCFCFB"/>
+                    </a:solidFill>
+                  </a:tcPr>
+                </a:tc>
+                <a:tc>
+                  <a:txBody>
+                    <a:bodyPr/>
+                    <a:lstStyle/>
+                    <a:p>
+                      <a:pPr>
+                        <a:lnSpc>
+                          <a:spcPct val="115000"/>
+                        </a:lnSpc>
+                      </a:pPr>
+                      <a:r>
+                        <a:rPr sz="1250" b="0">
+                          <a:solidFill>
+                            <a:srgbClr val="16181A"/>
+                          </a:solidFill>
+                          <a:latin typeface="Arial"/>
+                        </a:rPr>
+                        <a:t>Unplayable generated levels</a:t>
+                      </a:r>
+                    </a:p>
+                  </a:txBody>
+                  <a:tcPr marL="73152" marR="73152" marT="36576" marB="36576">
+                    <a:solidFill>
+                      <a:srgbClr val="FCFCFB"/>
+                    </a:solidFill>
+                  </a:tcPr>
+                </a:tc>
+              </a:tr>
+              <a:tr h="384048">
+                <a:tc>
+                  <a:txBody>
+                    <a:bodyPr/>
+                    <a:lstStyle/>
+                    <a:p>
+                      <a:pPr>
+                        <a:lnSpc>
+                          <a:spcPct val="115000"/>
+                        </a:lnSpc>
+                      </a:pPr>
+                      <a:r>
+                        <a:rPr sz="1250" b="0">
+                          <a:solidFill>
+                            <a:srgbClr val="16181A"/>
+                          </a:solidFill>
+                          <a:latin typeface="Arial"/>
+                        </a:rPr>
+                        <a:t>seal_door never disconnects</a:t>
+                      </a:r>
+                    </a:p>
+                  </a:txBody>
+                  <a:tcPr marL="73152" marR="73152" marT="36576" marB="36576">
+                    <a:solidFill>
+                      <a:srgbClr val="FCFCFB"/>
+                    </a:solidFill>
+                  </a:tcPr>
+                </a:tc>
+                <a:tc>
+                  <a:txBody>
+                    <a:bodyPr/>
+                    <a:lstStyle/>
+                    <a:p>
+                      <a:pPr>
+                        <a:lnSpc>
+                          <a:spcPct val="115000"/>
+                        </a:lnSpc>
+                      </a:pPr>
+                      <a:r>
+                        <a:rPr sz="1250" b="0">
+                          <a:solidFill>
+                            <a:srgbClr val="16181A"/>
+                          </a:solidFill>
+                          <a:latin typeface="Arial"/>
+                        </a:rPr>
+                        <a:t>The Director cutting the map in half</a:t>
+                      </a:r>
+                    </a:p>
+                  </a:txBody>
+                  <a:tcPr marL="73152" marR="73152" marT="36576" marB="36576">
+                    <a:solidFill>
+                      <a:srgbClr val="FCFCFB"/>
+                    </a:solidFill>
+                  </a:tcPr>
+                </a:tc>
+              </a:tr>
+              <a:tr h="384048">
+                <a:tc>
+                  <a:txBody>
+                    <a:bodyPr/>
+                    <a:lstStyle/>
+                    <a:p>
+                      <a:pPr>
+                        <a:lnSpc>
+                          <a:spcPct val="115000"/>
+                        </a:lnSpc>
+                      </a:pPr>
+                      <a:r>
+                        <a:rPr sz="1250" b="0">
+                          <a:solidFill>
+                            <a:srgbClr val="16181A"/>
+                          </a:solidFill>
+                          <a:latin typeface="Arial"/>
+                        </a:rPr>
+                        <a:t>rewire never disconnects</a:t>
+                      </a:r>
+                    </a:p>
+                  </a:txBody>
+                  <a:tcPr marL="73152" marR="73152" marT="36576" marB="36576">
+                    <a:solidFill>
+                      <a:srgbClr val="FCFCFB"/>
+                    </a:solidFill>
+                  </a:tcPr>
+                </a:tc>
+                <a:tc>
+                  <a:txBody>
+                    <a:bodyPr/>
+                    <a:lstStyle/>
+                    <a:p>
+                      <a:pPr>
+                        <a:lnSpc>
+                          <a:spcPct val="115000"/>
+                        </a:lnSpc>
+                      </a:pPr>
+                      <a:r>
+                        <a:rPr sz="1250" b="0">
+                          <a:solidFill>
+                            <a:srgbClr val="16181A"/>
+                          </a:solidFill>
+                          <a:latin typeface="Arial"/>
+                        </a:rPr>
+                        <a:t>The same, via door relocation</a:t>
+                      </a:r>
+                    </a:p>
+                  </a:txBody>
+                  <a:tcPr marL="73152" marR="73152" marT="36576" marB="36576">
+                    <a:solidFill>
+                      <a:srgbClr val="FCFCFB"/>
+                    </a:solidFill>
+                  </a:tcPr>
+                </a:tc>
+              </a:tr>
+              <a:tr h="384048">
+                <a:tc>
+                  <a:txBody>
+                    <a:bodyPr/>
+                    <a:lstStyle/>
+                    <a:p>
+                      <a:pPr>
+                        <a:lnSpc>
+                          <a:spcPct val="115000"/>
+                        </a:lnSpc>
+                      </a:pPr>
+                      <a:r>
+                        <a:rPr sz="1250" b="0">
+                          <a:solidFill>
+                            <a:srgbClr val="16181A"/>
+                          </a:solidFill>
+                          <a:latin typeface="Arial"/>
+                        </a:rPr>
+                        <a:t>Uplink reachable from every room after mutation</a:t>
+                      </a:r>
+                    </a:p>
+                  </a:txBody>
+                  <a:tcPr marL="73152" marR="73152" marT="36576" marB="36576">
+                    <a:solidFill>
+                      <a:srgbClr val="FCFCFB"/>
+                    </a:solidFill>
+                  </a:tcPr>
+                </a:tc>
+                <a:tc>
+                  <a:txBody>
+                    <a:bodyPr/>
+                    <a:lstStyle/>
+                    <a:p>
+                      <a:pPr>
+                        <a:lnSpc>
+                          <a:spcPct val="115000"/>
+                        </a:lnSpc>
+                      </a:pPr>
+                      <a:r>
+                        <a:rPr sz="1250" b="0">
+                          <a:solidFill>
+                            <a:srgbClr val="16181A"/>
+                          </a:solidFill>
+                          <a:latin typeface="Arial"/>
+                        </a:rPr>
+                        <a:t>Soft-locked, unwinnable runs</a:t>
+                      </a:r>
+                    </a:p>
+                  </a:txBody>
+                  <a:tcPr marL="73152" marR="73152" marT="36576" marB="36576">
+                    <a:solidFill>
+                      <a:srgbClr val="FCFCFB"/>
+                    </a:solidFill>
+                  </a:tcPr>
+                </a:tc>
+              </a:tr>
+              <a:tr h="384048">
+                <a:tc>
+                  <a:txBody>
+                    <a:bodyPr/>
+                    <a:lstStyle/>
+                    <a:p>
+                      <a:pPr>
+                        <a:lnSpc>
+                          <a:spcPct val="115000"/>
+                        </a:lnSpc>
+                      </a:pPr>
+                      <a:r>
+                        <a:rPr sz="1250" b="0">
+                          <a:solidFill>
+                            <a:srgbClr val="16181A"/>
+                          </a:solidFill>
+                          <a:latin typeface="Arial"/>
+                        </a:rPr>
+                        <a:t>Bots only move to adjacent rooms</a:t>
+                      </a:r>
+                    </a:p>
+                  </a:txBody>
+                  <a:tcPr marL="73152" marR="73152" marT="36576" marB="36576">
+                    <a:solidFill>
+                      <a:srgbClr val="FCFCFB"/>
+                    </a:solidFill>
+                  </a:tcPr>
+                </a:tc>
+                <a:tc>
+                  <a:txBody>
+                    <a:bodyPr/>
+                    <a:lstStyle/>
+                    <a:p>
+                      <a:pPr>
+                        <a:lnSpc>
+                          <a:spcPct val="115000"/>
+                        </a:lnSpc>
+                      </a:pPr>
+                      <a:r>
+                        <a:rPr sz="1250" b="0">
+                          <a:solidFill>
+                            <a:srgbClr val="16181A"/>
+                          </a:solidFill>
+                          <a:latin typeface="Arial"/>
+                        </a:rPr>
+                        <a:t>Silent teleportation corrupting telemetry</a:t>
+                      </a:r>
+                    </a:p>
+                  </a:txBody>
+                  <a:tcPr marL="73152" marR="73152" marT="36576" marB="36576">
+                    <a:solidFill>
+                      <a:srgbClr val="FCFCFB"/>
+                    </a:solidFill>
+                  </a:tcPr>
+                </a:tc>
+              </a:tr>
+              <a:tr h="384048">
+                <a:tc>
+                  <a:txBody>
+                    <a:bodyPr/>
+                    <a:lstStyle/>
+                    <a:p>
+                      <a:pPr>
+                        <a:lnSpc>
+                          <a:spcPct val="115000"/>
+                        </a:lnSpc>
+                      </a:pPr>
+                      <a:r>
+                        <a:rPr sz="1250" b="0">
+                          <a:solidFill>
+                            <a:srgbClr val="16181A"/>
+                          </a:solidFill>
+                          <a:latin typeface="Arial"/>
+                        </a:rPr>
+                        <a:t>Predictor output is a proper distribution</a:t>
+                      </a:r>
+                    </a:p>
+                  </a:txBody>
+                  <a:tcPr marL="73152" marR="73152" marT="36576" marB="36576">
+                    <a:solidFill>
+                      <a:srgbClr val="FCFCFB"/>
+                    </a:solidFill>
+                  </a:tcPr>
+                </a:tc>
+                <a:tc>
+                  <a:txBody>
+                    <a:bodyPr/>
+                    <a:lstStyle/>
+                    <a:p>
+                      <a:pPr>
+                        <a:lnSpc>
+                          <a:spcPct val="115000"/>
+                        </a:lnSpc>
+                      </a:pPr>
+                      <a:r>
+                        <a:rPr sz="1250" b="0">
+                          <a:solidFill>
+                            <a:srgbClr val="16181A"/>
+                          </a:solidFill>
+                          <a:latin typeface="Arial"/>
+                        </a:rPr>
+                        <a:t>Malformed probabilities</a:t>
+                      </a:r>
+                    </a:p>
+                  </a:txBody>
+                  <a:tcPr marL="73152" marR="73152" marT="36576" marB="36576">
+                    <a:solidFill>
+                      <a:srgbClr val="FCFCFB"/>
+                    </a:solidFill>
+                  </a:tcPr>
+                </a:tc>
+              </a:tr>
+              <a:tr h="384048">
+                <a:tc>
+                  <a:txBody>
+                    <a:bodyPr/>
+                    <a:lstStyle/>
+                    <a:p>
+                      <a:pPr>
+                        <a:lnSpc>
+                          <a:spcPct val="115000"/>
+                        </a:lnSpc>
+                      </a:pPr>
+                      <a:r>
+                        <a:rPr sz="1250" b="0">
+                          <a:solidFill>
+                            <a:srgbClr val="16181A"/>
+                          </a:solidFill>
+                          <a:latin typeface="Arial"/>
+                        </a:rPr>
+                        <a:t>VOMM approximates uniform on a random player</a:t>
+                      </a:r>
+                    </a:p>
+                  </a:txBody>
+                  <a:tcPr marL="73152" marR="73152" marT="36576" marB="36576">
+                    <a:solidFill>
+                      <a:srgbClr val="FCFCFB"/>
+                    </a:solidFill>
+                  </a:tcPr>
+                </a:tc>
+                <a:tc>
+                  <a:txBody>
+                    <a:bodyPr/>
+                    <a:lstStyle/>
+                    <a:p>
+                      <a:pPr>
+                        <a:lnSpc>
+                          <a:spcPct val="115000"/>
+                        </a:lnSpc>
+                      </a:pPr>
+                      <a:r>
+                        <a:rPr sz="1250" b="0">
+                          <a:solidFill>
+                            <a:srgbClr val="16181A"/>
+                          </a:solidFill>
+                          <a:latin typeface="Arial"/>
+                        </a:rPr>
+                        <a:t>Leakage in the evaluation</a:t>
+                      </a:r>
+                    </a:p>
+                  </a:txBody>
+                  <a:tcPr marL="73152" marR="73152" marT="36576" marB="36576">
+                    <a:solidFill>
+                      <a:srgbClr val="FCFCFB"/>
+                    </a:solidFill>
+                  </a:tcPr>
+                </a:tc>
+              </a:tr>
+              <a:tr h="384048">
+                <a:tc>
+                  <a:txBody>
+                    <a:bodyPr/>
+                    <a:lstStyle/>
+                    <a:p>
+                      <a:pPr>
+                        <a:lnSpc>
+                          <a:spcPct val="115000"/>
+                        </a:lnSpc>
+                      </a:pPr>
+                      <a:r>
+                        <a:rPr sz="1250" b="0">
+                          <a:solidFill>
+                            <a:srgbClr val="16181A"/>
+                          </a:solidFill>
+                          <a:latin typeface="Arial"/>
+                        </a:rPr>
+                        <a:t>Director never mutates a visible room</a:t>
+                      </a:r>
+                    </a:p>
+                  </a:txBody>
+                  <a:tcPr marL="73152" marR="73152" marT="36576" marB="36576">
+                    <a:solidFill>
+                      <a:srgbClr val="FCFCFB"/>
+                    </a:solidFill>
+                  </a:tcPr>
+                </a:tc>
+                <a:tc>
+                  <a:txBody>
+                    <a:bodyPr/>
+                    <a:lstStyle/>
+                    <a:p>
+                      <a:pPr>
+                        <a:lnSpc>
+                          <a:spcPct val="115000"/>
+                        </a:lnSpc>
+                      </a:pPr>
+                      <a:r>
+                        <a:rPr sz="1250" b="0">
+                          <a:solidFill>
+                            <a:srgbClr val="16181A"/>
+                          </a:solidFill>
+                          <a:latin typeface="Arial"/>
+                        </a:rPr>
+                        <a:t>Fairness rule 1</a:t>
+                      </a:r>
+                    </a:p>
+                  </a:txBody>
+                  <a:tcPr marL="73152" marR="73152" marT="36576" marB="36576">
+                    <a:solidFill>
+                      <a:srgbClr val="FCFCFB"/>
+                    </a:solidFill>
+                  </a:tcPr>
+                </a:tc>
+              </a:tr>
+              <a:tr h="384048">
+                <a:tc>
+                  <a:txBody>
+                    <a:bodyPr/>
+                    <a:lstStyle/>
+                    <a:p>
+                      <a:pPr>
+                        <a:lnSpc>
+                          <a:spcPct val="115000"/>
+                        </a:lnSpc>
+                      </a:pPr>
+                      <a:r>
+                        <a:rPr sz="1250" b="0">
+                          <a:solidFill>
+                            <a:srgbClr val="16181A"/>
+                          </a:solidFill>
+                          <a:latin typeface="Arial"/>
+                        </a:rPr>
+                        <a:t>Director never edits below its confidence gate</a:t>
+                      </a:r>
+                    </a:p>
+                  </a:txBody>
+                  <a:tcPr marL="73152" marR="73152" marT="36576" marB="36576">
+                    <a:solidFill>
+                      <a:srgbClr val="FCFCFB"/>
+                    </a:solidFill>
+                  </a:tcPr>
+                </a:tc>
+                <a:tc>
+                  <a:txBody>
+                    <a:bodyPr/>
+                    <a:lstStyle/>
+                    <a:p>
+                      <a:pPr>
+                        <a:lnSpc>
+                          <a:spcPct val="115000"/>
+                        </a:lnSpc>
+                      </a:pPr>
+                      <a:r>
+                        <a:rPr sz="1250" b="0">
+                          <a:solidFill>
+                            <a:srgbClr val="16181A"/>
+                          </a:solidFill>
+                          <a:latin typeface="Arial"/>
+                        </a:rPr>
+                        <a:t>Fairness rule 2</a:t>
+                      </a:r>
+                    </a:p>
+                  </a:txBody>
+                  <a:tcPr marL="73152" marR="73152" marT="36576" marB="36576">
+                    <a:solidFill>
+                      <a:srgbClr val="FCFCFB"/>
+                    </a:solidFill>
+                  </a:tcPr>
+                </a:tc>
+              </a:tr>
+            </a:tbl>
+          </a:graphicData>
+        </a:graphic>
+      </p:graphicFrame>
+      <p:sp>
+        <p:nvSpPr>
+          <p:cNvPr id="6" name="TextBox 5"/>
+          <p:cNvSpPr txBox="1"/>
+          <p:nvPr/>
+        </p:nvSpPr>
+        <p:spPr>
+          <a:xfrm>
+            <a:off x="658368" y="5806440"/>
+            <a:ext cx="10881360" cy="457200"/>
+          </a:xfrm>
+          <a:prstGeom prst="rect">
+            <a:avLst/>
+          </a:prstGeom>
+          <a:noFill/>
+        </p:spPr>
+        <p:txBody>
+          <a:bodyPr wrap="square" lIns="0" rIns="0" tIns="0" bIns="0">
+            <a:spAutoFit/>
+          </a:bodyPr>
+          <a:lstStyle/>
+          <a:p>
+            <a:pPr algn="l">
+              <a:lnSpc>
+                <a:spcPct val="125000"/>
+              </a:lnSpc>
+              <a:spcAft>
+                <a:spcPts val="600"/>
+              </a:spcAft>
+            </a:pPr>
+            <a:r>
+              <a:rPr sz="1400" b="1">
+                <a:solidFill>
+                  <a:srgbClr val="1BAF7A"/>
+                </a:solidFill>
+                <a:latin typeface="Arial"/>
+              </a:rPr>
+              <a:t>9 / 9 passing  ·  python3 model/test_invariants.py</a:t>
+            </a:r>
+          </a:p>
+        </p:txBody>
+      </p:sp>
+    </p:spTree>
+  </p:cSld>
+  <p:clrMapOvr>
+    <a:masterClrMapping/>
+  </p:clrMapOvr>
+</p:sld>
+</file>
+
+<file path=ppt/slides/slide22.xml><?xml version="1.0" encoding="utf-8"?>
+<p:sld xmlns:a="http://schemas.openxmlformats.org/drawingml/2006/main" xmlns:p="http://schemas.openxmlformats.org/presentationml/2006/main" xmlns:r="http://schemas.openxmlformats.org/officeDocument/2006/relationships">
+  <p:cSld>
+    <p:bg>
+      <p:bgPr>
+        <a:solidFill>
+          <a:srgbClr val="FCFCFB"/>
+        </a:solidFill>
+        <a:effectLst/>
+      </p:bgPr>
+    </p:bg>
+    <p:spTree>
+      <p:nvGrpSpPr>
+        <p:cNvPr id="1" name=""/>
+        <p:cNvGrpSpPr/>
+        <p:nvPr/>
+      </p:nvGrpSpPr>
+      <p:grpSpPr/>
+      <p:sp>
+        <p:nvSpPr>
+          <p:cNvPr id="2" name="TextBox 1"/>
+          <p:cNvSpPr txBox="1"/>
+          <p:nvPr/>
+        </p:nvSpPr>
+        <p:spPr>
+          <a:xfrm>
+            <a:off x="658368" y="420624"/>
+            <a:ext cx="10881360" cy="274320"/>
+          </a:xfrm>
+          <a:prstGeom prst="rect">
+            <a:avLst/>
+          </a:prstGeom>
+          <a:noFill/>
+        </p:spPr>
+        <p:txBody>
+          <a:bodyPr wrap="square" lIns="0" rIns="0" tIns="0" bIns="0">
+            <a:spAutoFit/>
+          </a:bodyPr>
+          <a:lstStyle/>
+          <a:p>
+            <a:pPr algn="l">
+              <a:lnSpc>
+                <a:spcPct val="125000"/>
+              </a:lnSpc>
+              <a:spcAft>
+                <a:spcPts val="600"/>
+              </a:spcAft>
+            </a:pPr>
+            <a:r>
+              <a:rPr sz="1050" b="1">
+                <a:solidFill>
+                  <a:srgbClr val="2A78D6"/>
+                </a:solidFill>
+                <a:latin typeface="Arial"/>
+              </a:rPr>
+              <a:t>20 · LIVE DEMONSTRATION</a:t>
+            </a:r>
+          </a:p>
+        </p:txBody>
+      </p:sp>
+      <p:sp>
+        <p:nvSpPr>
+          <p:cNvPr id="3" name="TextBox 2"/>
+          <p:cNvSpPr txBox="1"/>
+          <p:nvPr/>
+        </p:nvSpPr>
+        <p:spPr>
+          <a:xfrm>
+            <a:off x="658368" y="749808"/>
+            <a:ext cx="10881360" cy="822960"/>
+          </a:xfrm>
+          <a:prstGeom prst="rect">
+            <a:avLst/>
+          </a:prstGeom>
+          <a:noFill/>
+        </p:spPr>
+        <p:txBody>
+          <a:bodyPr wrap="square" lIns="0" rIns="0" tIns="0" bIns="0">
+            <a:spAutoFit/>
+          </a:bodyPr>
+          <a:lstStyle/>
+          <a:p>
+            <a:pPr algn="l">
+              <a:lnSpc>
+                <a:spcPct val="125000"/>
+              </a:lnSpc>
+              <a:spcAft>
+                <a:spcPts val="600"/>
+              </a:spcAft>
+            </a:pPr>
+            <a:r>
+              <a:rPr sz="2800" b="1">
+                <a:solidFill>
+                  <a:srgbClr val="16181A"/>
+                </a:solidFill>
+                <a:latin typeface="Arial"/>
+              </a:rPr>
+              <a:t>The full loop, running</a:t>
+            </a:r>
+          </a:p>
+        </p:txBody>
+      </p:sp>
+      <p:sp>
+        <p:nvSpPr>
+          <p:cNvPr id="4" name="Rectangle 3"/>
+          <p:cNvSpPr/>
+          <p:nvPr/>
+        </p:nvSpPr>
+        <p:spPr>
+          <a:xfrm>
+            <a:off x="658368" y="1481328"/>
+            <a:ext cx="10881360" cy="18288"/>
+          </a:xfrm>
+          <a:prstGeom prst="rect">
+            <a:avLst/>
+          </a:prstGeom>
+          <a:solidFill>
+            <a:srgbClr val="D8DCE0"/>
+          </a:solidFill>
+          <a:ln>
+            <a:noFill/>
+          </a:ln>
+          <a:effectLst/>
+        </p:spPr>
+        <p:style>
+          <a:lnRef idx="1">
+            <a:schemeClr val="accent1"/>
+          </a:lnRef>
+          <a:fillRef idx="3">
+            <a:schemeClr val="accent1"/>
+          </a:fillRef>
+          <a:effectRef idx="2">
+            <a:schemeClr val="accent1"/>
+          </a:effectRef>
+          <a:fontRef idx="minor">
+            <a:schemeClr val="lt1"/>
+          </a:fontRef>
+        </p:style>
+        <p:txBody>
+          <a:bodyPr rtlCol="0" anchor="ctr"/>
+          <a:lstStyle/>
+          <a:p>
+            <a:pPr algn="ctr"/>
+          </a:p>
+        </p:txBody>
+      </p:sp>
       <p:sp>
         <p:nvSpPr>
           <p:cNvPr id="5" name="TextBox 4"/>
@@ -7744,6 +10225,34 @@
                 <a:latin typeface="Arial"/>
               </a:rPr>
               <a:t>record entries; the Director silently poisons what you rely on.</a:t>
+            </a:r>
+          </a:p>
+          <a:p>
+            <a:pPr>
+              <a:lnSpc>
+                <a:spcPct val="130000"/>
+              </a:lnSpc>
+              <a:spcAft>
+                <a:spcPts val="1300"/>
+              </a:spcAft>
+            </a:pPr>
+            <a:r>
+              <a:rPr sz="1500" b="1">
+                <a:solidFill>
+                  <a:srgbClr val="16181A"/>
+                </a:solidFill>
+                <a:latin typeface="Arial"/>
+              </a:rPr>
+              <a:t>All four counter-moves —  </a:t>
+            </a:r>
+            <a:r>
+              <a:rPr sz="1500">
+                <a:solidFill>
+                  <a:srgbClr val="6B7178"/>
+                </a:solidFill>
+                <a:latin typeface="Arial"/>
+              </a:rPr>
+              <a:t>intercept, seal, rewire and poison, with a live counter for each.</a:t>
             </a:r>
           </a:p>
           <a:p>
@@ -7887,7 +10396,7 @@
                 </a:solidFill>
                 <a:latin typeface="Arial"/>
               </a:rPr>
-              <a:t>Observed in a 96-move automated session</a:t>
+              <a:t>Observed in a 126-move automated session</a:t>
             </a:r>
           </a:p>
           <a:p>
@@ -7906,7 +10415,7 @@
                 </a:solidFill>
                 <a:latin typeface="Arial"/>
               </a:rPr>
-              <a:t>VOMM 72%  vs.  no-model 31%  —  and 2 of 16 transmitted signals corrupted by sabotage the player was never told about.</a:t>
+              <a:t>VOMM 74%  vs.  no-model 48%.  The Director sealed 2 doors, rewired 4 rooms and poisoned 10 codebooks — corrupting 4 of 19 transmitted signals. The player was never told about any of it.</a:t>
             </a:r>
           </a:p>
         </p:txBody>
@@ -7919,7 +10428,7 @@
 </p:sld>
 </file>
 
-<file path=ppt/slides/slide2.xml><?xml version="1.0" encoding="utf-8"?>
+<file path=ppt/slides/slide23.xml><?xml version="1.0" encoding="utf-8"?>
 <p:sld xmlns:a="http://schemas.openxmlformats.org/drawingml/2006/main" xmlns:p="http://schemas.openxmlformats.org/presentationml/2006/main" xmlns:r="http://schemas.openxmlformats.org/officeDocument/2006/relationships">
   <p:cSld>
     <p:bg>
@@ -7974,7 +10483,7 @@
                 </a:solidFill>
                 <a:latin typeface="Arial"/>
               </a:rPr>
-              <a:t>WHAT THIS REVIEW COVERS</a:t>
+              <a:t>21 · ROADMAP</a:t>
             </a:r>
           </a:p>
         </p:txBody>
@@ -8016,7 +10525,7 @@
                 </a:solidFill>
                 <a:latin typeface="Arial"/>
               </a:rPr>
-              <a:t>Mapped to the marking rubric</a:t>
+              <a:t>Three of six milestones complete</a:t>
             </a:r>
           </a:p>
         </p:txBody>
@@ -8075,7 +10584,7 @@
         </p:nvGraphicFramePr>
         <p:xfrm>
           <a:off x="658368" y="1783080"/>
-          <a:ext cx="10881360" cy="2304288"/>
+          <a:ext cx="10881360" cy="2688336"/>
         </p:xfrm>
         <a:graphic>
           <a:graphicData uri="http://schemas.openxmlformats.org/drawingml/2006/table">
@@ -8084,9 +10593,9 @@
                 <a:tableStyleId>{5C22544A-7EE6-4342-B048-85BDC9FD1C3A}</a:tableStyleId>
               </a:tblPr>
               <a:tblGrid>
-                <a:gridCol w="3931920"/>
-                <a:gridCol w="3657600"/>
-                <a:gridCol w="3291840"/>
+                <a:gridCol w="1188720"/>
+                <a:gridCol w="7680960"/>
+                <a:gridCol w="2011680"/>
               </a:tblGrid>
               <a:tr h="384048">
                 <a:tc>
@@ -8106,7 +10615,7 @@
                           </a:solidFill>
                           <a:latin typeface="Arial"/>
                         </a:rPr>
-                        <a:t>Rubric</a:t>
+                        <a:t>Milestone</a:t>
                       </a:r>
                     </a:p>
                   </a:txBody>
@@ -8133,7 +10642,7 @@
                           </a:solidFill>
                           <a:latin typeface="Arial"/>
                         </a:rPr>
-                        <a:t>Where it is answered</a:t>
+                        <a:t>Deliverable</a:t>
                       </a:r>
                     </a:p>
                   </a:txBody>
@@ -8160,7 +10669,7 @@
                           </a:solidFill>
                           <a:latin typeface="Arial"/>
                         </a:rPr>
-                        <a:t>Evidence</a:t>
+                        <a:t>State</a:t>
                       </a:r>
                     </a:p>
                   </a:txBody>
@@ -8183,67 +10692,67 @@
                         </a:lnSpc>
                       </a:pPr>
                       <a:r>
-                        <a:rPr sz="1250" b="0">
-                          <a:solidFill>
-                            <a:srgbClr val="16181A"/>
-                          </a:solidFill>
-                          <a:latin typeface="Arial"/>
-                        </a:rPr>
-                        <a:t>Knowledge on domain / problem statement</a:t>
-                      </a:r>
-                    </a:p>
-                  </a:txBody>
-                  <a:tcPr marL="73152" marR="73152" marT="36576" marB="36576">
-                    <a:solidFill>
-                      <a:srgbClr val="FCFCFB"/>
-                    </a:solidFill>
-                  </a:tcPr>
-                </a:tc>
-                <a:tc>
-                  <a:txBody>
-                    <a:bodyPr/>
-                    <a:lstStyle/>
-                    <a:p>
-                      <a:pPr>
-                        <a:lnSpc>
-                          <a:spcPct val="115000"/>
-                        </a:lnSpc>
-                      </a:pPr>
-                      <a:r>
-                        <a:rPr sz="1250" b="0">
-                          <a:solidFill>
-                            <a:srgbClr val="16181A"/>
-                          </a:solidFill>
-                          <a:latin typeface="Arial"/>
-                        </a:rPr>
-                        <a:t>Sections 1–3 of this deck</a:t>
-                      </a:r>
-                    </a:p>
-                  </a:txBody>
-                  <a:tcPr marL="73152" marR="73152" marT="36576" marB="36576">
-                    <a:solidFill>
-                      <a:srgbClr val="FCFCFB"/>
-                    </a:solidFill>
-                  </a:tcPr>
-                </a:tc>
-                <a:tc>
-                  <a:txBody>
-                    <a:bodyPr/>
-                    <a:lstStyle/>
-                    <a:p>
-                      <a:pPr>
-                        <a:lnSpc>
-                          <a:spcPct val="115000"/>
-                        </a:lnSpc>
-                      </a:pPr>
-                      <a:r>
-                        <a:rPr sz="1250" b="0">
-                          <a:solidFill>
-                            <a:srgbClr val="16181A"/>
-                          </a:solidFill>
-                          <a:latin typeface="Arial"/>
-                        </a:rPr>
-                        <a:t>Gap analysis over 22 works</a:t>
+                        <a:rPr sz="1300" b="0">
+                          <a:solidFill>
+                            <a:srgbClr val="16181A"/>
+                          </a:solidFill>
+                          <a:latin typeface="Arial"/>
+                        </a:rPr>
+                        <a:t>M0</a:t>
+                      </a:r>
+                    </a:p>
+                  </a:txBody>
+                  <a:tcPr marL="73152" marR="73152" marT="36576" marB="36576">
+                    <a:solidFill>
+                      <a:srgbClr val="FCFCFB"/>
+                    </a:solidFill>
+                  </a:tcPr>
+                </a:tc>
+                <a:tc>
+                  <a:txBody>
+                    <a:bodyPr/>
+                    <a:lstStyle/>
+                    <a:p>
+                      <a:pPr>
+                        <a:lnSpc>
+                          <a:spcPct val="115000"/>
+                        </a:lnSpc>
+                      </a:pPr>
+                      <a:r>
+                        <a:rPr sz="1300" b="0">
+                          <a:solidFill>
+                            <a:srgbClr val="16181A"/>
+                          </a:solidFill>
+                          <a:latin typeface="Arial"/>
+                        </a:rPr>
+                        <a:t>Headless simulation core, telemetry, bot harness</a:t>
+                      </a:r>
+                    </a:p>
+                  </a:txBody>
+                  <a:tcPr marL="73152" marR="73152" marT="36576" marB="36576">
+                    <a:solidFill>
+                      <a:srgbClr val="FCFCFB"/>
+                    </a:solidFill>
+                  </a:tcPr>
+                </a:tc>
+                <a:tc>
+                  <a:txBody>
+                    <a:bodyPr/>
+                    <a:lstStyle/>
+                    <a:p>
+                      <a:pPr>
+                        <a:lnSpc>
+                          <a:spcPct val="115000"/>
+                        </a:lnSpc>
+                      </a:pPr>
+                      <a:r>
+                        <a:rPr sz="1300" b="0">
+                          <a:solidFill>
+                            <a:srgbClr val="16181A"/>
+                          </a:solidFill>
+                          <a:latin typeface="Arial"/>
+                        </a:rPr>
+                        <a:t>Complete</a:t>
                       </a:r>
                     </a:p>
                   </a:txBody>
@@ -8266,67 +10775,67 @@
                         </a:lnSpc>
                       </a:pPr>
                       <a:r>
-                        <a:rPr sz="1250" b="0">
-                          <a:solidFill>
-                            <a:srgbClr val="16181A"/>
-                          </a:solidFill>
-                          <a:latin typeface="Arial"/>
-                        </a:rPr>
-                        <a:t>Literature review (min. 15 recent papers)</a:t>
-                      </a:r>
-                    </a:p>
-                  </a:txBody>
-                  <a:tcPr marL="73152" marR="73152" marT="36576" marB="36576">
-                    <a:solidFill>
-                      <a:srgbClr val="FCFCFB"/>
-                    </a:solidFill>
-                  </a:tcPr>
-                </a:tc>
-                <a:tc>
-                  <a:txBody>
-                    <a:bodyPr/>
-                    <a:lstStyle/>
-                    <a:p>
-                      <a:pPr>
-                        <a:lnSpc>
-                          <a:spcPct val="115000"/>
-                        </a:lnSpc>
-                      </a:pPr>
-                      <a:r>
-                        <a:rPr sz="1250" b="0">
-                          <a:solidFill>
-                            <a:srgbClr val="16181A"/>
-                          </a:solidFill>
-                          <a:latin typeface="Arial"/>
-                        </a:rPr>
-                        <a:t>Sections 4–7</a:t>
-                      </a:r>
-                    </a:p>
-                  </a:txBody>
-                  <a:tcPr marL="73152" marR="73152" marT="36576" marB="36576">
-                    <a:solidFill>
-                      <a:srgbClr val="FCFCFB"/>
-                    </a:solidFill>
-                  </a:tcPr>
-                </a:tc>
-                <a:tc>
-                  <a:txBody>
-                    <a:bodyPr/>
-                    <a:lstStyle/>
-                    <a:p>
-                      <a:pPr>
-                        <a:lnSpc>
-                          <a:spcPct val="115000"/>
-                        </a:lnSpc>
-                      </a:pPr>
-                      <a:r>
-                        <a:rPr sz="1250" b="0">
-                          <a:solidFill>
-                            <a:srgbClr val="16181A"/>
-                          </a:solidFill>
-                          <a:latin typeface="Arial"/>
-                        </a:rPr>
-                        <a:t>22 works, 20 from 2023 or later</a:t>
+                        <a:rPr sz="1300" b="0">
+                          <a:solidFill>
+                            <a:srgbClr val="16181A"/>
+                          </a:solidFill>
+                          <a:latin typeface="Arial"/>
+                        </a:rPr>
+                        <a:t>M1</a:t>
+                      </a:r>
+                    </a:p>
+                  </a:txBody>
+                  <a:tcPr marL="73152" marR="73152" marT="36576" marB="36576">
+                    <a:solidFill>
+                      <a:srgbClr val="FCFCFB"/>
+                    </a:solidFill>
+                  </a:tcPr>
+                </a:tc>
+                <a:tc>
+                  <a:txBody>
+                    <a:bodyPr/>
+                    <a:lstStyle/>
+                    <a:p>
+                      <a:pPr>
+                        <a:lnSpc>
+                          <a:spcPct val="115000"/>
+                        </a:lnSpc>
+                      </a:pPr>
+                      <a:r>
+                        <a:rPr sz="1300" b="0">
+                          <a:solidFill>
+                            <a:srgbClr val="16181A"/>
+                          </a:solidFill>
+                          <a:latin typeface="Arial"/>
+                        </a:rPr>
+                        <a:t>Predictor, baselines, controls, offline metrics and figures</a:t>
+                      </a:r>
+                    </a:p>
+                  </a:txBody>
+                  <a:tcPr marL="73152" marR="73152" marT="36576" marB="36576">
+                    <a:solidFill>
+                      <a:srgbClr val="FCFCFB"/>
+                    </a:solidFill>
+                  </a:tcPr>
+                </a:tc>
+                <a:tc>
+                  <a:txBody>
+                    <a:bodyPr/>
+                    <a:lstStyle/>
+                    <a:p>
+                      <a:pPr>
+                        <a:lnSpc>
+                          <a:spcPct val="115000"/>
+                        </a:lnSpc>
+                      </a:pPr>
+                      <a:r>
+                        <a:rPr sz="1300" b="0">
+                          <a:solidFill>
+                            <a:srgbClr val="16181A"/>
+                          </a:solidFill>
+                          <a:latin typeface="Arial"/>
+                        </a:rPr>
+                        <a:t>Complete</a:t>
                       </a:r>
                     </a:p>
                   </a:txBody>
@@ -8349,67 +10858,67 @@
                         </a:lnSpc>
                       </a:pPr>
                       <a:r>
-                        <a:rPr sz="1250" b="0">
-                          <a:solidFill>
-                            <a:srgbClr val="16181A"/>
-                          </a:solidFill>
-                          <a:latin typeface="Arial"/>
-                        </a:rPr>
-                        <a:t>Design of proposed methodology</a:t>
-                      </a:r>
-                    </a:p>
-                  </a:txBody>
-                  <a:tcPr marL="73152" marR="73152" marT="36576" marB="36576">
-                    <a:solidFill>
-                      <a:srgbClr val="FCFCFB"/>
-                    </a:solidFill>
-                  </a:tcPr>
-                </a:tc>
-                <a:tc>
-                  <a:txBody>
-                    <a:bodyPr/>
-                    <a:lstStyle/>
-                    <a:p>
-                      <a:pPr>
-                        <a:lnSpc>
-                          <a:spcPct val="115000"/>
-                        </a:lnSpc>
-                      </a:pPr>
-                      <a:r>
-                        <a:rPr sz="1250" b="0">
-                          <a:solidFill>
-                            <a:srgbClr val="16181A"/>
-                          </a:solidFill>
-                          <a:latin typeface="Arial"/>
-                        </a:rPr>
-                        <a:t>Sections 8–11</a:t>
-                      </a:r>
-                    </a:p>
-                  </a:txBody>
-                  <a:tcPr marL="73152" marR="73152" marT="36576" marB="36576">
-                    <a:solidFill>
-                      <a:srgbClr val="FCFCFB"/>
-                    </a:solidFill>
-                  </a:tcPr>
-                </a:tc>
-                <a:tc>
-                  <a:txBody>
-                    <a:bodyPr/>
-                    <a:lstStyle/>
-                    <a:p>
-                      <a:pPr>
-                        <a:lnSpc>
-                          <a:spcPct val="115000"/>
-                        </a:lnSpc>
-                      </a:pPr>
-                      <a:r>
-                        <a:rPr sz="1250" b="0">
-                          <a:solidFill>
-                            <a:srgbClr val="16181A"/>
-                          </a:solidFill>
-                          <a:latin typeface="Arial"/>
-                        </a:rPr>
-                        <a:t>Formal model + evaluation protocol</a:t>
+                        <a:rPr sz="1300" b="0">
+                          <a:solidFill>
+                            <a:srgbClr val="16181A"/>
+                          </a:solidFill>
+                          <a:latin typeface="Arial"/>
+                        </a:rPr>
+                        <a:t>M2</a:t>
+                      </a:r>
+                    </a:p>
+                  </a:txBody>
+                  <a:tcPr marL="73152" marR="73152" marT="36576" marB="36576">
+                    <a:solidFill>
+                      <a:srgbClr val="FCFCFB"/>
+                    </a:solidFill>
+                  </a:tcPr>
+                </a:tc>
+                <a:tc>
+                  <a:txBody>
+                    <a:bodyPr/>
+                    <a:lstStyle/>
+                    <a:p>
+                      <a:pPr>
+                        <a:lnSpc>
+                          <a:spcPct val="115000"/>
+                        </a:lnSpc>
+                      </a:pPr>
+                      <a:r>
+                        <a:rPr sz="1300" b="0">
+                          <a:solidFill>
+                            <a:srgbClr val="16181A"/>
+                          </a:solidFill>
+                          <a:latin typeface="Arial"/>
+                        </a:rPr>
+                        <a:t>Director and counter-moves, validated headless</a:t>
+                      </a:r>
+                    </a:p>
+                  </a:txBody>
+                  <a:tcPr marL="73152" marR="73152" marT="36576" marB="36576">
+                    <a:solidFill>
+                      <a:srgbClr val="FCFCFB"/>
+                    </a:solidFill>
+                  </a:tcPr>
+                </a:tc>
+                <a:tc>
+                  <a:txBody>
+                    <a:bodyPr/>
+                    <a:lstStyle/>
+                    <a:p>
+                      <a:pPr>
+                        <a:lnSpc>
+                          <a:spcPct val="115000"/>
+                        </a:lnSpc>
+                      </a:pPr>
+                      <a:r>
+                        <a:rPr sz="1300" b="0">
+                          <a:solidFill>
+                            <a:srgbClr val="16181A"/>
+                          </a:solidFill>
+                          <a:latin typeface="Arial"/>
+                        </a:rPr>
+                        <a:t>Complete</a:t>
                       </a:r>
                     </a:p>
                   </a:txBody>
@@ -8432,67 +10941,67 @@
                         </a:lnSpc>
                       </a:pPr>
                       <a:r>
-                        <a:rPr sz="1250" b="0">
-                          <a:solidFill>
-                            <a:srgbClr val="16181A"/>
-                          </a:solidFill>
-                          <a:latin typeface="Arial"/>
-                        </a:rPr>
-                        <a:t>Module description / system design</a:t>
-                      </a:r>
-                    </a:p>
-                  </a:txBody>
-                  <a:tcPr marL="73152" marR="73152" marT="36576" marB="36576">
-                    <a:solidFill>
-                      <a:srgbClr val="FCFCFB"/>
-                    </a:solidFill>
-                  </a:tcPr>
-                </a:tc>
-                <a:tc>
-                  <a:txBody>
-                    <a:bodyPr/>
-                    <a:lstStyle/>
-                    <a:p>
-                      <a:pPr>
-                        <a:lnSpc>
-                          <a:spcPct val="115000"/>
-                        </a:lnSpc>
-                      </a:pPr>
-                      <a:r>
-                        <a:rPr sz="1250" b="0">
-                          <a:solidFill>
-                            <a:srgbClr val="16181A"/>
-                          </a:solidFill>
-                          <a:latin typeface="Arial"/>
-                        </a:rPr>
-                        <a:t>Sections 12–13</a:t>
-                      </a:r>
-                    </a:p>
-                  </a:txBody>
-                  <a:tcPr marL="73152" marR="73152" marT="36576" marB="36576">
-                    <a:solidFill>
-                      <a:srgbClr val="FCFCFB"/>
-                    </a:solidFill>
-                  </a:tcPr>
-                </a:tc>
-                <a:tc>
-                  <a:txBody>
-                    <a:bodyPr/>
-                    <a:lstStyle/>
-                    <a:p>
-                      <a:pPr>
-                        <a:lnSpc>
-                          <a:spcPct val="115000"/>
-                        </a:lnSpc>
-                      </a:pPr>
-                      <a:r>
-                        <a:rPr sz="1250" b="0">
-                          <a:solidFill>
-                            <a:srgbClr val="16181A"/>
-                          </a:solidFill>
-                          <a:latin typeface="Arial"/>
-                        </a:rPr>
-                        <a:t>8 modules, implemented and tested</a:t>
+                        <a:rPr sz="1300" b="0">
+                          <a:solidFill>
+                            <a:srgbClr val="16181A"/>
+                          </a:solidFill>
+                          <a:latin typeface="Arial"/>
+                        </a:rPr>
+                        <a:t>M3</a:t>
+                      </a:r>
+                    </a:p>
+                  </a:txBody>
+                  <a:tcPr marL="73152" marR="73152" marT="36576" marB="36576">
+                    <a:solidFill>
+                      <a:srgbClr val="FCFCFB"/>
+                    </a:solidFill>
+                  </a:tcPr>
+                </a:tc>
+                <a:tc>
+                  <a:txBody>
+                    <a:bodyPr/>
+                    <a:lstStyle/>
+                    <a:p>
+                      <a:pPr>
+                        <a:lnSpc>
+                          <a:spcPct val="115000"/>
+                        </a:lnSpc>
+                      </a:pPr>
+                      <a:r>
+                        <a:rPr sz="1300" b="0">
+                          <a:solidFill>
+                            <a:srgbClr val="16181A"/>
+                          </a:solidFill>
+                          <a:latin typeface="Arial"/>
+                        </a:rPr>
+                        <a:t>Godot greybox first-person build + live prediction overlay</a:t>
+                      </a:r>
+                    </a:p>
+                  </a:txBody>
+                  <a:tcPr marL="73152" marR="73152" marT="36576" marB="36576">
+                    <a:solidFill>
+                      <a:srgbClr val="FCFCFB"/>
+                    </a:solidFill>
+                  </a:tcPr>
+                </a:tc>
+                <a:tc>
+                  <a:txBody>
+                    <a:bodyPr/>
+                    <a:lstStyle/>
+                    <a:p>
+                      <a:pPr>
+                        <a:lnSpc>
+                          <a:spcPct val="115000"/>
+                        </a:lnSpc>
+                      </a:pPr>
+                      <a:r>
+                        <a:rPr sz="1300" b="0">
+                          <a:solidFill>
+                            <a:srgbClr val="16181A"/>
+                          </a:solidFill>
+                          <a:latin typeface="Arial"/>
+                        </a:rPr>
+                        <a:t>Next</a:t>
                       </a:r>
                     </a:p>
                   </a:txBody>
@@ -8515,67 +11024,150 @@
                         </a:lnSpc>
                       </a:pPr>
                       <a:r>
-                        <a:rPr sz="1250" b="0">
-                          <a:solidFill>
-                            <a:srgbClr val="16181A"/>
-                          </a:solidFill>
-                          <a:latin typeface="Arial"/>
-                        </a:rPr>
-                        <a:t>Beyond the rubric</a:t>
-                      </a:r>
-                    </a:p>
-                  </a:txBody>
-                  <a:tcPr marL="73152" marR="73152" marT="36576" marB="36576">
-                    <a:solidFill>
-                      <a:srgbClr val="FCFCFB"/>
-                    </a:solidFill>
-                  </a:tcPr>
-                </a:tc>
-                <a:tc>
-                  <a:txBody>
-                    <a:bodyPr/>
-                    <a:lstStyle/>
-                    <a:p>
-                      <a:pPr>
-                        <a:lnSpc>
-                          <a:spcPct val="115000"/>
-                        </a:lnSpc>
-                      </a:pPr>
-                      <a:r>
-                        <a:rPr sz="1250" b="0">
-                          <a:solidFill>
-                            <a:srgbClr val="16181A"/>
-                          </a:solidFill>
-                          <a:latin typeface="Arial"/>
-                        </a:rPr>
-                        <a:t>Sections 14–17</a:t>
-                      </a:r>
-                    </a:p>
-                  </a:txBody>
-                  <a:tcPr marL="73152" marR="73152" marT="36576" marB="36576">
-                    <a:solidFill>
-                      <a:srgbClr val="FCFCFB"/>
-                    </a:solidFill>
-                  </a:tcPr>
-                </a:tc>
-                <a:tc>
-                  <a:txBody>
-                    <a:bodyPr/>
-                    <a:lstStyle/>
-                    <a:p>
-                      <a:pPr>
-                        <a:lnSpc>
-                          <a:spcPct val="115000"/>
-                        </a:lnSpc>
-                      </a:pPr>
-                      <a:r>
-                        <a:rPr sz="1250" b="0">
-                          <a:solidFill>
-                            <a:srgbClr val="16181A"/>
-                          </a:solidFill>
-                          <a:latin typeface="Arial"/>
-                        </a:rPr>
-                        <a:t>Working results and a live demo</a:t>
+                        <a:rPr sz="1300" b="0">
+                          <a:solidFill>
+                            <a:srgbClr val="16181A"/>
+                          </a:solidFill>
+                          <a:latin typeface="Arial"/>
+                        </a:rPr>
+                        <a:t>M4</a:t>
+                      </a:r>
+                    </a:p>
+                  </a:txBody>
+                  <a:tcPr marL="73152" marR="73152" marT="36576" marB="36576">
+                    <a:solidFill>
+                      <a:srgbClr val="FCFCFB"/>
+                    </a:solidFill>
+                  </a:tcPr>
+                </a:tc>
+                <a:tc>
+                  <a:txBody>
+                    <a:bodyPr/>
+                    <a:lstStyle/>
+                    <a:p>
+                      <a:pPr>
+                        <a:lnSpc>
+                          <a:spcPct val="115000"/>
+                        </a:lnSpc>
+                      </a:pPr>
+                      <a:r>
+                        <a:rPr sz="1300" b="0">
+                          <a:solidFill>
+                            <a:srgbClr val="16181A"/>
+                          </a:solidFill>
+                          <a:latin typeface="Arial"/>
+                        </a:rPr>
+                        <a:t>Notebook vector editor and persistence</a:t>
+                      </a:r>
+                    </a:p>
+                  </a:txBody>
+                  <a:tcPr marL="73152" marR="73152" marT="36576" marB="36576">
+                    <a:solidFill>
+                      <a:srgbClr val="FCFCFB"/>
+                    </a:solidFill>
+                  </a:tcPr>
+                </a:tc>
+                <a:tc>
+                  <a:txBody>
+                    <a:bodyPr/>
+                    <a:lstStyle/>
+                    <a:p>
+                      <a:pPr>
+                        <a:lnSpc>
+                          <a:spcPct val="115000"/>
+                        </a:lnSpc>
+                      </a:pPr>
+                      <a:r>
+                        <a:rPr sz="1300" b="0">
+                          <a:solidFill>
+                            <a:srgbClr val="16181A"/>
+                          </a:solidFill>
+                          <a:latin typeface="Arial"/>
+                        </a:rPr>
+                        <a:t>Planned</a:t>
+                      </a:r>
+                    </a:p>
+                  </a:txBody>
+                  <a:tcPr marL="73152" marR="73152" marT="36576" marB="36576">
+                    <a:solidFill>
+                      <a:srgbClr val="FCFCFB"/>
+                    </a:solidFill>
+                  </a:tcPr>
+                </a:tc>
+              </a:tr>
+              <a:tr h="384048">
+                <a:tc>
+                  <a:txBody>
+                    <a:bodyPr/>
+                    <a:lstStyle/>
+                    <a:p>
+                      <a:pPr>
+                        <a:lnSpc>
+                          <a:spcPct val="115000"/>
+                        </a:lnSpc>
+                      </a:pPr>
+                      <a:r>
+                        <a:rPr sz="1300" b="0">
+                          <a:solidFill>
+                            <a:srgbClr val="16181A"/>
+                          </a:solidFill>
+                          <a:latin typeface="Arial"/>
+                        </a:rPr>
+                        <a:t>M5</a:t>
+                      </a:r>
+                    </a:p>
+                  </a:txBody>
+                  <a:tcPr marL="73152" marR="73152" marT="36576" marB="36576">
+                    <a:solidFill>
+                      <a:srgbClr val="FCFCFB"/>
+                    </a:solidFill>
+                  </a:tcPr>
+                </a:tc>
+                <a:tc>
+                  <a:txBody>
+                    <a:bodyPr/>
+                    <a:lstStyle/>
+                    <a:p>
+                      <a:pPr>
+                        <a:lnSpc>
+                          <a:spcPct val="115000"/>
+                        </a:lnSpc>
+                      </a:pPr>
+                      <a:r>
+                        <a:rPr sz="1300" b="0">
+                          <a:solidFill>
+                            <a:srgbClr val="16181A"/>
+                          </a:solidFill>
+                          <a:latin typeface="Arial"/>
+                        </a:rPr>
+                        <a:t>Entity polish, atmosphere, audio, human playtest</a:t>
+                      </a:r>
+                    </a:p>
+                  </a:txBody>
+                  <a:tcPr marL="73152" marR="73152" marT="36576" marB="36576">
+                    <a:solidFill>
+                      <a:srgbClr val="FCFCFB"/>
+                    </a:solidFill>
+                  </a:tcPr>
+                </a:tc>
+                <a:tc>
+                  <a:txBody>
+                    <a:bodyPr/>
+                    <a:lstStyle/>
+                    <a:p>
+                      <a:pPr>
+                        <a:lnSpc>
+                          <a:spcPct val="115000"/>
+                        </a:lnSpc>
+                      </a:pPr>
+                      <a:r>
+                        <a:rPr sz="1300" b="0">
+                          <a:solidFill>
+                            <a:srgbClr val="16181A"/>
+                          </a:solidFill>
+                          <a:latin typeface="Arial"/>
+                        </a:rPr>
+                        <a:t>Planned</a:t>
                       </a:r>
                     </a:p>
                   </a:txBody>
@@ -8590,6 +11182,48 @@
           </a:graphicData>
         </a:graphic>
       </p:graphicFrame>
+      <p:sp>
+        <p:nvSpPr>
+          <p:cNvPr id="6" name="TextBox 5"/>
+          <p:cNvSpPr txBox="1"/>
+          <p:nvPr/>
+        </p:nvSpPr>
+        <p:spPr>
+          <a:xfrm>
+            <a:off x="658368" y="4663440"/>
+            <a:ext cx="10881360" cy="1097280"/>
+          </a:xfrm>
+          <a:prstGeom prst="rect">
+            <a:avLst/>
+          </a:prstGeom>
+          <a:noFill/>
+        </p:spPr>
+        <p:txBody>
+          <a:bodyPr wrap="square" lIns="0" rIns="0" tIns="0" bIns="0">
+            <a:spAutoFit/>
+          </a:bodyPr>
+          <a:lstStyle/>
+          <a:p>
+            <a:pPr algn="l">
+              <a:lnSpc>
+                <a:spcPct val="135000"/>
+              </a:lnSpc>
+              <a:spcAft>
+                <a:spcPts val="600"/>
+              </a:spcAft>
+            </a:pPr>
+            <a:r>
+              <a:rPr sz="1300" b="0">
+                <a:solidFill>
+                  <a:srgbClr val="6B7178"/>
+                </a:solidFill>
+                <a:latin typeface="Arial"/>
+              </a:rPr>
+              <a:t>Art direction for M3 is settled: a low-poly modular brutalist kit instantiated from the room graph, near-total darkness with a flashlight, heavy fog, and a retro post-processing pass — chosen because it minimises modelling cost while staying coherent. Modularity is not a style choice: rooms are rotated, added and removed at runtime, so they must be prefab-instantiated regardless.</a:t>
+            </a:r>
+          </a:p>
+        </p:txBody>
+      </p:sp>
     </p:spTree>
   </p:cSld>
   <p:clrMapOvr>
@@ -8598,7 +11232,7 @@
 </p:sld>
 </file>
 
-<file path=ppt/slides/slide20.xml><?xml version="1.0" encoding="utf-8"?>
+<file path=ppt/slides/slide24.xml><?xml version="1.0" encoding="utf-8"?>
 <p:sld xmlns:a="http://schemas.openxmlformats.org/drawingml/2006/main" xmlns:p="http://schemas.openxmlformats.org/presentationml/2006/main" xmlns:r="http://schemas.openxmlformats.org/officeDocument/2006/relationships">
   <p:cSld>
     <p:bg>
@@ -8653,7 +11287,7 @@
                 </a:solidFill>
                 <a:latin typeface="Arial"/>
               </a:rPr>
-              <a:t>18 · ROADMAP</a:t>
+              <a:t>REFERENCES</a:t>
             </a:r>
           </a:p>
         </p:txBody>
@@ -8695,7 +11329,7 @@
                 </a:solidFill>
                 <a:latin typeface="Arial"/>
               </a:rPr>
-              <a:t>Three of six milestones complete</a:t>
+              <a:t>1 of 2</a:t>
             </a:r>
           </a:p>
         </p:txBody>
@@ -8744,810 +11378,6 @@
           </a:p>
         </p:txBody>
       </p:sp>
-      <p:graphicFrame>
-        <p:nvGraphicFramePr>
-          <p:cNvPr id="5" name="Table 4"/>
-          <p:cNvGraphicFramePr>
-            <a:graphicFrameLocks noGrp="1"/>
-          </p:cNvGraphicFramePr>
-          <p:nvPr/>
-        </p:nvGraphicFramePr>
-        <p:xfrm>
-          <a:off x="658368" y="1783080"/>
-          <a:ext cx="10881360" cy="2688336"/>
-        </p:xfrm>
-        <a:graphic>
-          <a:graphicData uri="http://schemas.openxmlformats.org/drawingml/2006/table">
-            <a:tbl>
-              <a:tblPr firstRow="1" bandRow="1">
-                <a:tableStyleId>{5C22544A-7EE6-4342-B048-85BDC9FD1C3A}</a:tableStyleId>
-              </a:tblPr>
-              <a:tblGrid>
-                <a:gridCol w="1188720"/>
-                <a:gridCol w="7680960"/>
-                <a:gridCol w="2011680"/>
-              </a:tblGrid>
-              <a:tr h="384048">
-                <a:tc>
-                  <a:txBody>
-                    <a:bodyPr/>
-                    <a:lstStyle/>
-                    <a:p>
-                      <a:pPr>
-                        <a:lnSpc>
-                          <a:spcPct val="115000"/>
-                        </a:lnSpc>
-                      </a:pPr>
-                      <a:r>
-                        <a:rPr sz="950" b="1">
-                          <a:solidFill>
-                            <a:srgbClr val="6B7178"/>
-                          </a:solidFill>
-                          <a:latin typeface="Arial"/>
-                        </a:rPr>
-                        <a:t>Milestone</a:t>
-                      </a:r>
-                    </a:p>
-                  </a:txBody>
-                  <a:tcPr marL="73152" marR="73152" marT="36576" marB="36576">
-                    <a:solidFill>
-                      <a:srgbClr val="F4F6F8"/>
-                    </a:solidFill>
-                  </a:tcPr>
-                </a:tc>
-                <a:tc>
-                  <a:txBody>
-                    <a:bodyPr/>
-                    <a:lstStyle/>
-                    <a:p>
-                      <a:pPr>
-                        <a:lnSpc>
-                          <a:spcPct val="115000"/>
-                        </a:lnSpc>
-                      </a:pPr>
-                      <a:r>
-                        <a:rPr sz="950" b="1">
-                          <a:solidFill>
-                            <a:srgbClr val="6B7178"/>
-                          </a:solidFill>
-                          <a:latin typeface="Arial"/>
-                        </a:rPr>
-                        <a:t>Deliverable</a:t>
-                      </a:r>
-                    </a:p>
-                  </a:txBody>
-                  <a:tcPr marL="73152" marR="73152" marT="36576" marB="36576">
-                    <a:solidFill>
-                      <a:srgbClr val="F4F6F8"/>
-                    </a:solidFill>
-                  </a:tcPr>
-                </a:tc>
-                <a:tc>
-                  <a:txBody>
-                    <a:bodyPr/>
-                    <a:lstStyle/>
-                    <a:p>
-                      <a:pPr>
-                        <a:lnSpc>
-                          <a:spcPct val="115000"/>
-                        </a:lnSpc>
-                      </a:pPr>
-                      <a:r>
-                        <a:rPr sz="950" b="1">
-                          <a:solidFill>
-                            <a:srgbClr val="6B7178"/>
-                          </a:solidFill>
-                          <a:latin typeface="Arial"/>
-                        </a:rPr>
-                        <a:t>State</a:t>
-                      </a:r>
-                    </a:p>
-                  </a:txBody>
-                  <a:tcPr marL="73152" marR="73152" marT="36576" marB="36576">
-                    <a:solidFill>
-                      <a:srgbClr val="F4F6F8"/>
-                    </a:solidFill>
-                  </a:tcPr>
-                </a:tc>
-              </a:tr>
-              <a:tr h="384048">
-                <a:tc>
-                  <a:txBody>
-                    <a:bodyPr/>
-                    <a:lstStyle/>
-                    <a:p>
-                      <a:pPr>
-                        <a:lnSpc>
-                          <a:spcPct val="115000"/>
-                        </a:lnSpc>
-                      </a:pPr>
-                      <a:r>
-                        <a:rPr sz="1300" b="0">
-                          <a:solidFill>
-                            <a:srgbClr val="16181A"/>
-                          </a:solidFill>
-                          <a:latin typeface="Arial"/>
-                        </a:rPr>
-                        <a:t>M0</a:t>
-                      </a:r>
-                    </a:p>
-                  </a:txBody>
-                  <a:tcPr marL="73152" marR="73152" marT="36576" marB="36576">
-                    <a:solidFill>
-                      <a:srgbClr val="FCFCFB"/>
-                    </a:solidFill>
-                  </a:tcPr>
-                </a:tc>
-                <a:tc>
-                  <a:txBody>
-                    <a:bodyPr/>
-                    <a:lstStyle/>
-                    <a:p>
-                      <a:pPr>
-                        <a:lnSpc>
-                          <a:spcPct val="115000"/>
-                        </a:lnSpc>
-                      </a:pPr>
-                      <a:r>
-                        <a:rPr sz="1300" b="0">
-                          <a:solidFill>
-                            <a:srgbClr val="16181A"/>
-                          </a:solidFill>
-                          <a:latin typeface="Arial"/>
-                        </a:rPr>
-                        <a:t>Headless simulation core, telemetry, bot harness</a:t>
-                      </a:r>
-                    </a:p>
-                  </a:txBody>
-                  <a:tcPr marL="73152" marR="73152" marT="36576" marB="36576">
-                    <a:solidFill>
-                      <a:srgbClr val="FCFCFB"/>
-                    </a:solidFill>
-                  </a:tcPr>
-                </a:tc>
-                <a:tc>
-                  <a:txBody>
-                    <a:bodyPr/>
-                    <a:lstStyle/>
-                    <a:p>
-                      <a:pPr>
-                        <a:lnSpc>
-                          <a:spcPct val="115000"/>
-                        </a:lnSpc>
-                      </a:pPr>
-                      <a:r>
-                        <a:rPr sz="1300" b="0">
-                          <a:solidFill>
-                            <a:srgbClr val="16181A"/>
-                          </a:solidFill>
-                          <a:latin typeface="Arial"/>
-                        </a:rPr>
-                        <a:t>Complete</a:t>
-                      </a:r>
-                    </a:p>
-                  </a:txBody>
-                  <a:tcPr marL="73152" marR="73152" marT="36576" marB="36576">
-                    <a:solidFill>
-                      <a:srgbClr val="FCFCFB"/>
-                    </a:solidFill>
-                  </a:tcPr>
-                </a:tc>
-              </a:tr>
-              <a:tr h="384048">
-                <a:tc>
-                  <a:txBody>
-                    <a:bodyPr/>
-                    <a:lstStyle/>
-                    <a:p>
-                      <a:pPr>
-                        <a:lnSpc>
-                          <a:spcPct val="115000"/>
-                        </a:lnSpc>
-                      </a:pPr>
-                      <a:r>
-                        <a:rPr sz="1300" b="0">
-                          <a:solidFill>
-                            <a:srgbClr val="16181A"/>
-                          </a:solidFill>
-                          <a:latin typeface="Arial"/>
-                        </a:rPr>
-                        <a:t>M1</a:t>
-                      </a:r>
-                    </a:p>
-                  </a:txBody>
-                  <a:tcPr marL="73152" marR="73152" marT="36576" marB="36576">
-                    <a:solidFill>
-                      <a:srgbClr val="FCFCFB"/>
-                    </a:solidFill>
-                  </a:tcPr>
-                </a:tc>
-                <a:tc>
-                  <a:txBody>
-                    <a:bodyPr/>
-                    <a:lstStyle/>
-                    <a:p>
-                      <a:pPr>
-                        <a:lnSpc>
-                          <a:spcPct val="115000"/>
-                        </a:lnSpc>
-                      </a:pPr>
-                      <a:r>
-                        <a:rPr sz="1300" b="0">
-                          <a:solidFill>
-                            <a:srgbClr val="16181A"/>
-                          </a:solidFill>
-                          <a:latin typeface="Arial"/>
-                        </a:rPr>
-                        <a:t>Predictor, baselines, controls, offline metrics and figures</a:t>
-                      </a:r>
-                    </a:p>
-                  </a:txBody>
-                  <a:tcPr marL="73152" marR="73152" marT="36576" marB="36576">
-                    <a:solidFill>
-                      <a:srgbClr val="FCFCFB"/>
-                    </a:solidFill>
-                  </a:tcPr>
-                </a:tc>
-                <a:tc>
-                  <a:txBody>
-                    <a:bodyPr/>
-                    <a:lstStyle/>
-                    <a:p>
-                      <a:pPr>
-                        <a:lnSpc>
-                          <a:spcPct val="115000"/>
-                        </a:lnSpc>
-                      </a:pPr>
-                      <a:r>
-                        <a:rPr sz="1300" b="0">
-                          <a:solidFill>
-                            <a:srgbClr val="16181A"/>
-                          </a:solidFill>
-                          <a:latin typeface="Arial"/>
-                        </a:rPr>
-                        <a:t>Complete</a:t>
-                      </a:r>
-                    </a:p>
-                  </a:txBody>
-                  <a:tcPr marL="73152" marR="73152" marT="36576" marB="36576">
-                    <a:solidFill>
-                      <a:srgbClr val="FCFCFB"/>
-                    </a:solidFill>
-                  </a:tcPr>
-                </a:tc>
-              </a:tr>
-              <a:tr h="384048">
-                <a:tc>
-                  <a:txBody>
-                    <a:bodyPr/>
-                    <a:lstStyle/>
-                    <a:p>
-                      <a:pPr>
-                        <a:lnSpc>
-                          <a:spcPct val="115000"/>
-                        </a:lnSpc>
-                      </a:pPr>
-                      <a:r>
-                        <a:rPr sz="1300" b="0">
-                          <a:solidFill>
-                            <a:srgbClr val="16181A"/>
-                          </a:solidFill>
-                          <a:latin typeface="Arial"/>
-                        </a:rPr>
-                        <a:t>M2</a:t>
-                      </a:r>
-                    </a:p>
-                  </a:txBody>
-                  <a:tcPr marL="73152" marR="73152" marT="36576" marB="36576">
-                    <a:solidFill>
-                      <a:srgbClr val="FCFCFB"/>
-                    </a:solidFill>
-                  </a:tcPr>
-                </a:tc>
-                <a:tc>
-                  <a:txBody>
-                    <a:bodyPr/>
-                    <a:lstStyle/>
-                    <a:p>
-                      <a:pPr>
-                        <a:lnSpc>
-                          <a:spcPct val="115000"/>
-                        </a:lnSpc>
-                      </a:pPr>
-                      <a:r>
-                        <a:rPr sz="1300" b="0">
-                          <a:solidFill>
-                            <a:srgbClr val="16181A"/>
-                          </a:solidFill>
-                          <a:latin typeface="Arial"/>
-                        </a:rPr>
-                        <a:t>Director and counter-moves, validated headless</a:t>
-                      </a:r>
-                    </a:p>
-                  </a:txBody>
-                  <a:tcPr marL="73152" marR="73152" marT="36576" marB="36576">
-                    <a:solidFill>
-                      <a:srgbClr val="FCFCFB"/>
-                    </a:solidFill>
-                  </a:tcPr>
-                </a:tc>
-                <a:tc>
-                  <a:txBody>
-                    <a:bodyPr/>
-                    <a:lstStyle/>
-                    <a:p>
-                      <a:pPr>
-                        <a:lnSpc>
-                          <a:spcPct val="115000"/>
-                        </a:lnSpc>
-                      </a:pPr>
-                      <a:r>
-                        <a:rPr sz="1300" b="0">
-                          <a:solidFill>
-                            <a:srgbClr val="16181A"/>
-                          </a:solidFill>
-                          <a:latin typeface="Arial"/>
-                        </a:rPr>
-                        <a:t>Complete</a:t>
-                      </a:r>
-                    </a:p>
-                  </a:txBody>
-                  <a:tcPr marL="73152" marR="73152" marT="36576" marB="36576">
-                    <a:solidFill>
-                      <a:srgbClr val="FCFCFB"/>
-                    </a:solidFill>
-                  </a:tcPr>
-                </a:tc>
-              </a:tr>
-              <a:tr h="384048">
-                <a:tc>
-                  <a:txBody>
-                    <a:bodyPr/>
-                    <a:lstStyle/>
-                    <a:p>
-                      <a:pPr>
-                        <a:lnSpc>
-                          <a:spcPct val="115000"/>
-                        </a:lnSpc>
-                      </a:pPr>
-                      <a:r>
-                        <a:rPr sz="1300" b="0">
-                          <a:solidFill>
-                            <a:srgbClr val="16181A"/>
-                          </a:solidFill>
-                          <a:latin typeface="Arial"/>
-                        </a:rPr>
-                        <a:t>M3</a:t>
-                      </a:r>
-                    </a:p>
-                  </a:txBody>
-                  <a:tcPr marL="73152" marR="73152" marT="36576" marB="36576">
-                    <a:solidFill>
-                      <a:srgbClr val="FCFCFB"/>
-                    </a:solidFill>
-                  </a:tcPr>
-                </a:tc>
-                <a:tc>
-                  <a:txBody>
-                    <a:bodyPr/>
-                    <a:lstStyle/>
-                    <a:p>
-                      <a:pPr>
-                        <a:lnSpc>
-                          <a:spcPct val="115000"/>
-                        </a:lnSpc>
-                      </a:pPr>
-                      <a:r>
-                        <a:rPr sz="1300" b="0">
-                          <a:solidFill>
-                            <a:srgbClr val="16181A"/>
-                          </a:solidFill>
-                          <a:latin typeface="Arial"/>
-                        </a:rPr>
-                        <a:t>Godot greybox first-person build + live prediction overlay</a:t>
-                      </a:r>
-                    </a:p>
-                  </a:txBody>
-                  <a:tcPr marL="73152" marR="73152" marT="36576" marB="36576">
-                    <a:solidFill>
-                      <a:srgbClr val="FCFCFB"/>
-                    </a:solidFill>
-                  </a:tcPr>
-                </a:tc>
-                <a:tc>
-                  <a:txBody>
-                    <a:bodyPr/>
-                    <a:lstStyle/>
-                    <a:p>
-                      <a:pPr>
-                        <a:lnSpc>
-                          <a:spcPct val="115000"/>
-                        </a:lnSpc>
-                      </a:pPr>
-                      <a:r>
-                        <a:rPr sz="1300" b="0">
-                          <a:solidFill>
-                            <a:srgbClr val="16181A"/>
-                          </a:solidFill>
-                          <a:latin typeface="Arial"/>
-                        </a:rPr>
-                        <a:t>Next</a:t>
-                      </a:r>
-                    </a:p>
-                  </a:txBody>
-                  <a:tcPr marL="73152" marR="73152" marT="36576" marB="36576">
-                    <a:solidFill>
-                      <a:srgbClr val="FCFCFB"/>
-                    </a:solidFill>
-                  </a:tcPr>
-                </a:tc>
-              </a:tr>
-              <a:tr h="384048">
-                <a:tc>
-                  <a:txBody>
-                    <a:bodyPr/>
-                    <a:lstStyle/>
-                    <a:p>
-                      <a:pPr>
-                        <a:lnSpc>
-                          <a:spcPct val="115000"/>
-                        </a:lnSpc>
-                      </a:pPr>
-                      <a:r>
-                        <a:rPr sz="1300" b="0">
-                          <a:solidFill>
-                            <a:srgbClr val="16181A"/>
-                          </a:solidFill>
-                          <a:latin typeface="Arial"/>
-                        </a:rPr>
-                        <a:t>M4</a:t>
-                      </a:r>
-                    </a:p>
-                  </a:txBody>
-                  <a:tcPr marL="73152" marR="73152" marT="36576" marB="36576">
-                    <a:solidFill>
-                      <a:srgbClr val="FCFCFB"/>
-                    </a:solidFill>
-                  </a:tcPr>
-                </a:tc>
-                <a:tc>
-                  <a:txBody>
-                    <a:bodyPr/>
-                    <a:lstStyle/>
-                    <a:p>
-                      <a:pPr>
-                        <a:lnSpc>
-                          <a:spcPct val="115000"/>
-                        </a:lnSpc>
-                      </a:pPr>
-                      <a:r>
-                        <a:rPr sz="1300" b="0">
-                          <a:solidFill>
-                            <a:srgbClr val="16181A"/>
-                          </a:solidFill>
-                          <a:latin typeface="Arial"/>
-                        </a:rPr>
-                        <a:t>Notebook vector editor and persistence</a:t>
-                      </a:r>
-                    </a:p>
-                  </a:txBody>
-                  <a:tcPr marL="73152" marR="73152" marT="36576" marB="36576">
-                    <a:solidFill>
-                      <a:srgbClr val="FCFCFB"/>
-                    </a:solidFill>
-                  </a:tcPr>
-                </a:tc>
-                <a:tc>
-                  <a:txBody>
-                    <a:bodyPr/>
-                    <a:lstStyle/>
-                    <a:p>
-                      <a:pPr>
-                        <a:lnSpc>
-                          <a:spcPct val="115000"/>
-                        </a:lnSpc>
-                      </a:pPr>
-                      <a:r>
-                        <a:rPr sz="1300" b="0">
-                          <a:solidFill>
-                            <a:srgbClr val="16181A"/>
-                          </a:solidFill>
-                          <a:latin typeface="Arial"/>
-                        </a:rPr>
-                        <a:t>Planned</a:t>
-                      </a:r>
-                    </a:p>
-                  </a:txBody>
-                  <a:tcPr marL="73152" marR="73152" marT="36576" marB="36576">
-                    <a:solidFill>
-                      <a:srgbClr val="FCFCFB"/>
-                    </a:solidFill>
-                  </a:tcPr>
-                </a:tc>
-              </a:tr>
-              <a:tr h="384048">
-                <a:tc>
-                  <a:txBody>
-                    <a:bodyPr/>
-                    <a:lstStyle/>
-                    <a:p>
-                      <a:pPr>
-                        <a:lnSpc>
-                          <a:spcPct val="115000"/>
-                        </a:lnSpc>
-                      </a:pPr>
-                      <a:r>
-                        <a:rPr sz="1300" b="0">
-                          <a:solidFill>
-                            <a:srgbClr val="16181A"/>
-                          </a:solidFill>
-                          <a:latin typeface="Arial"/>
-                        </a:rPr>
-                        <a:t>M5</a:t>
-                      </a:r>
-                    </a:p>
-                  </a:txBody>
-                  <a:tcPr marL="73152" marR="73152" marT="36576" marB="36576">
-                    <a:solidFill>
-                      <a:srgbClr val="FCFCFB"/>
-                    </a:solidFill>
-                  </a:tcPr>
-                </a:tc>
-                <a:tc>
-                  <a:txBody>
-                    <a:bodyPr/>
-                    <a:lstStyle/>
-                    <a:p>
-                      <a:pPr>
-                        <a:lnSpc>
-                          <a:spcPct val="115000"/>
-                        </a:lnSpc>
-                      </a:pPr>
-                      <a:r>
-                        <a:rPr sz="1300" b="0">
-                          <a:solidFill>
-                            <a:srgbClr val="16181A"/>
-                          </a:solidFill>
-                          <a:latin typeface="Arial"/>
-                        </a:rPr>
-                        <a:t>Entity polish, atmosphere, audio, human playtest</a:t>
-                      </a:r>
-                    </a:p>
-                  </a:txBody>
-                  <a:tcPr marL="73152" marR="73152" marT="36576" marB="36576">
-                    <a:solidFill>
-                      <a:srgbClr val="FCFCFB"/>
-                    </a:solidFill>
-                  </a:tcPr>
-                </a:tc>
-                <a:tc>
-                  <a:txBody>
-                    <a:bodyPr/>
-                    <a:lstStyle/>
-                    <a:p>
-                      <a:pPr>
-                        <a:lnSpc>
-                          <a:spcPct val="115000"/>
-                        </a:lnSpc>
-                      </a:pPr>
-                      <a:r>
-                        <a:rPr sz="1300" b="0">
-                          <a:solidFill>
-                            <a:srgbClr val="16181A"/>
-                          </a:solidFill>
-                          <a:latin typeface="Arial"/>
-                        </a:rPr>
-                        <a:t>Planned</a:t>
-                      </a:r>
-                    </a:p>
-                  </a:txBody>
-                  <a:tcPr marL="73152" marR="73152" marT="36576" marB="36576">
-                    <a:solidFill>
-                      <a:srgbClr val="FCFCFB"/>
-                    </a:solidFill>
-                  </a:tcPr>
-                </a:tc>
-              </a:tr>
-            </a:tbl>
-          </a:graphicData>
-        </a:graphic>
-      </p:graphicFrame>
-      <p:sp>
-        <p:nvSpPr>
-          <p:cNvPr id="6" name="TextBox 5"/>
-          <p:cNvSpPr txBox="1"/>
-          <p:nvPr/>
-        </p:nvSpPr>
-        <p:spPr>
-          <a:xfrm>
-            <a:off x="658368" y="4663440"/>
-            <a:ext cx="10881360" cy="1097280"/>
-          </a:xfrm>
-          <a:prstGeom prst="rect">
-            <a:avLst/>
-          </a:prstGeom>
-          <a:noFill/>
-        </p:spPr>
-        <p:txBody>
-          <a:bodyPr wrap="square" lIns="0" rIns="0" tIns="0" bIns="0">
-            <a:spAutoFit/>
-          </a:bodyPr>
-          <a:lstStyle/>
-          <a:p>
-            <a:pPr algn="l">
-              <a:lnSpc>
-                <a:spcPct val="135000"/>
-              </a:lnSpc>
-              <a:spcAft>
-                <a:spcPts val="600"/>
-              </a:spcAft>
-            </a:pPr>
-            <a:r>
-              <a:rPr sz="1300" b="0">
-                <a:solidFill>
-                  <a:srgbClr val="6B7178"/>
-                </a:solidFill>
-                <a:latin typeface="Arial"/>
-              </a:rPr>
-              <a:t>Art direction for M3 is settled: a low-poly modular brutalist kit instantiated from the room graph, near-total darkness with a flashlight, heavy fog, and a retro post-processing pass — chosen because it minimises modelling cost while staying coherent. Modularity is not a style choice: rooms are rotated, added and removed at runtime, so they must be prefab-instantiated regardless.</a:t>
-            </a:r>
-          </a:p>
-        </p:txBody>
-      </p:sp>
-    </p:spTree>
-  </p:cSld>
-  <p:clrMapOvr>
-    <a:masterClrMapping/>
-  </p:clrMapOvr>
-</p:sld>
-</file>
-
-<file path=ppt/slides/slide21.xml><?xml version="1.0" encoding="utf-8"?>
-<p:sld xmlns:a="http://schemas.openxmlformats.org/drawingml/2006/main" xmlns:p="http://schemas.openxmlformats.org/presentationml/2006/main" xmlns:r="http://schemas.openxmlformats.org/officeDocument/2006/relationships">
-  <p:cSld>
-    <p:bg>
-      <p:bgPr>
-        <a:solidFill>
-          <a:srgbClr val="FCFCFB"/>
-        </a:solidFill>
-        <a:effectLst/>
-      </p:bgPr>
-    </p:bg>
-    <p:spTree>
-      <p:nvGrpSpPr>
-        <p:cNvPr id="1" name=""/>
-        <p:cNvGrpSpPr/>
-        <p:nvPr/>
-      </p:nvGrpSpPr>
-      <p:grpSpPr/>
-      <p:sp>
-        <p:nvSpPr>
-          <p:cNvPr id="2" name="TextBox 1"/>
-          <p:cNvSpPr txBox="1"/>
-          <p:nvPr/>
-        </p:nvSpPr>
-        <p:spPr>
-          <a:xfrm>
-            <a:off x="658368" y="420624"/>
-            <a:ext cx="10881360" cy="274320"/>
-          </a:xfrm>
-          <a:prstGeom prst="rect">
-            <a:avLst/>
-          </a:prstGeom>
-          <a:noFill/>
-        </p:spPr>
-        <p:txBody>
-          <a:bodyPr wrap="square" lIns="0" rIns="0" tIns="0" bIns="0">
-            <a:spAutoFit/>
-          </a:bodyPr>
-          <a:lstStyle/>
-          <a:p>
-            <a:pPr algn="l">
-              <a:lnSpc>
-                <a:spcPct val="125000"/>
-              </a:lnSpc>
-              <a:spcAft>
-                <a:spcPts val="600"/>
-              </a:spcAft>
-            </a:pPr>
-            <a:r>
-              <a:rPr sz="1050" b="1">
-                <a:solidFill>
-                  <a:srgbClr val="2A78D6"/>
-                </a:solidFill>
-                <a:latin typeface="Arial"/>
-              </a:rPr>
-              <a:t>REFERENCES</a:t>
-            </a:r>
-          </a:p>
-        </p:txBody>
-      </p:sp>
-      <p:sp>
-        <p:nvSpPr>
-          <p:cNvPr id="3" name="TextBox 2"/>
-          <p:cNvSpPr txBox="1"/>
-          <p:nvPr/>
-        </p:nvSpPr>
-        <p:spPr>
-          <a:xfrm>
-            <a:off x="658368" y="749808"/>
-            <a:ext cx="10881360" cy="822960"/>
-          </a:xfrm>
-          <a:prstGeom prst="rect">
-            <a:avLst/>
-          </a:prstGeom>
-          <a:noFill/>
-        </p:spPr>
-        <p:txBody>
-          <a:bodyPr wrap="square" lIns="0" rIns="0" tIns="0" bIns="0">
-            <a:spAutoFit/>
-          </a:bodyPr>
-          <a:lstStyle/>
-          <a:p>
-            <a:pPr algn="l">
-              <a:lnSpc>
-                <a:spcPct val="125000"/>
-              </a:lnSpc>
-              <a:spcAft>
-                <a:spcPts val="600"/>
-              </a:spcAft>
-            </a:pPr>
-            <a:r>
-              <a:rPr sz="2800" b="1">
-                <a:solidFill>
-                  <a:srgbClr val="16181A"/>
-                </a:solidFill>
-                <a:latin typeface="Arial"/>
-              </a:rPr>
-              <a:t>1 of 2</a:t>
-            </a:r>
-          </a:p>
-        </p:txBody>
-      </p:sp>
-      <p:sp>
-        <p:nvSpPr>
-          <p:cNvPr id="4" name="Rectangle 3"/>
-          <p:cNvSpPr/>
-          <p:nvPr/>
-        </p:nvSpPr>
-        <p:spPr>
-          <a:xfrm>
-            <a:off x="658368" y="1481328"/>
-            <a:ext cx="10881360" cy="18288"/>
-          </a:xfrm>
-          <a:prstGeom prst="rect">
-            <a:avLst/>
-          </a:prstGeom>
-          <a:solidFill>
-            <a:srgbClr val="D8DCE0"/>
-          </a:solidFill>
-          <a:ln>
-            <a:noFill/>
-          </a:ln>
-          <a:effectLst/>
-        </p:spPr>
-        <p:style>
-          <a:lnRef idx="1">
-            <a:schemeClr val="accent1"/>
-          </a:lnRef>
-          <a:fillRef idx="3">
-            <a:schemeClr val="accent1"/>
-          </a:fillRef>
-          <a:effectRef idx="2">
-            <a:schemeClr val="accent1"/>
-          </a:effectRef>
-          <a:fontRef idx="minor">
-            <a:schemeClr val="lt1"/>
-          </a:fontRef>
-        </p:style>
-        <p:txBody>
-          <a:bodyPr rtlCol="0" anchor="ctr"/>
-          <a:lstStyle/>
-          <a:p>
-            <a:pPr algn="ctr"/>
-          </a:p>
-        </p:txBody>
-      </p:sp>
       <p:sp>
         <p:nvSpPr>
           <p:cNvPr id="5" name="TextBox 4"/>
@@ -9788,7 +11618,7 @@
 </p:sld>
 </file>
 
-<file path=ppt/slides/slide22.xml><?xml version="1.0" encoding="utf-8"?>
+<file path=ppt/slides/slide25.xml><?xml version="1.0" encoding="utf-8"?>
 <p:sld xmlns:a="http://schemas.openxmlformats.org/drawingml/2006/main" xmlns:p="http://schemas.openxmlformats.org/presentationml/2006/main" xmlns:r="http://schemas.openxmlformats.org/officeDocument/2006/relationships">
   <p:cSld>
     <p:bg>
@@ -11283,7 +13113,7 @@
         </p:nvGraphicFramePr>
         <p:xfrm>
           <a:off x="658368" y="2697480"/>
-          <a:ext cx="10881360" cy="3072384"/>
+          <a:ext cx="10881360" cy="3456432"/>
         </p:xfrm>
         <a:graphic>
           <a:graphicData uri="http://schemas.openxmlformats.org/drawingml/2006/table">
@@ -11839,7 +13669,7 @@
                           </a:solidFill>
                           <a:latin typeface="Arial"/>
                         </a:rPr>
-                        <a:t>Make the model legible to the player in-game</a:t>
+                        <a:t>Implement and measure all four Director counter-moves</a:t>
                       </a:r>
                     </a:p>
                   </a:txBody>
@@ -11866,7 +13696,7 @@
                           </a:solidFill>
                           <a:latin typeface="Arial"/>
                         </a:rPr>
-                        <a:t>Demo built</a:t>
+                        <a:t>Done</a:t>
                       </a:r>
                     </a:p>
                   </a:txBody>
@@ -11896,6 +13726,89 @@
                           <a:latin typeface="Arial"/>
                         </a:rPr>
                         <a:t>O7</a:t>
+                      </a:r>
+                    </a:p>
+                  </a:txBody>
+                  <a:tcPr marL="73152" marR="73152" marT="36576" marB="36576">
+                    <a:solidFill>
+                      <a:srgbClr val="FCFCFB"/>
+                    </a:solidFill>
+                  </a:tcPr>
+                </a:tc>
+                <a:tc>
+                  <a:txBody>
+                    <a:bodyPr/>
+                    <a:lstStyle/>
+                    <a:p>
+                      <a:pPr>
+                        <a:lnSpc>
+                          <a:spcPct val="115000"/>
+                        </a:lnSpc>
+                      </a:pPr>
+                      <a:r>
+                        <a:rPr sz="1250" b="0">
+                          <a:solidFill>
+                            <a:srgbClr val="16181A"/>
+                          </a:solidFill>
+                          <a:latin typeface="Arial"/>
+                        </a:rPr>
+                        <a:t>Make the model legible to the player in-game</a:t>
+                      </a:r>
+                    </a:p>
+                  </a:txBody>
+                  <a:tcPr marL="73152" marR="73152" marT="36576" marB="36576">
+                    <a:solidFill>
+                      <a:srgbClr val="FCFCFB"/>
+                    </a:solidFill>
+                  </a:tcPr>
+                </a:tc>
+                <a:tc>
+                  <a:txBody>
+                    <a:bodyPr/>
+                    <a:lstStyle/>
+                    <a:p>
+                      <a:pPr>
+                        <a:lnSpc>
+                          <a:spcPct val="115000"/>
+                        </a:lnSpc>
+                      </a:pPr>
+                      <a:r>
+                        <a:rPr sz="1250" b="0">
+                          <a:solidFill>
+                            <a:srgbClr val="16181A"/>
+                          </a:solidFill>
+                          <a:latin typeface="Arial"/>
+                        </a:rPr>
+                        <a:t>Demo built</a:t>
+                      </a:r>
+                    </a:p>
+                  </a:txBody>
+                  <a:tcPr marL="73152" marR="73152" marT="36576" marB="36576">
+                    <a:solidFill>
+                      <a:srgbClr val="FCFCFB"/>
+                    </a:solidFill>
+                  </a:tcPr>
+                </a:tc>
+              </a:tr>
+              <a:tr h="384048">
+                <a:tc>
+                  <a:txBody>
+                    <a:bodyPr/>
+                    <a:lstStyle/>
+                    <a:p>
+                      <a:pPr>
+                        <a:lnSpc>
+                          <a:spcPct val="115000"/>
+                        </a:lnSpc>
+                      </a:pPr>
+                      <a:r>
+                        <a:rPr sz="1250" b="0">
+                          <a:solidFill>
+                            <a:srgbClr val="16181A"/>
+                          </a:solidFill>
+                          <a:latin typeface="Arial"/>
+                        </a:rPr>
+                        <a:t>O8</a:t>
                       </a:r>
                     </a:p>
                   </a:txBody>

</xml_diff>

<commit_message>
Fix naive interception and measure how prediction scales with facility size
The pursuit director aimed at the room the player would enter next, but the entity
also moves one room per step, so that room was usually unreachable in time and it
chased perpetually a step behind. InterceptDirector rolls the model forward five
steps and picks the earliest predicted room it can reach no later than the player,
weighted by the probability they stay on that path.

- E4: 364 -> 390 captures/1000 from the same model, used properly
- E7 (new): the advantage over hub-camping widens from 1.30x at 10 rooms to 1.57x
  at 32. Hub-camping was only competitive because the map was small, so the
  ten-room result understated the value of prediction
- New scaling figure and slide; deck now 26 slides
- Report sections 5.3-5.8 renumbered; all numbers regenerated from metrics.json
</commit_message>
<xml_diff>
--- a/docs/PARITY-review-deck.pptx
+++ b/docs/PARITY-review-deck.pptx
@@ -30,6 +30,7 @@
     <p:sldId id="278" r:id="rId29"/>
     <p:sldId id="279" r:id="rId30"/>
     <p:sldId id="280" r:id="rId31"/>
+    <p:sldId id="281" r:id="rId32"/>
   </p:sldIdLst>
   <p:sldSz cx="12191695" cy="6858000" type="screen4x3"/>
   <p:notesSz cx="6858000" cy="9144000"/>
@@ -4716,7 +4717,7 @@
                           </a:solidFill>
                           <a:latin typeface="Arial"/>
                         </a:rPr>
-                        <a:t>High confidence on a specific room — move to meet the player there</a:t>
+                        <a:t>Rolls the model forward; meets the player where they will be</a:t>
                       </a:r>
                     </a:p>
                   </a:txBody>
@@ -4743,7 +4744,7 @@
                           </a:solidFill>
                           <a:latin typeface="Arial"/>
                         </a:rPr>
-                        <a:t>Measured (§14, 16)</a:t>
+                        <a:t>Measured (§16, 17)</a:t>
                       </a:r>
                     </a:p>
                   </a:txBody>
@@ -4826,7 +4827,7 @@
                           </a:solidFill>
                           <a:latin typeface="Arial"/>
                         </a:rPr>
-                        <a:t>Measured (§17)</a:t>
+                        <a:t>Measured (§18)</a:t>
                       </a:r>
                     </a:p>
                   </a:txBody>
@@ -4909,7 +4910,7 @@
                           </a:solidFill>
                           <a:latin typeface="Arial"/>
                         </a:rPr>
-                        <a:t>Measured (§17)</a:t>
+                        <a:t>Measured (§18)</a:t>
                       </a:r>
                     </a:p>
                   </a:txBody>
@@ -4992,7 +4993,7 @@
                           </a:solidFill>
                           <a:latin typeface="Arial"/>
                         </a:rPr>
-                        <a:t>Measured (§18)</a:t>
+                        <a:t>Measured (§19)</a:t>
                       </a:r>
                     </a:p>
                   </a:txBody>
@@ -7576,8 +7577,8 @@
         </p:blipFill>
         <p:spPr>
           <a:xfrm>
-            <a:off x="1709928" y="1783080"/>
-            <a:ext cx="8778240" cy="3853861"/>
+            <a:off x="2167128" y="1719072"/>
+            <a:ext cx="7863840" cy="3836020"/>
           </a:xfrm>
           <a:prstGeom prst="rect">
             <a:avLst/>
@@ -7592,8 +7593,8 @@
         </p:nvSpPr>
         <p:spPr>
           <a:xfrm>
-            <a:off x="658368" y="5870448"/>
-            <a:ext cx="10881360" cy="777240"/>
+            <a:off x="658368" y="5715000"/>
+            <a:ext cx="10881360" cy="914400"/>
           </a:xfrm>
           <a:prstGeom prst="rect">
             <a:avLst/>
@@ -7615,13 +7616,13 @@
               </a:spcAft>
             </a:pPr>
             <a:r>
-              <a:rPr sz="1300" b="0">
+              <a:rPr sz="1250" b="0">
                 <a:solidFill>
                   <a:srgbClr val="6B7178"/>
                 </a:solidFill>
                 <a:latin typeface="Arial"/>
               </a:rPr>
-              <a:t>The hub-camping baseline is included deliberately: a model that cannot beat 'sit in the busiest room' has not earned its complexity. The proposed director achieves 3.7× the control and 1.2× the strongest non-learning heuristic.</a:t>
+              <a:t>A one-step director aims at the room you enter next — but the entity moves one room per step too, so it chases a step behind forever. The interceptor rolls the model forward five steps and picks the earliest room it can reach no later than you. Same model, used properly: 3.9× the control, 1.3× hub-camping.</a:t>
             </a:r>
           </a:p>
         </p:txBody>
@@ -7689,7 +7690,7 @@
                 </a:solidFill>
                 <a:latin typeface="Arial"/>
               </a:rPr>
-              <a:t>17 · RESULTS — DO THE WORLD EDITS MATTER?</a:t>
+              <a:t>17 · RESULTS — DOES THE ADVANTAGE HOLD AT SCALE?</a:t>
             </a:r>
           </a:p>
         </p:txBody>
@@ -7731,7 +7732,7 @@
                 </a:solidFill>
                 <a:latin typeface="Arial"/>
               </a:rPr>
-              <a:t>Interception is only one of four counter-moves</a:t>
+              <a:t>Hub-camping only looks good on a small map</a:t>
             </a:r>
           </a:p>
         </p:txBody>
@@ -7782,7 +7783,7 @@
       </p:sp>
       <p:pic>
         <p:nvPicPr>
-          <p:cNvPr id="5" name="Picture 4" descr="fig_disruption.png"/>
+          <p:cNvPr id="5" name="Picture 4" descr="fig_scaling.png"/>
           <p:cNvPicPr>
             <a:picLocks noChangeAspect="1"/>
           </p:cNvPicPr>
@@ -7796,8 +7797,8 @@
         </p:blipFill>
         <p:spPr>
           <a:xfrm>
-            <a:off x="2286000" y="1737360"/>
-            <a:ext cx="7680960" cy="3653140"/>
+            <a:off x="2286000" y="1691640"/>
+            <a:ext cx="7680960" cy="4027820"/>
           </a:xfrm>
           <a:prstGeom prst="rect">
             <a:avLst/>
@@ -7812,8 +7813,8 @@
         </p:nvSpPr>
         <p:spPr>
           <a:xfrm>
-            <a:off x="658368" y="5532120"/>
-            <a:ext cx="10881360" cy="1005840"/>
+            <a:off x="658368" y="5623560"/>
+            <a:ext cx="10881360" cy="914400"/>
           </a:xfrm>
           <a:prstGeom prst="rect">
             <a:avLst/>
@@ -7835,13 +7836,13 @@
               </a:spcAft>
             </a:pPr>
             <a:r>
-              <a:rPr sz="1300" b="0">
+              <a:rPr sz="1250" b="0">
                 <a:solidFill>
                   <a:srgbClr val="6B7178"/>
                 </a:solidFill>
                 <a:latin typeface="Arial"/>
               </a:rPr>
-              <a:t>The entity is removed entirely here, isolating topology mutation. Sealing and rewiring ahead of the player raises the cost of completing an objective by 60% (15.7 to 25.2 moves per lap). Every one of the 350 rewires and 55 seals passed the reachability check — no run was ever soft-locked.</a:t>
+              <a:t>On 10 rooms with one dominant junction the player has nowhere else to go, so a naive heuristic looks competitive for reasons unrelated to intelligence. As the facility grows, hub-camping decays fastest and the interceptor's advantage widens from 1.30× to 1.57×. The small-facility result understates the value of prediction.</a:t>
             </a:r>
           </a:p>
         </p:txBody>
@@ -8483,7 +8484,7 @@
                           </a:solidFill>
                           <a:latin typeface="Arial"/>
                         </a:rPr>
-                        <a:t>Sections 14–21</a:t>
+                        <a:t>Sections 14–22</a:t>
                       </a:r>
                     </a:p>
                   </a:txBody>
@@ -8510,7 +8511,7 @@
                           </a:solidFill>
                           <a:latin typeface="Arial"/>
                         </a:rPr>
-                        <a:t>Six experiments, 9 invariants, a live demo</a:t>
+                        <a:t>Seven experiments, 9 invariants, a live demo</a:t>
                       </a:r>
                     </a:p>
                   </a:txBody>
@@ -8588,7 +8589,227 @@
                 </a:solidFill>
                 <a:latin typeface="Arial"/>
               </a:rPr>
-              <a:t>18 · RESULTS — IS THE SABOTAGE AIMED?</a:t>
+              <a:t>18 · RESULTS — DO THE WORLD EDITS MATTER?</a:t>
+            </a:r>
+          </a:p>
+        </p:txBody>
+      </p:sp>
+      <p:sp>
+        <p:nvSpPr>
+          <p:cNvPr id="3" name="TextBox 2"/>
+          <p:cNvSpPr txBox="1"/>
+          <p:nvPr/>
+        </p:nvSpPr>
+        <p:spPr>
+          <a:xfrm>
+            <a:off x="658368" y="749808"/>
+            <a:ext cx="10881360" cy="822960"/>
+          </a:xfrm>
+          <a:prstGeom prst="rect">
+            <a:avLst/>
+          </a:prstGeom>
+          <a:noFill/>
+        </p:spPr>
+        <p:txBody>
+          <a:bodyPr wrap="square" lIns="0" rIns="0" tIns="0" bIns="0">
+            <a:spAutoFit/>
+          </a:bodyPr>
+          <a:lstStyle/>
+          <a:p>
+            <a:pPr algn="l">
+              <a:lnSpc>
+                <a:spcPct val="125000"/>
+              </a:lnSpc>
+              <a:spcAft>
+                <a:spcPts val="600"/>
+              </a:spcAft>
+            </a:pPr>
+            <a:r>
+              <a:rPr sz="2800" b="1">
+                <a:solidFill>
+                  <a:srgbClr val="16181A"/>
+                </a:solidFill>
+                <a:latin typeface="Arial"/>
+              </a:rPr>
+              <a:t>Interception is only one of four counter-moves</a:t>
+            </a:r>
+          </a:p>
+        </p:txBody>
+      </p:sp>
+      <p:sp>
+        <p:nvSpPr>
+          <p:cNvPr id="4" name="Rectangle 3"/>
+          <p:cNvSpPr/>
+          <p:nvPr/>
+        </p:nvSpPr>
+        <p:spPr>
+          <a:xfrm>
+            <a:off x="658368" y="1481328"/>
+            <a:ext cx="10881360" cy="18288"/>
+          </a:xfrm>
+          <a:prstGeom prst="rect">
+            <a:avLst/>
+          </a:prstGeom>
+          <a:solidFill>
+            <a:srgbClr val="D8DCE0"/>
+          </a:solidFill>
+          <a:ln>
+            <a:noFill/>
+          </a:ln>
+          <a:effectLst/>
+        </p:spPr>
+        <p:style>
+          <a:lnRef idx="1">
+            <a:schemeClr val="accent1"/>
+          </a:lnRef>
+          <a:fillRef idx="3">
+            <a:schemeClr val="accent1"/>
+          </a:fillRef>
+          <a:effectRef idx="2">
+            <a:schemeClr val="accent1"/>
+          </a:effectRef>
+          <a:fontRef idx="minor">
+            <a:schemeClr val="lt1"/>
+          </a:fontRef>
+        </p:style>
+        <p:txBody>
+          <a:bodyPr rtlCol="0" anchor="ctr"/>
+          <a:lstStyle/>
+          <a:p>
+            <a:pPr algn="ctr"/>
+          </a:p>
+        </p:txBody>
+      </p:sp>
+      <p:pic>
+        <p:nvPicPr>
+          <p:cNvPr id="5" name="Picture 4" descr="fig_disruption.png"/>
+          <p:cNvPicPr>
+            <a:picLocks noChangeAspect="1"/>
+          </p:cNvPicPr>
+          <p:nvPr/>
+        </p:nvPicPr>
+        <p:blipFill>
+          <a:blip r:embed="rId2"/>
+          <a:stretch>
+            <a:fillRect/>
+          </a:stretch>
+        </p:blipFill>
+        <p:spPr>
+          <a:xfrm>
+            <a:off x="2286000" y="1737360"/>
+            <a:ext cx="7680960" cy="3653140"/>
+          </a:xfrm>
+          <a:prstGeom prst="rect">
+            <a:avLst/>
+          </a:prstGeom>
+        </p:spPr>
+      </p:pic>
+      <p:sp>
+        <p:nvSpPr>
+          <p:cNvPr id="6" name="TextBox 5"/>
+          <p:cNvSpPr txBox="1"/>
+          <p:nvPr/>
+        </p:nvSpPr>
+        <p:spPr>
+          <a:xfrm>
+            <a:off x="658368" y="5532120"/>
+            <a:ext cx="10881360" cy="1005840"/>
+          </a:xfrm>
+          <a:prstGeom prst="rect">
+            <a:avLst/>
+          </a:prstGeom>
+          <a:noFill/>
+        </p:spPr>
+        <p:txBody>
+          <a:bodyPr wrap="square" lIns="0" rIns="0" tIns="0" bIns="0">
+            <a:spAutoFit/>
+          </a:bodyPr>
+          <a:lstStyle/>
+          <a:p>
+            <a:pPr algn="l">
+              <a:lnSpc>
+                <a:spcPct val="130000"/>
+              </a:lnSpc>
+              <a:spcAft>
+                <a:spcPts val="600"/>
+              </a:spcAft>
+            </a:pPr>
+            <a:r>
+              <a:rPr sz="1300" b="0">
+                <a:solidFill>
+                  <a:srgbClr val="6B7178"/>
+                </a:solidFill>
+                <a:latin typeface="Arial"/>
+              </a:rPr>
+              <a:t>The entity is removed entirely here, isolating topology mutation. Sealing and rewiring ahead of the player raises the cost of completing an objective by 60% (15.7 to 25.2 moves per lap). Every one of the 350 rewires and 55 seals passed the reachability check — no run was ever soft-locked.</a:t>
+            </a:r>
+          </a:p>
+        </p:txBody>
+      </p:sp>
+    </p:spTree>
+  </p:cSld>
+  <p:clrMapOvr>
+    <a:masterClrMapping/>
+  </p:clrMapOvr>
+</p:sld>
+</file>
+
+<file path=ppt/slides/slide21.xml><?xml version="1.0" encoding="utf-8"?>
+<p:sld xmlns:a="http://schemas.openxmlformats.org/drawingml/2006/main" xmlns:p="http://schemas.openxmlformats.org/presentationml/2006/main" xmlns:r="http://schemas.openxmlformats.org/officeDocument/2006/relationships">
+  <p:cSld>
+    <p:bg>
+      <p:bgPr>
+        <a:solidFill>
+          <a:srgbClr val="FCFCFB"/>
+        </a:solidFill>
+        <a:effectLst/>
+      </p:bgPr>
+    </p:bg>
+    <p:spTree>
+      <p:nvGrpSpPr>
+        <p:cNvPr id="1" name=""/>
+        <p:cNvGrpSpPr/>
+        <p:nvPr/>
+      </p:nvGrpSpPr>
+      <p:grpSpPr/>
+      <p:sp>
+        <p:nvSpPr>
+          <p:cNvPr id="2" name="TextBox 1"/>
+          <p:cNvSpPr txBox="1"/>
+          <p:nvPr/>
+        </p:nvSpPr>
+        <p:spPr>
+          <a:xfrm>
+            <a:off x="658368" y="420624"/>
+            <a:ext cx="10881360" cy="274320"/>
+          </a:xfrm>
+          <a:prstGeom prst="rect">
+            <a:avLst/>
+          </a:prstGeom>
+          <a:noFill/>
+        </p:spPr>
+        <p:txBody>
+          <a:bodyPr wrap="square" lIns="0" rIns="0" tIns="0" bIns="0">
+            <a:spAutoFit/>
+          </a:bodyPr>
+          <a:lstStyle/>
+          <a:p>
+            <a:pPr algn="l">
+              <a:lnSpc>
+                <a:spcPct val="125000"/>
+              </a:lnSpc>
+              <a:spcAft>
+                <a:spcPts val="600"/>
+              </a:spcAft>
+            </a:pPr>
+            <a:r>
+              <a:rPr sz="1050" b="1">
+                <a:solidFill>
+                  <a:srgbClr val="2A78D6"/>
+                </a:solidFill>
+                <a:latin typeface="Arial"/>
+              </a:rPr>
+              <a:t>19 · RESULTS — IS THE SABOTAGE AIMED?</a:t>
             </a:r>
           </a:p>
         </p:txBody>
@@ -9194,7 +9415,7 @@
 </p:sld>
 </file>
 
-<file path=ppt/slides/slide21.xml><?xml version="1.0" encoding="utf-8"?>
+<file path=ppt/slides/slide22.xml><?xml version="1.0" encoding="utf-8"?>
 <p:sld xmlns:a="http://schemas.openxmlformats.org/drawingml/2006/main" xmlns:p="http://schemas.openxmlformats.org/presentationml/2006/main" xmlns:r="http://schemas.openxmlformats.org/officeDocument/2006/relationships">
   <p:cSld>
     <p:bg>
@@ -9249,7 +9470,7 @@
                 </a:solidFill>
                 <a:latin typeface="Arial"/>
               </a:rPr>
-              <a:t>19 · VERIFICATION</a:t>
+              <a:t>20 · VERIFICATION</a:t>
             </a:r>
           </a:p>
         </p:txBody>
@@ -9976,7 +10197,7 @@
 </p:sld>
 </file>
 
-<file path=ppt/slides/slide22.xml><?xml version="1.0" encoding="utf-8"?>
+<file path=ppt/slides/slide23.xml><?xml version="1.0" encoding="utf-8"?>
 <p:sld xmlns:a="http://schemas.openxmlformats.org/drawingml/2006/main" xmlns:p="http://schemas.openxmlformats.org/presentationml/2006/main" xmlns:r="http://schemas.openxmlformats.org/officeDocument/2006/relationships">
   <p:cSld>
     <p:bg>
@@ -10031,7 +10252,7 @@
                 </a:solidFill>
                 <a:latin typeface="Arial"/>
               </a:rPr>
-              <a:t>20 · LIVE DEMONSTRATION</a:t>
+              <a:t>21 · LIVE DEMONSTRATION</a:t>
             </a:r>
           </a:p>
         </p:txBody>
@@ -10428,7 +10649,7 @@
 </p:sld>
 </file>
 
-<file path=ppt/slides/slide23.xml><?xml version="1.0" encoding="utf-8"?>
+<file path=ppt/slides/slide24.xml><?xml version="1.0" encoding="utf-8"?>
 <p:sld xmlns:a="http://schemas.openxmlformats.org/drawingml/2006/main" xmlns:p="http://schemas.openxmlformats.org/presentationml/2006/main" xmlns:r="http://schemas.openxmlformats.org/officeDocument/2006/relationships">
   <p:cSld>
     <p:bg>
@@ -10483,7 +10704,7 @@
                 </a:solidFill>
                 <a:latin typeface="Arial"/>
               </a:rPr>
-              <a:t>21 · ROADMAP</a:t>
+              <a:t>22 · ROADMAP</a:t>
             </a:r>
           </a:p>
         </p:txBody>
@@ -11232,7 +11453,7 @@
 </p:sld>
 </file>
 
-<file path=ppt/slides/slide24.xml><?xml version="1.0" encoding="utf-8"?>
+<file path=ppt/slides/slide25.xml><?xml version="1.0" encoding="utf-8"?>
 <p:sld xmlns:a="http://schemas.openxmlformats.org/drawingml/2006/main" xmlns:p="http://schemas.openxmlformats.org/presentationml/2006/main" xmlns:r="http://schemas.openxmlformats.org/officeDocument/2006/relationships">
   <p:cSld>
     <p:bg>
@@ -11618,7 +11839,7 @@
 </p:sld>
 </file>
 
-<file path=ppt/slides/slide25.xml><?xml version="1.0" encoding="utf-8"?>
+<file path=ppt/slides/slide26.xml><?xml version="1.0" encoding="utf-8"?>
 <p:sld xmlns:a="http://schemas.openxmlformats.org/drawingml/2006/main" xmlns:p="http://schemas.openxmlformats.org/presentationml/2006/main" xmlns:r="http://schemas.openxmlformats.org/officeDocument/2006/relationships">
   <p:cSld>
     <p:bg>

</xml_diff>

<commit_message>
Add speaker notes to all 26 slides
Per-slide talking points, including how to handle the two questions a panel is
most likely to push on: the narrow gap over hub-camping at ten rooms, and the
negative sabotage-targeting result.
</commit_message>
<xml_diff>
--- a/docs/PARITY-review-deck.pptx
+++ b/docs/PARITY-review-deck.pptx
@@ -130,6 +130,2176 @@
     </a:lvl9pPr>
   </p:defaultTextStyle>
 </p:presentation>
+</file>
+
+<file path=ppt/notesMasters/notesMaster1.xml><?xml version="1.0" encoding="utf-8"?>
+<p:notesMaster xmlns:a="http://schemas.openxmlformats.org/drawingml/2006/main" xmlns:p="http://schemas.openxmlformats.org/presentationml/2006/main" xmlns:r="http://schemas.openxmlformats.org/officeDocument/2006/relationships">
+  <p:cSld>
+    <p:bg>
+      <p:bgRef idx="1001">
+        <a:schemeClr val="bg1"/>
+      </p:bgRef>
+    </p:bg>
+    <p:spTree>
+      <p:nvGrpSpPr>
+        <p:cNvPr id="1" name=""/>
+        <p:cNvGrpSpPr/>
+        <p:nvPr/>
+      </p:nvGrpSpPr>
+      <p:grpSpPr>
+        <a:xfrm>
+          <a:off x="0" y="0"/>
+          <a:ext cx="0" cy="0"/>
+          <a:chOff x="0" y="0"/>
+          <a:chExt cx="0" cy="0"/>
+        </a:xfrm>
+      </p:grpSpPr>
+      <p:sp>
+        <p:nvSpPr>
+          <p:cNvPr id="2" name="Header Placeholder 1"/>
+          <p:cNvSpPr>
+            <a:spLocks noGrp="1"/>
+          </p:cNvSpPr>
+          <p:nvPr>
+            <p:ph type="hdr" sz="quarter"/>
+          </p:nvPr>
+        </p:nvSpPr>
+        <p:spPr>
+          <a:xfrm>
+            <a:off x="0" y="0"/>
+            <a:ext cx="2971800" cy="457200"/>
+          </a:xfrm>
+          <a:prstGeom prst="rect">
+            <a:avLst/>
+          </a:prstGeom>
+        </p:spPr>
+        <p:txBody>
+          <a:bodyPr vert="horz" lIns="91440" tIns="45720" rIns="91440" bIns="45720" rtlCol="0"/>
+          <a:lstStyle>
+            <a:lvl1pPr algn="l">
+              <a:defRPr sz="1200"/>
+            </a:lvl1pPr>
+          </a:lstStyle>
+          <a:p>
+            <a:endParaRPr lang="en-US"/>
+          </a:p>
+        </p:txBody>
+      </p:sp>
+      <p:sp>
+        <p:nvSpPr>
+          <p:cNvPr id="3" name="Date Placeholder 2"/>
+          <p:cNvSpPr>
+            <a:spLocks noGrp="1"/>
+          </p:cNvSpPr>
+          <p:nvPr>
+            <p:ph type="dt" idx="1"/>
+          </p:nvPr>
+        </p:nvSpPr>
+        <p:spPr>
+          <a:xfrm>
+            <a:off x="3884613" y="0"/>
+            <a:ext cx="2971800" cy="457200"/>
+          </a:xfrm>
+          <a:prstGeom prst="rect">
+            <a:avLst/>
+          </a:prstGeom>
+        </p:spPr>
+        <p:txBody>
+          <a:bodyPr vert="horz" lIns="91440" tIns="45720" rIns="91440" bIns="45720" rtlCol="0"/>
+          <a:lstStyle>
+            <a:lvl1pPr algn="r">
+              <a:defRPr sz="1200"/>
+            </a:lvl1pPr>
+          </a:lstStyle>
+          <a:p>
+            <a:fld id="{0F89C1C7-3DCD-1040-A9CF-14679D8B5DDD}" type="datetimeFigureOut">
+              <a:rPr lang="en-US" smtClean="0"/>
+              <a:t>10/17/16</a:t>
+            </a:fld>
+            <a:endParaRPr lang="en-US"/>
+          </a:p>
+        </p:txBody>
+      </p:sp>
+      <p:sp>
+        <p:nvSpPr>
+          <p:cNvPr id="4" name="Slide Image Placeholder 3"/>
+          <p:cNvSpPr>
+            <a:spLocks noGrp="1" noRot="1" noChangeAspect="1"/>
+          </p:cNvSpPr>
+          <p:nvPr>
+            <p:ph type="sldImg" idx="2"/>
+          </p:nvPr>
+        </p:nvSpPr>
+        <p:spPr>
+          <a:xfrm>
+            <a:off x="1143000" y="685800"/>
+            <a:ext cx="4572000" cy="3429000"/>
+          </a:xfrm>
+          <a:prstGeom prst="rect">
+            <a:avLst/>
+          </a:prstGeom>
+          <a:noFill/>
+          <a:ln w="12700">
+            <a:solidFill>
+              <a:prstClr val="black"/>
+            </a:solidFill>
+          </a:ln>
+        </p:spPr>
+        <p:txBody>
+          <a:bodyPr vert="horz" lIns="91440" tIns="45720" rIns="91440" bIns="45720" rtlCol="0" anchor="ctr"/>
+          <a:lstStyle/>
+          <a:p>
+            <a:endParaRPr lang="en-US"/>
+          </a:p>
+        </p:txBody>
+      </p:sp>
+      <p:sp>
+        <p:nvSpPr>
+          <p:cNvPr id="5" name="Notes Placeholder 4"/>
+          <p:cNvSpPr>
+            <a:spLocks noGrp="1"/>
+          </p:cNvSpPr>
+          <p:nvPr>
+            <p:ph type="body" sz="quarter" idx="3"/>
+          </p:nvPr>
+        </p:nvSpPr>
+        <p:spPr>
+          <a:xfrm>
+            <a:off x="685800" y="4343400"/>
+            <a:ext cx="5486400" cy="4114800"/>
+          </a:xfrm>
+          <a:prstGeom prst="rect">
+            <a:avLst/>
+          </a:prstGeom>
+        </p:spPr>
+        <p:txBody>
+          <a:bodyPr vert="horz" lIns="91440" tIns="45720" rIns="91440" bIns="45720" rtlCol="0"/>
+          <a:lstStyle/>
+          <a:p>
+            <a:pPr lvl="0"/>
+            <a:r>
+              <a:rPr lang="en-US" smtClean="0"/>
+              <a:t>Click to edit Master text styles</a:t>
+            </a:r>
+          </a:p>
+          <a:p>
+            <a:pPr lvl="1"/>
+            <a:r>
+              <a:rPr lang="en-US" smtClean="0"/>
+              <a:t>Second level</a:t>
+            </a:r>
+          </a:p>
+          <a:p>
+            <a:pPr lvl="2"/>
+            <a:r>
+              <a:rPr lang="en-US" smtClean="0"/>
+              <a:t>Third level</a:t>
+            </a:r>
+          </a:p>
+          <a:p>
+            <a:pPr lvl="3"/>
+            <a:r>
+              <a:rPr lang="en-US" smtClean="0"/>
+              <a:t>Fourth level</a:t>
+            </a:r>
+          </a:p>
+          <a:p>
+            <a:pPr lvl="4"/>
+            <a:r>
+              <a:rPr lang="en-US" smtClean="0"/>
+              <a:t>Fifth level</a:t>
+            </a:r>
+            <a:endParaRPr lang="en-US"/>
+          </a:p>
+        </p:txBody>
+      </p:sp>
+      <p:sp>
+        <p:nvSpPr>
+          <p:cNvPr id="6" name="Footer Placeholder 5"/>
+          <p:cNvSpPr>
+            <a:spLocks noGrp="1"/>
+          </p:cNvSpPr>
+          <p:nvPr>
+            <p:ph type="ftr" sz="quarter" idx="4"/>
+          </p:nvPr>
+        </p:nvSpPr>
+        <p:spPr>
+          <a:xfrm>
+            <a:off x="0" y="8685213"/>
+            <a:ext cx="2971800" cy="457200"/>
+          </a:xfrm>
+          <a:prstGeom prst="rect">
+            <a:avLst/>
+          </a:prstGeom>
+        </p:spPr>
+        <p:txBody>
+          <a:bodyPr vert="horz" lIns="91440" tIns="45720" rIns="91440" bIns="45720" rtlCol="0" anchor="b"/>
+          <a:lstStyle>
+            <a:lvl1pPr algn="l">
+              <a:defRPr sz="1200"/>
+            </a:lvl1pPr>
+          </a:lstStyle>
+          <a:p>
+            <a:endParaRPr lang="en-US"/>
+          </a:p>
+        </p:txBody>
+      </p:sp>
+      <p:sp>
+        <p:nvSpPr>
+          <p:cNvPr id="7" name="Slide Number Placeholder 6"/>
+          <p:cNvSpPr>
+            <a:spLocks noGrp="1"/>
+          </p:cNvSpPr>
+          <p:nvPr>
+            <p:ph type="sldNum" sz="quarter" idx="5"/>
+          </p:nvPr>
+        </p:nvSpPr>
+        <p:spPr>
+          <a:xfrm>
+            <a:off x="3884613" y="8685213"/>
+            <a:ext cx="2971800" cy="457200"/>
+          </a:xfrm>
+          <a:prstGeom prst="rect">
+            <a:avLst/>
+          </a:prstGeom>
+        </p:spPr>
+        <p:txBody>
+          <a:bodyPr vert="horz" lIns="91440" tIns="45720" rIns="91440" bIns="45720" rtlCol="0" anchor="b"/>
+          <a:lstStyle>
+            <a:lvl1pPr algn="r">
+              <a:defRPr sz="1200"/>
+            </a:lvl1pPr>
+          </a:lstStyle>
+          <a:p>
+            <a:fld id="{BB5E49A5-4136-284D-997B-48E1D791AD67}" type="slidenum">
+              <a:rPr lang="en-US" smtClean="0"/>
+              <a:t>‹#›</a:t>
+            </a:fld>
+            <a:endParaRPr lang="en-US"/>
+          </a:p>
+        </p:txBody>
+      </p:sp>
+    </p:spTree>
+    <p:extLst>
+      <p:ext uri="{BB962C8B-B14F-4D97-AF65-F5344CB8AC3E}">
+        <p14:creationId xmlns:p14="http://schemas.microsoft.com/office/powerpoint/2010/main" val="2623252185"/>
+      </p:ext>
+    </p:extLst>
+  </p:cSld>
+  <p:clrMap bg1="lt1" tx1="dk1" bg2="lt2" tx2="dk2" accent1="accent1" accent2="accent2" accent3="accent3" accent4="accent4" accent5="accent5" accent6="accent6" hlink="hlink" folHlink="folHlink"/>
+  <p:notesStyle>
+    <a:lvl1pPr marL="0" algn="l" defTabSz="457200" rtl="0" eaLnBrk="1" latinLnBrk="0" hangingPunct="1">
+      <a:defRPr sz="1200" kern="1200">
+        <a:solidFill>
+          <a:schemeClr val="tx1"/>
+        </a:solidFill>
+        <a:latin typeface="+mn-lt"/>
+        <a:ea typeface="+mn-ea"/>
+        <a:cs typeface="+mn-cs"/>
+      </a:defRPr>
+    </a:lvl1pPr>
+    <a:lvl2pPr marL="457200" algn="l" defTabSz="457200" rtl="0" eaLnBrk="1" latinLnBrk="0" hangingPunct="1">
+      <a:defRPr sz="1200" kern="1200">
+        <a:solidFill>
+          <a:schemeClr val="tx1"/>
+        </a:solidFill>
+        <a:latin typeface="+mn-lt"/>
+        <a:ea typeface="+mn-ea"/>
+        <a:cs typeface="+mn-cs"/>
+      </a:defRPr>
+    </a:lvl2pPr>
+    <a:lvl3pPr marL="914400" algn="l" defTabSz="457200" rtl="0" eaLnBrk="1" latinLnBrk="0" hangingPunct="1">
+      <a:defRPr sz="1200" kern="1200">
+        <a:solidFill>
+          <a:schemeClr val="tx1"/>
+        </a:solidFill>
+        <a:latin typeface="+mn-lt"/>
+        <a:ea typeface="+mn-ea"/>
+        <a:cs typeface="+mn-cs"/>
+      </a:defRPr>
+    </a:lvl3pPr>
+    <a:lvl4pPr marL="1371600" algn="l" defTabSz="457200" rtl="0" eaLnBrk="1" latinLnBrk="0" hangingPunct="1">
+      <a:defRPr sz="1200" kern="1200">
+        <a:solidFill>
+          <a:schemeClr val="tx1"/>
+        </a:solidFill>
+        <a:latin typeface="+mn-lt"/>
+        <a:ea typeface="+mn-ea"/>
+        <a:cs typeface="+mn-cs"/>
+      </a:defRPr>
+    </a:lvl4pPr>
+    <a:lvl5pPr marL="1828800" algn="l" defTabSz="457200" rtl="0" eaLnBrk="1" latinLnBrk="0" hangingPunct="1">
+      <a:defRPr sz="1200" kern="1200">
+        <a:solidFill>
+          <a:schemeClr val="tx1"/>
+        </a:solidFill>
+        <a:latin typeface="+mn-lt"/>
+        <a:ea typeface="+mn-ea"/>
+        <a:cs typeface="+mn-cs"/>
+      </a:defRPr>
+    </a:lvl5pPr>
+    <a:lvl6pPr marL="2286000" algn="l" defTabSz="457200" rtl="0" eaLnBrk="1" latinLnBrk="0" hangingPunct="1">
+      <a:defRPr sz="1200" kern="1200">
+        <a:solidFill>
+          <a:schemeClr val="tx1"/>
+        </a:solidFill>
+        <a:latin typeface="+mn-lt"/>
+        <a:ea typeface="+mn-ea"/>
+        <a:cs typeface="+mn-cs"/>
+      </a:defRPr>
+    </a:lvl6pPr>
+    <a:lvl7pPr marL="2743200" algn="l" defTabSz="457200" rtl="0" eaLnBrk="1" latinLnBrk="0" hangingPunct="1">
+      <a:defRPr sz="1200" kern="1200">
+        <a:solidFill>
+          <a:schemeClr val="tx1"/>
+        </a:solidFill>
+        <a:latin typeface="+mn-lt"/>
+        <a:ea typeface="+mn-ea"/>
+        <a:cs typeface="+mn-cs"/>
+      </a:defRPr>
+    </a:lvl7pPr>
+    <a:lvl8pPr marL="3200400" algn="l" defTabSz="457200" rtl="0" eaLnBrk="1" latinLnBrk="0" hangingPunct="1">
+      <a:defRPr sz="1200" kern="1200">
+        <a:solidFill>
+          <a:schemeClr val="tx1"/>
+        </a:solidFill>
+        <a:latin typeface="+mn-lt"/>
+        <a:ea typeface="+mn-ea"/>
+        <a:cs typeface="+mn-cs"/>
+      </a:defRPr>
+    </a:lvl8pPr>
+    <a:lvl9pPr marL="3657600" algn="l" defTabSz="457200" rtl="0" eaLnBrk="1" latinLnBrk="0" hangingPunct="1">
+      <a:defRPr sz="1200" kern="1200">
+        <a:solidFill>
+          <a:schemeClr val="tx1"/>
+        </a:solidFill>
+        <a:latin typeface="+mn-lt"/>
+        <a:ea typeface="+mn-ea"/>
+        <a:cs typeface="+mn-cs"/>
+      </a:defRPr>
+    </a:lvl9pPr>
+  </p:notesStyle>
+</p:notesMaster>
+</file>
+
+<file path=ppt/notesSlides/notesSlide1.xml><?xml version="1.0" encoding="utf-8"?>
+<p:notes xmlns:a="http://schemas.openxmlformats.org/drawingml/2006/main" xmlns:p="http://schemas.openxmlformats.org/presentationml/2006/main" xmlns:r="http://schemas.openxmlformats.org/officeDocument/2006/relationships">
+  <p:cSld>
+    <p:spTree>
+      <p:nvGrpSpPr>
+        <p:cNvPr id="1" name=""/>
+        <p:cNvGrpSpPr/>
+        <p:nvPr/>
+      </p:nvGrpSpPr>
+      <p:grpSpPr>
+        <a:xfrm>
+          <a:off x="0" y="0"/>
+          <a:ext cx="0" cy="0"/>
+          <a:chOff x="0" y="0"/>
+          <a:chExt cx="0" cy="0"/>
+        </a:xfrm>
+      </p:grpSpPr>
+      <p:sp>
+        <p:nvSpPr>
+          <p:cNvPr id="2" name="Slide Image Placeholder 1"/>
+          <p:cNvSpPr>
+            <a:spLocks noGrp="1"/>
+          </p:cNvSpPr>
+          <p:nvPr>
+            <p:ph type="sldImg" idx="2"/>
+          </p:nvPr>
+        </p:nvSpPr>
+        <p:spPr/>
+      </p:sp>
+      <p:sp>
+        <p:nvSpPr>
+          <p:cNvPr id="3" name="Notes Placeholder 2"/>
+          <p:cNvSpPr>
+            <a:spLocks noGrp="1"/>
+          </p:cNvSpPr>
+          <p:nvPr>
+            <p:ph type="body" idx="3" sz="quarter"/>
+          </p:nvPr>
+        </p:nvSpPr>
+        <p:spPr/>
+        <p:txBody>
+          <a:bodyPr/>
+          <a:lstStyle/>
+          <a:p>
+            <a:r>
+              <a:t>Open with the one-sentence pitch: a horror antagonist that builds a live behavioural model of the individual player and acts on its predictions. The model is the project; the game is what makes it legible.</a:t>
+            </a:r>
+          </a:p>
+        </p:txBody>
+      </p:sp>
+      <p:sp>
+        <p:nvSpPr>
+          <p:cNvPr id="4" name="Slide Number Placeholder 3"/>
+          <p:cNvSpPr>
+            <a:spLocks noGrp="1"/>
+          </p:cNvSpPr>
+          <p:nvPr>
+            <p:ph type="sldNum" idx="5" sz="quarter"/>
+          </p:nvPr>
+        </p:nvSpPr>
+        <p:spPr/>
+      </p:sp>
+    </p:spTree>
+  </p:cSld>
+  <p:clrMapOvr>
+    <a:masterClrMapping/>
+  </p:clrMapOvr>
+</p:notes>
+</file>
+
+<file path=ppt/notesSlides/notesSlide10.xml><?xml version="1.0" encoding="utf-8"?>
+<p:notes xmlns:a="http://schemas.openxmlformats.org/drawingml/2006/main" xmlns:p="http://schemas.openxmlformats.org/presentationml/2006/main" xmlns:r="http://schemas.openxmlformats.org/officeDocument/2006/relationships">
+  <p:cSld>
+    <p:spTree>
+      <p:nvGrpSpPr>
+        <p:cNvPr id="1" name=""/>
+        <p:cNvGrpSpPr/>
+        <p:nvPr/>
+      </p:nvGrpSpPr>
+      <p:grpSpPr>
+        <a:xfrm>
+          <a:off x="0" y="0"/>
+          <a:ext cx="0" cy="0"/>
+          <a:chOff x="0" y="0"/>
+          <a:chExt cx="0" cy="0"/>
+        </a:xfrm>
+      </p:grpSpPr>
+      <p:sp>
+        <p:nvSpPr>
+          <p:cNvPr id="2" name="Slide Image Placeholder 1"/>
+          <p:cNvSpPr>
+            <a:spLocks noGrp="1"/>
+          </p:cNvSpPr>
+          <p:nvPr>
+            <p:ph type="sldImg" idx="2"/>
+          </p:nvPr>
+        </p:nvSpPr>
+        <p:spPr/>
+      </p:sp>
+      <p:sp>
+        <p:nvSpPr>
+          <p:cNvPr id="3" name="Notes Placeholder 2"/>
+          <p:cNvSpPr>
+            <a:spLocks noGrp="1"/>
+          </p:cNvSpPr>
+          <p:nvPr>
+            <p:ph type="body" idx="3" sz="quarter"/>
+          </p:nvPr>
+        </p:nvSpPr>
+        <p:spPr/>
+        <p:txBody>
+          <a:bodyPr/>
+          <a:lstStyle/>
+          <a:p>
+            <a:r>
+              <a:t>Explain the order-1 failure concretely: a player running a route passes through the same room repeatedly with different successors each time. Order-1 conditions only on the current room, so it cannot separate those cases.</a:t>
+            </a:r>
+          </a:p>
+        </p:txBody>
+      </p:sp>
+      <p:sp>
+        <p:nvSpPr>
+          <p:cNvPr id="4" name="Slide Number Placeholder 3"/>
+          <p:cNvSpPr>
+            <a:spLocks noGrp="1"/>
+          </p:cNvSpPr>
+          <p:nvPr>
+            <p:ph type="sldNum" idx="5" sz="quarter"/>
+          </p:nvPr>
+        </p:nvSpPr>
+        <p:spPr/>
+      </p:sp>
+    </p:spTree>
+  </p:cSld>
+  <p:clrMapOvr>
+    <a:masterClrMapping/>
+  </p:clrMapOvr>
+</p:notes>
+</file>
+
+<file path=ppt/notesSlides/notesSlide11.xml><?xml version="1.0" encoding="utf-8"?>
+<p:notes xmlns:a="http://schemas.openxmlformats.org/drawingml/2006/main" xmlns:p="http://schemas.openxmlformats.org/presentationml/2006/main" xmlns:r="http://schemas.openxmlformats.org/officeDocument/2006/relationships">
+  <p:cSld>
+    <p:spTree>
+      <p:nvGrpSpPr>
+        <p:cNvPr id="1" name=""/>
+        <p:cNvGrpSpPr/>
+        <p:nvPr/>
+      </p:nvGrpSpPr>
+      <p:grpSpPr>
+        <a:xfrm>
+          <a:off x="0" y="0"/>
+          <a:ext cx="0" cy="0"/>
+          <a:chOff x="0" y="0"/>
+          <a:chExt cx="0" cy="0"/>
+        </a:xfrm>
+      </p:grpSpPr>
+      <p:sp>
+        <p:nvSpPr>
+          <p:cNvPr id="2" name="Slide Image Placeholder 1"/>
+          <p:cNvSpPr>
+            <a:spLocks noGrp="1"/>
+          </p:cNvSpPr>
+          <p:nvPr>
+            <p:ph type="sldImg" idx="2"/>
+          </p:nvPr>
+        </p:nvSpPr>
+        <p:spPr/>
+      </p:sp>
+      <p:sp>
+        <p:nvSpPr>
+          <p:cNvPr id="3" name="Notes Placeholder 2"/>
+          <p:cNvSpPr>
+            <a:spLocks noGrp="1"/>
+          </p:cNvSpPr>
+          <p:nvPr>
+            <p:ph type="body" idx="3" sz="quarter"/>
+          </p:nvPr>
+        </p:nvSpPr>
+        <p:spPr/>
+        <p:txBody>
+          <a:bodyPr/>
+          <a:lstStyle/>
+          <a:p>
+            <a:r>
+              <a:t>Walk the equation slowly. w is a confidence weight: the more often a context has been seen, the more the model trusts it, otherwise it backs off to shorter context. Four properties matter: online, persistent, inspectable, cheap.</a:t>
+            </a:r>
+          </a:p>
+        </p:txBody>
+      </p:sp>
+      <p:sp>
+        <p:nvSpPr>
+          <p:cNvPr id="4" name="Slide Number Placeholder 3"/>
+          <p:cNvSpPr>
+            <a:spLocks noGrp="1"/>
+          </p:cNvSpPr>
+          <p:nvPr>
+            <p:ph type="sldNum" idx="5" sz="quarter"/>
+          </p:nvPr>
+        </p:nvSpPr>
+        <p:spPr/>
+      </p:sp>
+    </p:spTree>
+  </p:cSld>
+  <p:clrMapOvr>
+    <a:masterClrMapping/>
+  </p:clrMapOvr>
+</p:notes>
+</file>
+
+<file path=ppt/notesSlides/notesSlide12.xml><?xml version="1.0" encoding="utf-8"?>
+<p:notes xmlns:a="http://schemas.openxmlformats.org/drawingml/2006/main" xmlns:p="http://schemas.openxmlformats.org/presentationml/2006/main" xmlns:r="http://schemas.openxmlformats.org/officeDocument/2006/relationships">
+  <p:cSld>
+    <p:spTree>
+      <p:nvGrpSpPr>
+        <p:cNvPr id="1" name=""/>
+        <p:cNvGrpSpPr/>
+        <p:nvPr/>
+      </p:nvGrpSpPr>
+      <p:grpSpPr>
+        <a:xfrm>
+          <a:off x="0" y="0"/>
+          <a:ext cx="0" cy="0"/>
+          <a:chOff x="0" y="0"/>
+          <a:chExt cx="0" cy="0"/>
+        </a:xfrm>
+      </p:grpSpPr>
+      <p:sp>
+        <p:nvSpPr>
+          <p:cNvPr id="2" name="Slide Image Placeholder 1"/>
+          <p:cNvSpPr>
+            <a:spLocks noGrp="1"/>
+          </p:cNvSpPr>
+          <p:nvPr>
+            <p:ph type="sldImg" idx="2"/>
+          </p:nvPr>
+        </p:nvSpPr>
+        <p:spPr/>
+      </p:sp>
+      <p:sp>
+        <p:nvSpPr>
+          <p:cNvPr id="3" name="Notes Placeholder 2"/>
+          <p:cNvSpPr>
+            <a:spLocks noGrp="1"/>
+          </p:cNvSpPr>
+          <p:nvPr>
+            <p:ph type="body" idx="3" sz="quarter"/>
+          </p:nvPr>
+        </p:nvSpPr>
+        <p:spPr/>
+        <p:txBody>
+          <a:bodyPr/>
+          <a:lstStyle/>
+          <a:p>
+            <a:r>
+              <a:t>Emphasise the separation. Predictor outputs beliefs; Director decides what to do. That is why the model can be swapped for a GRU later without re-tuning the horror. All four counter-moves are implemented AND measured — say that explicitly.</a:t>
+            </a:r>
+          </a:p>
+        </p:txBody>
+      </p:sp>
+      <p:sp>
+        <p:nvSpPr>
+          <p:cNvPr id="4" name="Slide Number Placeholder 3"/>
+          <p:cNvSpPr>
+            <a:spLocks noGrp="1"/>
+          </p:cNvSpPr>
+          <p:nvPr>
+            <p:ph type="sldNum" idx="5" sz="quarter"/>
+          </p:nvPr>
+        </p:nvSpPr>
+        <p:spPr/>
+      </p:sp>
+    </p:spTree>
+  </p:cSld>
+  <p:clrMapOvr>
+    <a:masterClrMapping/>
+  </p:clrMapOvr>
+</p:notes>
+</file>
+
+<file path=ppt/notesSlides/notesSlide13.xml><?xml version="1.0" encoding="utf-8"?>
+<p:notes xmlns:a="http://schemas.openxmlformats.org/drawingml/2006/main" xmlns:p="http://schemas.openxmlformats.org/presentationml/2006/main" xmlns:r="http://schemas.openxmlformats.org/officeDocument/2006/relationships">
+  <p:cSld>
+    <p:spTree>
+      <p:nvGrpSpPr>
+        <p:cNvPr id="1" name=""/>
+        <p:cNvGrpSpPr/>
+        <p:nvPr/>
+      </p:nvGrpSpPr>
+      <p:grpSpPr>
+        <a:xfrm>
+          <a:off x="0" y="0"/>
+          <a:ext cx="0" cy="0"/>
+          <a:chOff x="0" y="0"/>
+          <a:chExt cx="0" cy="0"/>
+        </a:xfrm>
+      </p:grpSpPr>
+      <p:sp>
+        <p:nvSpPr>
+          <p:cNvPr id="2" name="Slide Image Placeholder 1"/>
+          <p:cNvSpPr>
+            <a:spLocks noGrp="1"/>
+          </p:cNvSpPr>
+          <p:nvPr>
+            <p:ph type="sldImg" idx="2"/>
+          </p:nvPr>
+        </p:nvSpPr>
+        <p:spPr/>
+      </p:sp>
+      <p:sp>
+        <p:nvSpPr>
+          <p:cNvPr id="3" name="Notes Placeholder 2"/>
+          <p:cNvSpPr>
+            <a:spLocks noGrp="1"/>
+          </p:cNvSpPr>
+          <p:nvPr>
+            <p:ph type="body" idx="3" sz="quarter"/>
+          </p:nvPr>
+        </p:nvSpPr>
+        <p:spPr/>
+        <p:txBody>
+          <a:bodyPr/>
+          <a:lstStyle/>
+          <a:p>
+            <a:r>
+              <a:t>The control is the strongest thing in this project. Against a random player the model MUST NOT beat baseline. If it did, something is leaking. Prequential evaluation means every prediction is made before its outcome is seen — no train/test split needed and no leakage possible by construction.</a:t>
+            </a:r>
+          </a:p>
+        </p:txBody>
+      </p:sp>
+      <p:sp>
+        <p:nvSpPr>
+          <p:cNvPr id="4" name="Slide Number Placeholder 3"/>
+          <p:cNvSpPr>
+            <a:spLocks noGrp="1"/>
+          </p:cNvSpPr>
+          <p:nvPr>
+            <p:ph type="sldNum" idx="5" sz="quarter"/>
+          </p:nvPr>
+        </p:nvSpPr>
+        <p:spPr/>
+      </p:sp>
+    </p:spTree>
+  </p:cSld>
+  <p:clrMapOvr>
+    <a:masterClrMapping/>
+  </p:clrMapOvr>
+</p:notes>
+</file>
+
+<file path=ppt/notesSlides/notesSlide14.xml><?xml version="1.0" encoding="utf-8"?>
+<p:notes xmlns:a="http://schemas.openxmlformats.org/drawingml/2006/main" xmlns:p="http://schemas.openxmlformats.org/presentationml/2006/main" xmlns:r="http://schemas.openxmlformats.org/officeDocument/2006/relationships">
+  <p:cSld>
+    <p:spTree>
+      <p:nvGrpSpPr>
+        <p:cNvPr id="1" name=""/>
+        <p:cNvGrpSpPr/>
+        <p:nvPr/>
+      </p:nvGrpSpPr>
+      <p:grpSpPr>
+        <a:xfrm>
+          <a:off x="0" y="0"/>
+          <a:ext cx="0" cy="0"/>
+          <a:chOff x="0" y="0"/>
+          <a:chExt cx="0" cy="0"/>
+        </a:xfrm>
+      </p:grpSpPr>
+      <p:sp>
+        <p:nvSpPr>
+          <p:cNvPr id="2" name="Slide Image Placeholder 1"/>
+          <p:cNvSpPr>
+            <a:spLocks noGrp="1"/>
+          </p:cNvSpPr>
+          <p:nvPr>
+            <p:ph type="sldImg" idx="2"/>
+          </p:nvPr>
+        </p:nvSpPr>
+        <p:spPr/>
+      </p:sp>
+      <p:sp>
+        <p:nvSpPr>
+          <p:cNvPr id="3" name="Notes Placeholder 2"/>
+          <p:cNvSpPr>
+            <a:spLocks noGrp="1"/>
+          </p:cNvSpPr>
+          <p:nvPr>
+            <p:ph type="body" idx="3" sz="quarter"/>
+          </p:nvPr>
+        </p:nvSpPr>
+        <p:spPr/>
+        <p:txBody>
+          <a:bodyPr/>
+          <a:lstStyle/>
+          <a:p>
+            <a:r>
+              <a:t>Eight modules. Two design decisions to defend: Sabotage is the single mutator, so every lie the game tells is logged and replayable; the Notebook sits outside the loop entirely, which is what makes it the player's counter-move rather than decoration.</a:t>
+            </a:r>
+          </a:p>
+        </p:txBody>
+      </p:sp>
+      <p:sp>
+        <p:nvSpPr>
+          <p:cNvPr id="4" name="Slide Number Placeholder 3"/>
+          <p:cNvSpPr>
+            <a:spLocks noGrp="1"/>
+          </p:cNvSpPr>
+          <p:nvPr>
+            <p:ph type="sldNum" idx="5" sz="quarter"/>
+          </p:nvPr>
+        </p:nvSpPr>
+        <p:spPr/>
+      </p:sp>
+    </p:spTree>
+  </p:cSld>
+  <p:clrMapOvr>
+    <a:masterClrMapping/>
+  </p:clrMapOvr>
+</p:notes>
+</file>
+
+<file path=ppt/notesSlides/notesSlide15.xml><?xml version="1.0" encoding="utf-8"?>
+<p:notes xmlns:a="http://schemas.openxmlformats.org/drawingml/2006/main" xmlns:p="http://schemas.openxmlformats.org/presentationml/2006/main" xmlns:r="http://schemas.openxmlformats.org/officeDocument/2006/relationships">
+  <p:cSld>
+    <p:spTree>
+      <p:nvGrpSpPr>
+        <p:cNvPr id="1" name=""/>
+        <p:cNvGrpSpPr/>
+        <p:nvPr/>
+      </p:nvGrpSpPr>
+      <p:grpSpPr>
+        <a:xfrm>
+          <a:off x="0" y="0"/>
+          <a:ext cx="0" cy="0"/>
+          <a:chOff x="0" y="0"/>
+          <a:chExt cx="0" cy="0"/>
+        </a:xfrm>
+      </p:grpSpPr>
+      <p:sp>
+        <p:nvSpPr>
+          <p:cNvPr id="2" name="Slide Image Placeholder 1"/>
+          <p:cNvSpPr>
+            <a:spLocks noGrp="1"/>
+          </p:cNvSpPr>
+          <p:nvPr>
+            <p:ph type="sldImg" idx="2"/>
+          </p:nvPr>
+        </p:nvSpPr>
+        <p:spPr/>
+      </p:sp>
+      <p:sp>
+        <p:nvSpPr>
+          <p:cNvPr id="3" name="Notes Placeholder 2"/>
+          <p:cNvSpPr>
+            <a:spLocks noGrp="1"/>
+          </p:cNvSpPr>
+          <p:nvPr>
+            <p:ph type="body" idx="3" sz="quarter"/>
+          </p:nvPr>
+        </p:nvSpPr>
+        <p:spPr/>
+        <p:txBody>
+          <a:bodyPr/>
+          <a:lstStyle/>
+          <a:p>
+            <a:r>
+              <a:t>Skim this. It is here as evidence of module-level design for the rubric, not to be read out.</a:t>
+            </a:r>
+          </a:p>
+        </p:txBody>
+      </p:sp>
+      <p:sp>
+        <p:nvSpPr>
+          <p:cNvPr id="4" name="Slide Number Placeholder 3"/>
+          <p:cNvSpPr>
+            <a:spLocks noGrp="1"/>
+          </p:cNvSpPr>
+          <p:nvPr>
+            <p:ph type="sldNum" idx="5" sz="quarter"/>
+          </p:nvPr>
+        </p:nvSpPr>
+        <p:spPr/>
+      </p:sp>
+    </p:spTree>
+  </p:cSld>
+  <p:clrMapOvr>
+    <a:masterClrMapping/>
+  </p:clrMapOvr>
+</p:notes>
+</file>
+
+<file path=ppt/notesSlides/notesSlide16.xml><?xml version="1.0" encoding="utf-8"?>
+<p:notes xmlns:a="http://schemas.openxmlformats.org/drawingml/2006/main" xmlns:p="http://schemas.openxmlformats.org/presentationml/2006/main" xmlns:r="http://schemas.openxmlformats.org/officeDocument/2006/relationships">
+  <p:cSld>
+    <p:spTree>
+      <p:nvGrpSpPr>
+        <p:cNvPr id="1" name=""/>
+        <p:cNvGrpSpPr/>
+        <p:nvPr/>
+      </p:nvGrpSpPr>
+      <p:grpSpPr>
+        <a:xfrm>
+          <a:off x="0" y="0"/>
+          <a:ext cx="0" cy="0"/>
+          <a:chOff x="0" y="0"/>
+          <a:chExt cx="0" cy="0"/>
+        </a:xfrm>
+      </p:grpSpPr>
+      <p:sp>
+        <p:nvSpPr>
+          <p:cNvPr id="2" name="Slide Image Placeholder 1"/>
+          <p:cNvSpPr>
+            <a:spLocks noGrp="1"/>
+          </p:cNvSpPr>
+          <p:nvPr>
+            <p:ph type="sldImg" idx="2"/>
+          </p:nvPr>
+        </p:nvSpPr>
+        <p:spPr/>
+      </p:sp>
+      <p:sp>
+        <p:nvSpPr>
+          <p:cNvPr id="3" name="Notes Placeholder 2"/>
+          <p:cNvSpPr>
+            <a:spLocks noGrp="1"/>
+          </p:cNvSpPr>
+          <p:nvPr>
+            <p:ph type="body" idx="3" sz="quarter"/>
+          </p:nvPr>
+        </p:nvSpPr>
+        <p:spPr/>
+        <p:txBody>
+          <a:bodyPr/>
+          <a:lstStyle/>
+          <a:p>
+            <a:r>
+              <a:t>Lead with the control row (the 37/36/37 column), not the 90% one. Explain why the control matters BEFORE showing the win. That framing is what makes the result credible.</a:t>
+            </a:r>
+          </a:p>
+        </p:txBody>
+      </p:sp>
+      <p:sp>
+        <p:nvSpPr>
+          <p:cNvPr id="4" name="Slide Number Placeholder 3"/>
+          <p:cNvSpPr>
+            <a:spLocks noGrp="1"/>
+          </p:cNvSpPr>
+          <p:nvPr>
+            <p:ph type="sldNum" idx="5" sz="quarter"/>
+          </p:nvPr>
+        </p:nvSpPr>
+        <p:spPr/>
+      </p:sp>
+    </p:spTree>
+  </p:cSld>
+  <p:clrMapOvr>
+    <a:masterClrMapping/>
+  </p:clrMapOvr>
+</p:notes>
+</file>
+
+<file path=ppt/notesSlides/notesSlide17.xml><?xml version="1.0" encoding="utf-8"?>
+<p:notes xmlns:a="http://schemas.openxmlformats.org/drawingml/2006/main" xmlns:p="http://schemas.openxmlformats.org/presentationml/2006/main" xmlns:r="http://schemas.openxmlformats.org/officeDocument/2006/relationships">
+  <p:cSld>
+    <p:spTree>
+      <p:nvGrpSpPr>
+        <p:cNvPr id="1" name=""/>
+        <p:cNvGrpSpPr/>
+        <p:nvPr/>
+      </p:nvGrpSpPr>
+      <p:grpSpPr>
+        <a:xfrm>
+          <a:off x="0" y="0"/>
+          <a:ext cx="0" cy="0"/>
+          <a:chOff x="0" y="0"/>
+          <a:chExt cx="0" cy="0"/>
+        </a:xfrm>
+      </p:grpSpPr>
+      <p:sp>
+        <p:nvSpPr>
+          <p:cNvPr id="2" name="Slide Image Placeholder 1"/>
+          <p:cNvSpPr>
+            <a:spLocks noGrp="1"/>
+          </p:cNvSpPr>
+          <p:nvPr>
+            <p:ph type="sldImg" idx="2"/>
+          </p:nvPr>
+        </p:nvSpPr>
+        <p:spPr/>
+      </p:sp>
+      <p:sp>
+        <p:nvSpPr>
+          <p:cNvPr id="3" name="Notes Placeholder 2"/>
+          <p:cNvSpPr>
+            <a:spLocks noGrp="1"/>
+          </p:cNvSpPr>
+          <p:nvPr>
+            <p:ph type="body" idx="3" sz="quarter"/>
+          </p:nvPr>
+        </p:nvSpPr>
+        <p:spPr/>
+        <p:txBody>
+          <a:bodyPr/>
+          <a:lstStyle/>
+          <a:p>
+            <a:r>
+              <a:t>Cold start solved: 44% to ~91% inside about 60 observed moves. This is the answer to 'how can it be interesting against a player it has never seen?'</a:t>
+            </a:r>
+          </a:p>
+        </p:txBody>
+      </p:sp>
+      <p:sp>
+        <p:nvSpPr>
+          <p:cNvPr id="4" name="Slide Number Placeholder 3"/>
+          <p:cNvSpPr>
+            <a:spLocks noGrp="1"/>
+          </p:cNvSpPr>
+          <p:nvPr>
+            <p:ph type="sldNum" idx="5" sz="quarter"/>
+          </p:nvPr>
+        </p:nvSpPr>
+        <p:spPr/>
+      </p:sp>
+    </p:spTree>
+  </p:cSld>
+  <p:clrMapOvr>
+    <a:masterClrMapping/>
+  </p:clrMapOvr>
+</p:notes>
+</file>
+
+<file path=ppt/notesSlides/notesSlide18.xml><?xml version="1.0" encoding="utf-8"?>
+<p:notes xmlns:a="http://schemas.openxmlformats.org/drawingml/2006/main" xmlns:p="http://schemas.openxmlformats.org/presentationml/2006/main" xmlns:r="http://schemas.openxmlformats.org/officeDocument/2006/relationships">
+  <p:cSld>
+    <p:spTree>
+      <p:nvGrpSpPr>
+        <p:cNvPr id="1" name=""/>
+        <p:cNvGrpSpPr/>
+        <p:nvPr/>
+      </p:nvGrpSpPr>
+      <p:grpSpPr>
+        <a:xfrm>
+          <a:off x="0" y="0"/>
+          <a:ext cx="0" cy="0"/>
+          <a:chOff x="0" y="0"/>
+          <a:chExt cx="0" cy="0"/>
+        </a:xfrm>
+      </p:grpSpPr>
+      <p:sp>
+        <p:nvSpPr>
+          <p:cNvPr id="2" name="Slide Image Placeholder 1"/>
+          <p:cNvSpPr>
+            <a:spLocks noGrp="1"/>
+          </p:cNvSpPr>
+          <p:nvPr>
+            <p:ph type="sldImg" idx="2"/>
+          </p:nvPr>
+        </p:nvSpPr>
+        <p:spPr/>
+      </p:sp>
+      <p:sp>
+        <p:nvSpPr>
+          <p:cNvPr id="3" name="Notes Placeholder 2"/>
+          <p:cNvSpPr>
+            <a:spLocks noGrp="1"/>
+          </p:cNvSpPr>
+          <p:nvPr>
+            <p:ph type="body" idx="3" sz="quarter"/>
+          </p:nvPr>
+        </p:nvSpPr>
+        <p:spPr/>
+        <p:txBody>
+          <a:bodyPr/>
+          <a:lstStyle/>
+          <a:p>
+            <a:r>
+              <a:t>Two honest points. First, hub-camping at 305 is a strong baseline and I included it deliberately. Second, the one-step director at 364 is only slightly ahead of order-1 Markov at 350 — I found that, diagnosed it as a targeting bug rather than a model problem, and fixed it. The interceptor is at 390. If a panellist pushes on the narrow gap, agree with them and go straight to the next slide.</a:t>
+            </a:r>
+          </a:p>
+        </p:txBody>
+      </p:sp>
+      <p:sp>
+        <p:nvSpPr>
+          <p:cNvPr id="4" name="Slide Number Placeholder 3"/>
+          <p:cNvSpPr>
+            <a:spLocks noGrp="1"/>
+          </p:cNvSpPr>
+          <p:nvPr>
+            <p:ph type="sldNum" idx="5" sz="quarter"/>
+          </p:nvPr>
+        </p:nvSpPr>
+        <p:spPr/>
+      </p:sp>
+    </p:spTree>
+  </p:cSld>
+  <p:clrMapOvr>
+    <a:masterClrMapping/>
+  </p:clrMapOvr>
+</p:notes>
+</file>
+
+<file path=ppt/notesSlides/notesSlide19.xml><?xml version="1.0" encoding="utf-8"?>
+<p:notes xmlns:a="http://schemas.openxmlformats.org/drawingml/2006/main" xmlns:p="http://schemas.openxmlformats.org/presentationml/2006/main" xmlns:r="http://schemas.openxmlformats.org/officeDocument/2006/relationships">
+  <p:cSld>
+    <p:spTree>
+      <p:nvGrpSpPr>
+        <p:cNvPr id="1" name=""/>
+        <p:cNvGrpSpPr/>
+        <p:nvPr/>
+      </p:nvGrpSpPr>
+      <p:grpSpPr>
+        <a:xfrm>
+          <a:off x="0" y="0"/>
+          <a:ext cx="0" cy="0"/>
+          <a:chOff x="0" y="0"/>
+          <a:chExt cx="0" cy="0"/>
+        </a:xfrm>
+      </p:grpSpPr>
+      <p:sp>
+        <p:nvSpPr>
+          <p:cNvPr id="2" name="Slide Image Placeholder 1"/>
+          <p:cNvSpPr>
+            <a:spLocks noGrp="1"/>
+          </p:cNvSpPr>
+          <p:nvPr>
+            <p:ph type="sldImg" idx="2"/>
+          </p:nvPr>
+        </p:nvSpPr>
+        <p:spPr/>
+      </p:sp>
+      <p:sp>
+        <p:nvSpPr>
+          <p:cNvPr id="3" name="Notes Placeholder 2"/>
+          <p:cNvSpPr>
+            <a:spLocks noGrp="1"/>
+          </p:cNvSpPr>
+          <p:nvPr>
+            <p:ph type="body" idx="3" sz="quarter"/>
+          </p:nvPr>
+        </p:nvSpPr>
+        <p:spPr/>
+        <p:txBody>
+          <a:bodyPr/>
+          <a:lstStyle/>
+          <a:p>
+            <a:r>
+              <a:t>This is the answer to 'hub-camping is nearly as good, so why bother?'. It is only nearly as good on a small map. At 32 rooms the advantage is 1.57x and widening. The ten-room result understates the value of prediction.</a:t>
+            </a:r>
+          </a:p>
+        </p:txBody>
+      </p:sp>
+      <p:sp>
+        <p:nvSpPr>
+          <p:cNvPr id="4" name="Slide Number Placeholder 3"/>
+          <p:cNvSpPr>
+            <a:spLocks noGrp="1"/>
+          </p:cNvSpPr>
+          <p:nvPr>
+            <p:ph type="sldNum" idx="5" sz="quarter"/>
+          </p:nvPr>
+        </p:nvSpPr>
+        <p:spPr/>
+      </p:sp>
+    </p:spTree>
+  </p:cSld>
+  <p:clrMapOvr>
+    <a:masterClrMapping/>
+  </p:clrMapOvr>
+</p:notes>
+</file>
+
+<file path=ppt/notesSlides/notesSlide2.xml><?xml version="1.0" encoding="utf-8"?>
+<p:notes xmlns:a="http://schemas.openxmlformats.org/drawingml/2006/main" xmlns:p="http://schemas.openxmlformats.org/presentationml/2006/main" xmlns:r="http://schemas.openxmlformats.org/officeDocument/2006/relationships">
+  <p:cSld>
+    <p:spTree>
+      <p:nvGrpSpPr>
+        <p:cNvPr id="1" name=""/>
+        <p:cNvGrpSpPr/>
+        <p:nvPr/>
+      </p:nvGrpSpPr>
+      <p:grpSpPr>
+        <a:xfrm>
+          <a:off x="0" y="0"/>
+          <a:ext cx="0" cy="0"/>
+          <a:chOff x="0" y="0"/>
+          <a:chExt cx="0" cy="0"/>
+        </a:xfrm>
+      </p:grpSpPr>
+      <p:sp>
+        <p:nvSpPr>
+          <p:cNvPr id="2" name="Slide Image Placeholder 1"/>
+          <p:cNvSpPr>
+            <a:spLocks noGrp="1"/>
+          </p:cNvSpPr>
+          <p:nvPr>
+            <p:ph type="sldImg" idx="2"/>
+          </p:nvPr>
+        </p:nvSpPr>
+        <p:spPr/>
+      </p:sp>
+      <p:sp>
+        <p:nvSpPr>
+          <p:cNvPr id="3" name="Notes Placeholder 2"/>
+          <p:cNvSpPr>
+            <a:spLocks noGrp="1"/>
+          </p:cNvSpPr>
+          <p:nvPr>
+            <p:ph type="body" idx="3" sz="quarter"/>
+          </p:nvPr>
+        </p:nvSpPr>
+        <p:spPr/>
+        <p:txBody>
+          <a:bodyPr/>
+          <a:lstStyle/>
+          <a:p>
+            <a:r>
+              <a:t>Use this to tell the panel exactly where each rubric item is answered. Don't linger.</a:t>
+            </a:r>
+          </a:p>
+        </p:txBody>
+      </p:sp>
+      <p:sp>
+        <p:nvSpPr>
+          <p:cNvPr id="4" name="Slide Number Placeholder 3"/>
+          <p:cNvSpPr>
+            <a:spLocks noGrp="1"/>
+          </p:cNvSpPr>
+          <p:nvPr>
+            <p:ph type="sldNum" idx="5" sz="quarter"/>
+          </p:nvPr>
+        </p:nvSpPr>
+        <p:spPr/>
+      </p:sp>
+    </p:spTree>
+  </p:cSld>
+  <p:clrMapOvr>
+    <a:masterClrMapping/>
+  </p:clrMapOvr>
+</p:notes>
+</file>
+
+<file path=ppt/notesSlides/notesSlide20.xml><?xml version="1.0" encoding="utf-8"?>
+<p:notes xmlns:a="http://schemas.openxmlformats.org/drawingml/2006/main" xmlns:p="http://schemas.openxmlformats.org/presentationml/2006/main" xmlns:r="http://schemas.openxmlformats.org/officeDocument/2006/relationships">
+  <p:cSld>
+    <p:spTree>
+      <p:nvGrpSpPr>
+        <p:cNvPr id="1" name=""/>
+        <p:cNvGrpSpPr/>
+        <p:nvPr/>
+      </p:nvGrpSpPr>
+      <p:grpSpPr>
+        <a:xfrm>
+          <a:off x="0" y="0"/>
+          <a:ext cx="0" cy="0"/>
+          <a:chOff x="0" y="0"/>
+          <a:chExt cx="0" cy="0"/>
+        </a:xfrm>
+      </p:grpSpPr>
+      <p:sp>
+        <p:nvSpPr>
+          <p:cNvPr id="2" name="Slide Image Placeholder 1"/>
+          <p:cNvSpPr>
+            <a:spLocks noGrp="1"/>
+          </p:cNvSpPr>
+          <p:nvPr>
+            <p:ph type="sldImg" idx="2"/>
+          </p:nvPr>
+        </p:nvSpPr>
+        <p:spPr/>
+      </p:sp>
+      <p:sp>
+        <p:nvSpPr>
+          <p:cNvPr id="3" name="Notes Placeholder 2"/>
+          <p:cNvSpPr>
+            <a:spLocks noGrp="1"/>
+          </p:cNvSpPr>
+          <p:nvPr>
+            <p:ph type="body" idx="3" sz="quarter"/>
+          </p:nvPr>
+        </p:nvSpPr>
+        <p:spPr/>
+        <p:txBody>
+          <a:bodyPr/>
+          <a:lstStyle/>
+          <a:p>
+            <a:r>
+              <a:t>Note the entity is REMOVED here — this isolates world editing from interception. 60% more moves per objective lap, and every mutation passed a reachability check so no run was ever soft-locked.</a:t>
+            </a:r>
+          </a:p>
+        </p:txBody>
+      </p:sp>
+      <p:sp>
+        <p:nvSpPr>
+          <p:cNvPr id="4" name="Slide Number Placeholder 3"/>
+          <p:cNvSpPr>
+            <a:spLocks noGrp="1"/>
+          </p:cNvSpPr>
+          <p:nvPr>
+            <p:ph type="sldNum" idx="5" sz="quarter"/>
+          </p:nvPr>
+        </p:nvSpPr>
+        <p:spPr/>
+      </p:sp>
+    </p:spTree>
+  </p:cSld>
+  <p:clrMapOvr>
+    <a:masterClrMapping/>
+  </p:clrMapOvr>
+</p:notes>
+</file>
+
+<file path=ppt/notesSlides/notesSlide21.xml><?xml version="1.0" encoding="utf-8"?>
+<p:notes xmlns:a="http://schemas.openxmlformats.org/drawingml/2006/main" xmlns:p="http://schemas.openxmlformats.org/presentationml/2006/main" xmlns:r="http://schemas.openxmlformats.org/officeDocument/2006/relationships">
+  <p:cSld>
+    <p:spTree>
+      <p:nvGrpSpPr>
+        <p:cNvPr id="1" name=""/>
+        <p:cNvGrpSpPr/>
+        <p:nvPr/>
+      </p:nvGrpSpPr>
+      <p:grpSpPr>
+        <a:xfrm>
+          <a:off x="0" y="0"/>
+          <a:ext cx="0" cy="0"/>
+          <a:chOff x="0" y="0"/>
+          <a:chExt cx="0" cy="0"/>
+        </a:xfrm>
+      </p:grpSpPr>
+      <p:sp>
+        <p:nvSpPr>
+          <p:cNvPr id="2" name="Slide Image Placeholder 1"/>
+          <p:cNvSpPr>
+            <a:spLocks noGrp="1"/>
+          </p:cNvSpPr>
+          <p:nvPr>
+            <p:ph type="sldImg" idx="2"/>
+          </p:nvPr>
+        </p:nvSpPr>
+        <p:spPr/>
+      </p:sp>
+      <p:sp>
+        <p:nvSpPr>
+          <p:cNvPr id="3" name="Notes Placeholder 2"/>
+          <p:cNvSpPr>
+            <a:spLocks noGrp="1"/>
+          </p:cNvSpPr>
+          <p:nvPr>
+            <p:ph type="body" idx="3" sz="quarter"/>
+          </p:nvPr>
+        </p:nvSpPr>
+        <p:spPr/>
+        <p:txBody>
+          <a:bodyPr/>
+          <a:lstStyle/>
+          <a:p>
+            <a:r>
+              <a:t>Volunteer this one; do not wait to be asked. Targeted sabotage gives NO advantage when the player relies on every room equally. It only pays off against uneven habits. Reporting a negative result is a strength, not a weakness — say so.</a:t>
+            </a:r>
+          </a:p>
+        </p:txBody>
+      </p:sp>
+      <p:sp>
+        <p:nvSpPr>
+          <p:cNvPr id="4" name="Slide Number Placeholder 3"/>
+          <p:cNvSpPr>
+            <a:spLocks noGrp="1"/>
+          </p:cNvSpPr>
+          <p:nvPr>
+            <p:ph type="sldNum" idx="5" sz="quarter"/>
+          </p:nvPr>
+        </p:nvSpPr>
+        <p:spPr/>
+      </p:sp>
+    </p:spTree>
+  </p:cSld>
+  <p:clrMapOvr>
+    <a:masterClrMapping/>
+  </p:clrMapOvr>
+</p:notes>
+</file>
+
+<file path=ppt/notesSlides/notesSlide22.xml><?xml version="1.0" encoding="utf-8"?>
+<p:notes xmlns:a="http://schemas.openxmlformats.org/drawingml/2006/main" xmlns:p="http://schemas.openxmlformats.org/presentationml/2006/main" xmlns:r="http://schemas.openxmlformats.org/officeDocument/2006/relationships">
+  <p:cSld>
+    <p:spTree>
+      <p:nvGrpSpPr>
+        <p:cNvPr id="1" name=""/>
+        <p:cNvGrpSpPr/>
+        <p:nvPr/>
+      </p:nvGrpSpPr>
+      <p:grpSpPr>
+        <a:xfrm>
+          <a:off x="0" y="0"/>
+          <a:ext cx="0" cy="0"/>
+          <a:chOff x="0" y="0"/>
+          <a:chExt cx="0" cy="0"/>
+        </a:xfrm>
+      </p:grpSpPr>
+      <p:sp>
+        <p:nvSpPr>
+          <p:cNvPr id="2" name="Slide Image Placeholder 1"/>
+          <p:cNvSpPr>
+            <a:spLocks noGrp="1"/>
+          </p:cNvSpPr>
+          <p:nvPr>
+            <p:ph type="sldImg" idx="2"/>
+          </p:nvPr>
+        </p:nvSpPr>
+        <p:spPr/>
+      </p:sp>
+      <p:sp>
+        <p:nvSpPr>
+          <p:cNvPr id="3" name="Notes Placeholder 2"/>
+          <p:cNvSpPr>
+            <a:spLocks noGrp="1"/>
+          </p:cNvSpPr>
+          <p:nvPr>
+            <p:ph type="body" idx="3" sz="quarter"/>
+          </p:nvPr>
+        </p:nvSpPr>
+        <p:spPr/>
+        <p:txBody>
+          <a:bodyPr/>
+          <a:lstStyle/>
+          <a:p>
+            <a:r>
+              <a:t>Nine invariants, 25 generated facilities, all passing. The two that matter most: 'uplink reachable after mutation' (the AI can never soft-lock you) and 'VOMM approximates uniform on a random player' (no leakage). Offer to run it live — it takes seconds.</a:t>
+            </a:r>
+          </a:p>
+        </p:txBody>
+      </p:sp>
+      <p:sp>
+        <p:nvSpPr>
+          <p:cNvPr id="4" name="Slide Number Placeholder 3"/>
+          <p:cNvSpPr>
+            <a:spLocks noGrp="1"/>
+          </p:cNvSpPr>
+          <p:nvPr>
+            <p:ph type="sldNum" idx="5" sz="quarter"/>
+          </p:nvPr>
+        </p:nvSpPr>
+        <p:spPr/>
+      </p:sp>
+    </p:spTree>
+  </p:cSld>
+  <p:clrMapOvr>
+    <a:masterClrMapping/>
+  </p:clrMapOvr>
+</p:notes>
+</file>
+
+<file path=ppt/notesSlides/notesSlide23.xml><?xml version="1.0" encoding="utf-8"?>
+<p:notes xmlns:a="http://schemas.openxmlformats.org/drawingml/2006/main" xmlns:p="http://schemas.openxmlformats.org/presentationml/2006/main" xmlns:r="http://schemas.openxmlformats.org/officeDocument/2006/relationships">
+  <p:cSld>
+    <p:spTree>
+      <p:nvGrpSpPr>
+        <p:cNvPr id="1" name=""/>
+        <p:cNvGrpSpPr/>
+        <p:nvPr/>
+      </p:nvGrpSpPr>
+      <p:grpSpPr>
+        <a:xfrm>
+          <a:off x="0" y="0"/>
+          <a:ext cx="0" cy="0"/>
+          <a:chOff x="0" y="0"/>
+          <a:chExt cx="0" cy="0"/>
+        </a:xfrm>
+      </p:grpSpPr>
+      <p:sp>
+        <p:nvSpPr>
+          <p:cNvPr id="2" name="Slide Image Placeholder 1"/>
+          <p:cNvSpPr>
+            <a:spLocks noGrp="1"/>
+          </p:cNvSpPr>
+          <p:nvPr>
+            <p:ph type="sldImg" idx="2"/>
+          </p:nvPr>
+        </p:nvSpPr>
+        <p:spPr/>
+      </p:sp>
+      <p:sp>
+        <p:nvSpPr>
+          <p:cNvPr id="3" name="Notes Placeholder 2"/>
+          <p:cNvSpPr>
+            <a:spLocks noGrp="1"/>
+          </p:cNvSpPr>
+          <p:nvPr>
+            <p:ph type="body" idx="3" sz="quarter"/>
+          </p:nvPr>
+        </p:nvSpPr>
+        <p:spPr/>
+        <p:txBody>
+          <a:bodyPr/>
+          <a:lstStyle/>
+          <a:p>
+            <a:r>
+              <a:t>Run the demo here. Press auto-play and talk over it. Point at the belief panel, then the live accuracy comparison, then the learned-rule readout in plain English. Let the counter-move counters tick up while you talk.</a:t>
+            </a:r>
+          </a:p>
+        </p:txBody>
+      </p:sp>
+      <p:sp>
+        <p:nvSpPr>
+          <p:cNvPr id="4" name="Slide Number Placeholder 3"/>
+          <p:cNvSpPr>
+            <a:spLocks noGrp="1"/>
+          </p:cNvSpPr>
+          <p:nvPr>
+            <p:ph type="sldNum" idx="5" sz="quarter"/>
+          </p:nvPr>
+        </p:nvSpPr>
+        <p:spPr/>
+      </p:sp>
+    </p:spTree>
+  </p:cSld>
+  <p:clrMapOvr>
+    <a:masterClrMapping/>
+  </p:clrMapOvr>
+</p:notes>
+</file>
+
+<file path=ppt/notesSlides/notesSlide24.xml><?xml version="1.0" encoding="utf-8"?>
+<p:notes xmlns:a="http://schemas.openxmlformats.org/drawingml/2006/main" xmlns:p="http://schemas.openxmlformats.org/presentationml/2006/main" xmlns:r="http://schemas.openxmlformats.org/officeDocument/2006/relationships">
+  <p:cSld>
+    <p:spTree>
+      <p:nvGrpSpPr>
+        <p:cNvPr id="1" name=""/>
+        <p:cNvGrpSpPr/>
+        <p:nvPr/>
+      </p:nvGrpSpPr>
+      <p:grpSpPr>
+        <a:xfrm>
+          <a:off x="0" y="0"/>
+          <a:ext cx="0" cy="0"/>
+          <a:chOff x="0" y="0"/>
+          <a:chExt cx="0" cy="0"/>
+        </a:xfrm>
+      </p:grpSpPr>
+      <p:sp>
+        <p:nvSpPr>
+          <p:cNvPr id="2" name="Slide Image Placeholder 1"/>
+          <p:cNvSpPr>
+            <a:spLocks noGrp="1"/>
+          </p:cNvSpPr>
+          <p:nvPr>
+            <p:ph type="sldImg" idx="2"/>
+          </p:nvPr>
+        </p:nvSpPr>
+        <p:spPr/>
+      </p:sp>
+      <p:sp>
+        <p:nvSpPr>
+          <p:cNvPr id="3" name="Notes Placeholder 2"/>
+          <p:cNvSpPr>
+            <a:spLocks noGrp="1"/>
+          </p:cNvSpPr>
+          <p:nvPr>
+            <p:ph type="body" idx="3" sz="quarter"/>
+          </p:nvPr>
+        </p:nvSpPr>
+        <p:spPr/>
+        <p:txBody>
+          <a:bodyPr/>
+          <a:lstStyle/>
+          <a:p>
+            <a:r>
+              <a:t>Be direct: M0 to M2 are done, M3 is next. The 3D game does not exist yet. The art direction is settled and chosen to minimise modelling cost, and room modularity is forced by the design anyway because rooms are added and rotated at runtime.</a:t>
+            </a:r>
+          </a:p>
+        </p:txBody>
+      </p:sp>
+      <p:sp>
+        <p:nvSpPr>
+          <p:cNvPr id="4" name="Slide Number Placeholder 3"/>
+          <p:cNvSpPr>
+            <a:spLocks noGrp="1"/>
+          </p:cNvSpPr>
+          <p:nvPr>
+            <p:ph type="sldNum" idx="5" sz="quarter"/>
+          </p:nvPr>
+        </p:nvSpPr>
+        <p:spPr/>
+      </p:sp>
+    </p:spTree>
+  </p:cSld>
+  <p:clrMapOvr>
+    <a:masterClrMapping/>
+  </p:clrMapOvr>
+</p:notes>
+</file>
+
+<file path=ppt/notesSlides/notesSlide25.xml><?xml version="1.0" encoding="utf-8"?>
+<p:notes xmlns:a="http://schemas.openxmlformats.org/drawingml/2006/main" xmlns:p="http://schemas.openxmlformats.org/presentationml/2006/main" xmlns:r="http://schemas.openxmlformats.org/officeDocument/2006/relationships">
+  <p:cSld>
+    <p:spTree>
+      <p:nvGrpSpPr>
+        <p:cNvPr id="1" name=""/>
+        <p:cNvGrpSpPr/>
+        <p:nvPr/>
+      </p:nvGrpSpPr>
+      <p:grpSpPr>
+        <a:xfrm>
+          <a:off x="0" y="0"/>
+          <a:ext cx="0" cy="0"/>
+          <a:chOff x="0" y="0"/>
+          <a:chExt cx="0" cy="0"/>
+        </a:xfrm>
+      </p:grpSpPr>
+      <p:sp>
+        <p:nvSpPr>
+          <p:cNvPr id="2" name="Slide Image Placeholder 1"/>
+          <p:cNvSpPr>
+            <a:spLocks noGrp="1"/>
+          </p:cNvSpPr>
+          <p:nvPr>
+            <p:ph type="sldImg" idx="2"/>
+          </p:nvPr>
+        </p:nvSpPr>
+        <p:spPr/>
+      </p:sp>
+      <p:sp>
+        <p:nvSpPr>
+          <p:cNvPr id="3" name="Notes Placeholder 2"/>
+          <p:cNvSpPr>
+            <a:spLocks noGrp="1"/>
+          </p:cNvSpPr>
+          <p:nvPr>
+            <p:ph type="body" idx="3" sz="quarter"/>
+          </p:nvPr>
+        </p:nvSpPr>
+        <p:spPr/>
+        <p:txBody>
+          <a:bodyPr/>
+          <a:lstStyle/>
+          <a:p>
+            <a:r>
+              <a:t>References 1 to 11.</a:t>
+            </a:r>
+          </a:p>
+        </p:txBody>
+      </p:sp>
+      <p:sp>
+        <p:nvSpPr>
+          <p:cNvPr id="4" name="Slide Number Placeholder 3"/>
+          <p:cNvSpPr>
+            <a:spLocks noGrp="1"/>
+          </p:cNvSpPr>
+          <p:nvPr>
+            <p:ph type="sldNum" idx="5" sz="quarter"/>
+          </p:nvPr>
+        </p:nvSpPr>
+        <p:spPr/>
+      </p:sp>
+    </p:spTree>
+  </p:cSld>
+  <p:clrMapOvr>
+    <a:masterClrMapping/>
+  </p:clrMapOvr>
+</p:notes>
+</file>
+
+<file path=ppt/notesSlides/notesSlide26.xml><?xml version="1.0" encoding="utf-8"?>
+<p:notes xmlns:a="http://schemas.openxmlformats.org/drawingml/2006/main" xmlns:p="http://schemas.openxmlformats.org/presentationml/2006/main" xmlns:r="http://schemas.openxmlformats.org/officeDocument/2006/relationships">
+  <p:cSld>
+    <p:spTree>
+      <p:nvGrpSpPr>
+        <p:cNvPr id="1" name=""/>
+        <p:cNvGrpSpPr/>
+        <p:nvPr/>
+      </p:nvGrpSpPr>
+      <p:grpSpPr>
+        <a:xfrm>
+          <a:off x="0" y="0"/>
+          <a:ext cx="0" cy="0"/>
+          <a:chOff x="0" y="0"/>
+          <a:chExt cx="0" cy="0"/>
+        </a:xfrm>
+      </p:grpSpPr>
+      <p:sp>
+        <p:nvSpPr>
+          <p:cNvPr id="2" name="Slide Image Placeholder 1"/>
+          <p:cNvSpPr>
+            <a:spLocks noGrp="1"/>
+          </p:cNvSpPr>
+          <p:nvPr>
+            <p:ph type="sldImg" idx="2"/>
+          </p:nvPr>
+        </p:nvSpPr>
+        <p:spPr/>
+      </p:sp>
+      <p:sp>
+        <p:nvSpPr>
+          <p:cNvPr id="3" name="Notes Placeholder 2"/>
+          <p:cNvSpPr>
+            <a:spLocks noGrp="1"/>
+          </p:cNvSpPr>
+          <p:nvPr>
+            <p:ph type="body" idx="3" sz="quarter"/>
+          </p:nvPr>
+        </p:nvSpPr>
+        <p:spPr/>
+        <p:txBody>
+          <a:bodyPr/>
+          <a:lstStyle/>
+          <a:p>
+            <a:r>
+              <a:t>References 12 to 22.</a:t>
+            </a:r>
+          </a:p>
+        </p:txBody>
+      </p:sp>
+      <p:sp>
+        <p:nvSpPr>
+          <p:cNvPr id="4" name="Slide Number Placeholder 3"/>
+          <p:cNvSpPr>
+            <a:spLocks noGrp="1"/>
+          </p:cNvSpPr>
+          <p:nvPr>
+            <p:ph type="sldNum" idx="5" sz="quarter"/>
+          </p:nvPr>
+        </p:nvSpPr>
+        <p:spPr/>
+      </p:sp>
+    </p:spTree>
+  </p:cSld>
+  <p:clrMapOvr>
+    <a:masterClrMapping/>
+  </p:clrMapOvr>
+</p:notes>
+</file>
+
+<file path=ppt/notesSlides/notesSlide3.xml><?xml version="1.0" encoding="utf-8"?>
+<p:notes xmlns:a="http://schemas.openxmlformats.org/drawingml/2006/main" xmlns:p="http://schemas.openxmlformats.org/presentationml/2006/main" xmlns:r="http://schemas.openxmlformats.org/officeDocument/2006/relationships">
+  <p:cSld>
+    <p:spTree>
+      <p:nvGrpSpPr>
+        <p:cNvPr id="1" name=""/>
+        <p:cNvGrpSpPr/>
+        <p:nvPr/>
+      </p:nvGrpSpPr>
+      <p:grpSpPr>
+        <a:xfrm>
+          <a:off x="0" y="0"/>
+          <a:ext cx="0" cy="0"/>
+          <a:chOff x="0" y="0"/>
+          <a:chExt cx="0" cy="0"/>
+        </a:xfrm>
+      </p:grpSpPr>
+      <p:sp>
+        <p:nvSpPr>
+          <p:cNvPr id="2" name="Slide Image Placeholder 1"/>
+          <p:cNvSpPr>
+            <a:spLocks noGrp="1"/>
+          </p:cNvSpPr>
+          <p:nvPr>
+            <p:ph type="sldImg" idx="2"/>
+          </p:nvPr>
+        </p:nvSpPr>
+        <p:spPr/>
+      </p:sp>
+      <p:sp>
+        <p:nvSpPr>
+          <p:cNvPr id="3" name="Notes Placeholder 2"/>
+          <p:cNvSpPr>
+            <a:spLocks noGrp="1"/>
+          </p:cNvSpPr>
+          <p:nvPr>
+            <p:ph type="body" idx="3" sz="quarter"/>
+          </p:nvPr>
+        </p:nvSpPr>
+        <p:spPr/>
+        <p:txBody>
+          <a:bodyPr/>
+          <a:lstStyle/>
+          <a:p>
+            <a:r>
+              <a:t>Point: game AI research optimises for agents that PLAY well. Adapting to the specific person is a different and less-solved problem. Horror is where it matters most because the genre dies when the player learns it.</a:t>
+            </a:r>
+          </a:p>
+        </p:txBody>
+      </p:sp>
+      <p:sp>
+        <p:nvSpPr>
+          <p:cNvPr id="4" name="Slide Number Placeholder 3"/>
+          <p:cNvSpPr>
+            <a:spLocks noGrp="1"/>
+          </p:cNvSpPr>
+          <p:nvPr>
+            <p:ph type="sldNum" idx="5" sz="quarter"/>
+          </p:nvPr>
+        </p:nvSpPr>
+        <p:spPr/>
+      </p:sp>
+    </p:spTree>
+  </p:cSld>
+  <p:clrMapOvr>
+    <a:masterClrMapping/>
+  </p:clrMapOvr>
+</p:notes>
+</file>
+
+<file path=ppt/notesSlides/notesSlide4.xml><?xml version="1.0" encoding="utf-8"?>
+<p:notes xmlns:a="http://schemas.openxmlformats.org/drawingml/2006/main" xmlns:p="http://schemas.openxmlformats.org/presentationml/2006/main" xmlns:r="http://schemas.openxmlformats.org/officeDocument/2006/relationships">
+  <p:cSld>
+    <p:spTree>
+      <p:nvGrpSpPr>
+        <p:cNvPr id="1" name=""/>
+        <p:cNvGrpSpPr/>
+        <p:nvPr/>
+      </p:nvGrpSpPr>
+      <p:grpSpPr>
+        <a:xfrm>
+          <a:off x="0" y="0"/>
+          <a:ext cx="0" cy="0"/>
+          <a:chOff x="0" y="0"/>
+          <a:chExt cx="0" cy="0"/>
+        </a:xfrm>
+      </p:grpSpPr>
+      <p:sp>
+        <p:nvSpPr>
+          <p:cNvPr id="2" name="Slide Image Placeholder 1"/>
+          <p:cNvSpPr>
+            <a:spLocks noGrp="1"/>
+          </p:cNvSpPr>
+          <p:nvPr>
+            <p:ph type="sldImg" idx="2"/>
+          </p:nvPr>
+        </p:nvSpPr>
+        <p:spPr/>
+      </p:sp>
+      <p:sp>
+        <p:nvSpPr>
+          <p:cNvPr id="3" name="Notes Placeholder 2"/>
+          <p:cNvSpPr>
+            <a:spLocks noGrp="1"/>
+          </p:cNvSpPr>
+          <p:nvPr>
+            <p:ph type="body" idx="3" sz="quarter"/>
+          </p:nvPr>
+        </p:nvSpPr>
+        <p:spPr/>
+        <p:txBody>
+          <a:bodyPr/>
+          <a:lstStyle/>
+          <a:p>
+            <a:r>
+              <a:t>The core argument. Static AI is learnable and stops scaring. Random AI is unlearnable and feels unfair. Neither adapts to you. If asked 'isn't this just DDA?' — no: DDA tunes difficulty magnitude, this changes WHERE the antagonist chooses to be.</a:t>
+            </a:r>
+          </a:p>
+        </p:txBody>
+      </p:sp>
+      <p:sp>
+        <p:nvSpPr>
+          <p:cNvPr id="4" name="Slide Number Placeholder 3"/>
+          <p:cNvSpPr>
+            <a:spLocks noGrp="1"/>
+          </p:cNvSpPr>
+          <p:nvPr>
+            <p:ph type="sldNum" idx="5" sz="quarter"/>
+          </p:nvPr>
+        </p:nvSpPr>
+        <p:spPr/>
+      </p:sp>
+    </p:spTree>
+  </p:cSld>
+  <p:clrMapOvr>
+    <a:masterClrMapping/>
+  </p:clrMapOvr>
+</p:notes>
+</file>
+
+<file path=ppt/notesSlides/notesSlide5.xml><?xml version="1.0" encoding="utf-8"?>
+<p:notes xmlns:a="http://schemas.openxmlformats.org/drawingml/2006/main" xmlns:p="http://schemas.openxmlformats.org/presentationml/2006/main" xmlns:r="http://schemas.openxmlformats.org/officeDocument/2006/relationships">
+  <p:cSld>
+    <p:spTree>
+      <p:nvGrpSpPr>
+        <p:cNvPr id="1" name=""/>
+        <p:cNvGrpSpPr/>
+        <p:nvPr/>
+      </p:nvGrpSpPr>
+      <p:grpSpPr>
+        <a:xfrm>
+          <a:off x="0" y="0"/>
+          <a:ext cx="0" cy="0"/>
+          <a:chOff x="0" y="0"/>
+          <a:chExt cx="0" cy="0"/>
+        </a:xfrm>
+      </p:grpSpPr>
+      <p:sp>
+        <p:nvSpPr>
+          <p:cNvPr id="2" name="Slide Image Placeholder 1"/>
+          <p:cNvSpPr>
+            <a:spLocks noGrp="1"/>
+          </p:cNvSpPr>
+          <p:nvPr>
+            <p:ph type="sldImg" idx="2"/>
+          </p:nvPr>
+        </p:nvSpPr>
+        <p:spPr/>
+      </p:sp>
+      <p:sp>
+        <p:nvSpPr>
+          <p:cNvPr id="3" name="Notes Placeholder 2"/>
+          <p:cNvSpPr>
+            <a:spLocks noGrp="1"/>
+          </p:cNvSpPr>
+          <p:nvPr>
+            <p:ph type="body" idx="3" sz="quarter"/>
+          </p:nvPr>
+        </p:nvSpPr>
+        <p:spPr/>
+        <p:txBody>
+          <a:bodyPr/>
+          <a:lstStyle/>
+          <a:p>
+            <a:r>
+              <a:t>Seven objectives, six complete. Be explicit that O8 (the Godot build) is not done — do not let them think a 3D game exists.</a:t>
+            </a:r>
+          </a:p>
+        </p:txBody>
+      </p:sp>
+      <p:sp>
+        <p:nvSpPr>
+          <p:cNvPr id="4" name="Slide Number Placeholder 3"/>
+          <p:cNvSpPr>
+            <a:spLocks noGrp="1"/>
+          </p:cNvSpPr>
+          <p:nvPr>
+            <p:ph type="sldNum" idx="5" sz="quarter"/>
+          </p:nvPr>
+        </p:nvSpPr>
+        <p:spPr/>
+      </p:sp>
+    </p:spTree>
+  </p:cSld>
+  <p:clrMapOvr>
+    <a:masterClrMapping/>
+  </p:clrMapOvr>
+</p:notes>
+</file>
+
+<file path=ppt/notesSlides/notesSlide6.xml><?xml version="1.0" encoding="utf-8"?>
+<p:notes xmlns:a="http://schemas.openxmlformats.org/drawingml/2006/main" xmlns:p="http://schemas.openxmlformats.org/presentationml/2006/main" xmlns:r="http://schemas.openxmlformats.org/officeDocument/2006/relationships">
+  <p:cSld>
+    <p:spTree>
+      <p:nvGrpSpPr>
+        <p:cNvPr id="1" name=""/>
+        <p:cNvGrpSpPr/>
+        <p:nvPr/>
+      </p:nvGrpSpPr>
+      <p:grpSpPr>
+        <a:xfrm>
+          <a:off x="0" y="0"/>
+          <a:ext cx="0" cy="0"/>
+          <a:chOff x="0" y="0"/>
+          <a:chExt cx="0" cy="0"/>
+        </a:xfrm>
+      </p:grpSpPr>
+      <p:sp>
+        <p:nvSpPr>
+          <p:cNvPr id="2" name="Slide Image Placeholder 1"/>
+          <p:cNvSpPr>
+            <a:spLocks noGrp="1"/>
+          </p:cNvSpPr>
+          <p:nvPr>
+            <p:ph type="sldImg" idx="2"/>
+          </p:nvPr>
+        </p:nvSpPr>
+        <p:spPr/>
+      </p:sp>
+      <p:sp>
+        <p:nvSpPr>
+          <p:cNvPr id="3" name="Notes Placeholder 2"/>
+          <p:cNvSpPr>
+            <a:spLocks noGrp="1"/>
+          </p:cNvSpPr>
+          <p:nvPr>
+            <p:ph type="body" idx="3" sz="quarter"/>
+          </p:nvPr>
+        </p:nvSpPr>
+        <p:spPr/>
+        <p:txBody>
+          <a:bodyPr/>
+          <a:lstStyle/>
+          <a:p>
+            <a:r>
+              <a:t>22 works, 20 from 2023 or later. Say the selection criteria out loud: player behaviour prediction, runtime adaptation, or discrete-trajectory prediction.</a:t>
+            </a:r>
+          </a:p>
+        </p:txBody>
+      </p:sp>
+      <p:sp>
+        <p:nvSpPr>
+          <p:cNvPr id="4" name="Slide Number Placeholder 3"/>
+          <p:cNvSpPr>
+            <a:spLocks noGrp="1"/>
+          </p:cNvSpPr>
+          <p:nvPr>
+            <p:ph type="sldNum" idx="5" sz="quarter"/>
+          </p:nvPr>
+        </p:nvSpPr>
+        <p:spPr/>
+      </p:sp>
+    </p:spTree>
+  </p:cSld>
+  <p:clrMapOvr>
+    <a:masterClrMapping/>
+  </p:clrMapOvr>
+</p:notes>
+</file>
+
+<file path=ppt/notesSlides/notesSlide7.xml><?xml version="1.0" encoding="utf-8"?>
+<p:notes xmlns:a="http://schemas.openxmlformats.org/drawingml/2006/main" xmlns:p="http://schemas.openxmlformats.org/presentationml/2006/main" xmlns:r="http://schemas.openxmlformats.org/officeDocument/2006/relationships">
+  <p:cSld>
+    <p:spTree>
+      <p:nvGrpSpPr>
+        <p:cNvPr id="1" name=""/>
+        <p:cNvGrpSpPr/>
+        <p:nvPr/>
+      </p:nvGrpSpPr>
+      <p:grpSpPr>
+        <a:xfrm>
+          <a:off x="0" y="0"/>
+          <a:ext cx="0" cy="0"/>
+          <a:chOff x="0" y="0"/>
+          <a:chExt cx="0" cy="0"/>
+        </a:xfrm>
+      </p:grpSpPr>
+      <p:sp>
+        <p:nvSpPr>
+          <p:cNvPr id="2" name="Slide Image Placeholder 1"/>
+          <p:cNvSpPr>
+            <a:spLocks noGrp="1"/>
+          </p:cNvSpPr>
+          <p:nvPr>
+            <p:ph type="sldImg" idx="2"/>
+          </p:nvPr>
+        </p:nvSpPr>
+        <p:spPr/>
+      </p:sp>
+      <p:sp>
+        <p:nvSpPr>
+          <p:cNvPr id="3" name="Notes Placeholder 2"/>
+          <p:cNvSpPr>
+            <a:spLocks noGrp="1"/>
+          </p:cNvSpPr>
+          <p:nvPr>
+            <p:ph type="body" idx="3" sz="quarter"/>
+          </p:nvPr>
+        </p:nvSpPr>
+        <p:spPr/>
+        <p:txBody>
+          <a:bodyPr/>
+          <a:lstStyle/>
+          <a:p>
+            <a:r>
+              <a:t>Do not read the table. Pick two: Romeo (closest analogue, adapts encounters via RL) and Lopes (systematic review that names evaluation as the field's weak point — which is the gap my bot harness addresses).</a:t>
+            </a:r>
+          </a:p>
+        </p:txBody>
+      </p:sp>
+      <p:sp>
+        <p:nvSpPr>
+          <p:cNvPr id="4" name="Slide Number Placeholder 3"/>
+          <p:cNvSpPr>
+            <a:spLocks noGrp="1"/>
+          </p:cNvSpPr>
+          <p:nvPr>
+            <p:ph type="sldNum" idx="5" sz="quarter"/>
+          </p:nvPr>
+        </p:nvSpPr>
+        <p:spPr/>
+      </p:sp>
+    </p:spTree>
+  </p:cSld>
+  <p:clrMapOvr>
+    <a:masterClrMapping/>
+  </p:clrMapOvr>
+</p:notes>
+</file>
+
+<file path=ppt/notesSlides/notesSlide8.xml><?xml version="1.0" encoding="utf-8"?>
+<p:notes xmlns:a="http://schemas.openxmlformats.org/drawingml/2006/main" xmlns:p="http://schemas.openxmlformats.org/presentationml/2006/main" xmlns:r="http://schemas.openxmlformats.org/officeDocument/2006/relationships">
+  <p:cSld>
+    <p:spTree>
+      <p:nvGrpSpPr>
+        <p:cNvPr id="1" name=""/>
+        <p:cNvGrpSpPr/>
+        <p:nvPr/>
+      </p:nvGrpSpPr>
+      <p:grpSpPr>
+        <a:xfrm>
+          <a:off x="0" y="0"/>
+          <a:ext cx="0" cy="0"/>
+          <a:chOff x="0" y="0"/>
+          <a:chExt cx="0" cy="0"/>
+        </a:xfrm>
+      </p:grpSpPr>
+      <p:sp>
+        <p:nvSpPr>
+          <p:cNvPr id="2" name="Slide Image Placeholder 1"/>
+          <p:cNvSpPr>
+            <a:spLocks noGrp="1"/>
+          </p:cNvSpPr>
+          <p:nvPr>
+            <p:ph type="sldImg" idx="2"/>
+          </p:nvPr>
+        </p:nvSpPr>
+        <p:spPr/>
+      </p:sp>
+      <p:sp>
+        <p:nvSpPr>
+          <p:cNvPr id="3" name="Notes Placeholder 2"/>
+          <p:cNvSpPr>
+            <a:spLocks noGrp="1"/>
+          </p:cNvSpPr>
+          <p:nvPr>
+            <p:ph type="body" idx="3" sz="quarter"/>
+          </p:nvPr>
+        </p:nvSpPr>
+        <p:spPr/>
+        <p:txBody>
+          <a:bodyPr/>
+          <a:lstStyle/>
+          <a:p>
+            <a:r>
+              <a:t>Begleiter is the one to name aloud — it is the formal basis of the model. If asked why a 2004 paper is in a 'recent papers' review: it is the foundational treatment of variable-order Markov prediction, and the four 2025 trajectory-prediction papers beside it are the modern line of work.</a:t>
+            </a:r>
+          </a:p>
+        </p:txBody>
+      </p:sp>
+      <p:sp>
+        <p:nvSpPr>
+          <p:cNvPr id="4" name="Slide Number Placeholder 3"/>
+          <p:cNvSpPr>
+            <a:spLocks noGrp="1"/>
+          </p:cNvSpPr>
+          <p:nvPr>
+            <p:ph type="sldNum" idx="5" sz="quarter"/>
+          </p:nvPr>
+        </p:nvSpPr>
+        <p:spPr/>
+      </p:sp>
+    </p:spTree>
+  </p:cSld>
+  <p:clrMapOvr>
+    <a:masterClrMapping/>
+  </p:clrMapOvr>
+</p:notes>
+</file>
+
+<file path=ppt/notesSlides/notesSlide9.xml><?xml version="1.0" encoding="utf-8"?>
+<p:notes xmlns:a="http://schemas.openxmlformats.org/drawingml/2006/main" xmlns:p="http://schemas.openxmlformats.org/presentationml/2006/main" xmlns:r="http://schemas.openxmlformats.org/officeDocument/2006/relationships">
+  <p:cSld>
+    <p:spTree>
+      <p:nvGrpSpPr>
+        <p:cNvPr id="1" name=""/>
+        <p:cNvGrpSpPr/>
+        <p:nvPr/>
+      </p:nvGrpSpPr>
+      <p:grpSpPr>
+        <a:xfrm>
+          <a:off x="0" y="0"/>
+          <a:ext cx="0" cy="0"/>
+          <a:chOff x="0" y="0"/>
+          <a:chExt cx="0" cy="0"/>
+        </a:xfrm>
+      </p:grpSpPr>
+      <p:sp>
+        <p:nvSpPr>
+          <p:cNvPr id="2" name="Slide Image Placeholder 1"/>
+          <p:cNvSpPr>
+            <a:spLocks noGrp="1"/>
+          </p:cNvSpPr>
+          <p:nvPr>
+            <p:ph type="sldImg" idx="2"/>
+          </p:nvPr>
+        </p:nvSpPr>
+        <p:spPr/>
+      </p:sp>
+      <p:sp>
+        <p:nvSpPr>
+          <p:cNvPr id="3" name="Notes Placeholder 2"/>
+          <p:cNvSpPr>
+            <a:spLocks noGrp="1"/>
+          </p:cNvSpPr>
+          <p:nvPr>
+            <p:ph type="body" idx="3" sz="quarter"/>
+          </p:nvPr>
+        </p:nvSpPr>
+        <p:spPr/>
+        <p:txBody>
+          <a:bodyPr/>
+          <a:lstStyle/>
+          <a:p>
+            <a:r>
+              <a:t>The heart of the literature section. Three gaps: DDA adapts parameters not position; trajectory prediction is never used adversarially; adaptation is invisible so it is never evaluated against a control. This project does all three.</a:t>
+            </a:r>
+          </a:p>
+        </p:txBody>
+      </p:sp>
+      <p:sp>
+        <p:nvSpPr>
+          <p:cNvPr id="4" name="Slide Number Placeholder 3"/>
+          <p:cNvSpPr>
+            <a:spLocks noGrp="1"/>
+          </p:cNvSpPr>
+          <p:nvPr>
+            <p:ph type="sldNum" idx="5" sz="quarter"/>
+          </p:nvPr>
+        </p:nvSpPr>
+        <p:spPr/>
+      </p:sp>
+    </p:spTree>
+  </p:cSld>
+  <p:clrMapOvr>
+    <a:masterClrMapping/>
+  </p:clrMapOvr>
+</p:notes>
 </file>
 
 <file path=ppt/slideLayouts/slideLayout1.xml><?xml version="1.0" encoding="utf-8"?>
@@ -17516,4 +19686,324 @@
   </a:objectDefaults>
   <a:extraClrSchemeLst/>
 </a:theme>
+</file>
+
+<file path=ppt/theme/theme2.xml><?xml version="1.0" encoding="utf-8"?>
+<a:theme xmlns:a="http://schemas.openxmlformats.org/drawingml/2006/main" name="Office Theme">
+  <a:themeElements>
+    <a:clrScheme name="Office">
+      <a:dk1>
+        <a:sysClr val="windowText" lastClr="000000"/>
+      </a:dk1>
+      <a:lt1>
+        <a:sysClr val="window" lastClr="FFFFFF"/>
+      </a:lt1>
+      <a:dk2>
+        <a:srgbClr val="1F497D"/>
+      </a:dk2>
+      <a:lt2>
+        <a:srgbClr val="EEECE1"/>
+      </a:lt2>
+      <a:accent1>
+        <a:srgbClr val="4F81BD"/>
+      </a:accent1>
+      <a:accent2>
+        <a:srgbClr val="C0504D"/>
+      </a:accent2>
+      <a:accent3>
+        <a:srgbClr val="9BBB59"/>
+      </a:accent3>
+      <a:accent4>
+        <a:srgbClr val="8064A2"/>
+      </a:accent4>
+      <a:accent5>
+        <a:srgbClr val="4BACC6"/>
+      </a:accent5>
+      <a:accent6>
+        <a:srgbClr val="F79646"/>
+      </a:accent6>
+      <a:hlink>
+        <a:srgbClr val="0000FF"/>
+      </a:hlink>
+      <a:folHlink>
+        <a:srgbClr val="800080"/>
+      </a:folHlink>
+    </a:clrScheme>
+    <a:fontScheme name="Office">
+      <a:majorFont>
+        <a:latin typeface="Calibri"/>
+        <a:ea typeface=""/>
+        <a:cs typeface=""/>
+        <a:font script="Jpan" typeface="ＭＳ Ｐゴシック"/>
+        <a:font script="Hang" typeface="맑은 고딕"/>
+        <a:font script="Hans" typeface="宋体"/>
+        <a:font script="Hant" typeface="新細明體"/>
+        <a:font script="Arab" typeface="Times New Roman"/>
+        <a:font script="Hebr" typeface="Times New Roman"/>
+        <a:font script="Thai" typeface="Angsana New"/>
+        <a:font script="Ethi" typeface="Nyala"/>
+        <a:font script="Beng" typeface="Vrinda"/>
+        <a:font script="Gujr" typeface="Shruti"/>
+        <a:font script="Khmr" typeface="MoolBoran"/>
+        <a:font script="Knda" typeface="Tunga"/>
+        <a:font script="Guru" typeface="Raavi"/>
+        <a:font script="Cans" typeface="Euphemia"/>
+        <a:font script="Cher" typeface="Plantagenet Cherokee"/>
+        <a:font script="Yiii" typeface="Microsoft Yi Baiti"/>
+        <a:font script="Tibt" typeface="Microsoft Himalaya"/>
+        <a:font script="Thaa" typeface="MV Boli"/>
+        <a:font script="Deva" typeface="Mangal"/>
+        <a:font script="Telu" typeface="Gautami"/>
+        <a:font script="Taml" typeface="Latha"/>
+        <a:font script="Syrc" typeface="Estrangelo Edessa"/>
+        <a:font script="Orya" typeface="Kalinga"/>
+        <a:font script="Mlym" typeface="Kartika"/>
+        <a:font script="Laoo" typeface="DokChampa"/>
+        <a:font script="Sinh" typeface="Iskoola Pota"/>
+        <a:font script="Mong" typeface="Mongolian Baiti"/>
+        <a:font script="Viet" typeface="Times New Roman"/>
+        <a:font script="Uigh" typeface="Microsoft Uighur"/>
+        <a:font script="Geor" typeface="Sylfaen"/>
+      </a:majorFont>
+      <a:minorFont>
+        <a:latin typeface="Calibri"/>
+        <a:ea typeface=""/>
+        <a:cs typeface=""/>
+        <a:font script="Jpan" typeface="ＭＳ Ｐゴシック"/>
+        <a:font script="Hang" typeface="맑은 고딕"/>
+        <a:font script="Hans" typeface="宋体"/>
+        <a:font script="Hant" typeface="新細明體"/>
+        <a:font script="Arab" typeface="Arial"/>
+        <a:font script="Hebr" typeface="Arial"/>
+        <a:font script="Thai" typeface="Cordia New"/>
+        <a:font script="Ethi" typeface="Nyala"/>
+        <a:font script="Beng" typeface="Vrinda"/>
+        <a:font script="Gujr" typeface="Shruti"/>
+        <a:font script="Khmr" typeface="DaunPenh"/>
+        <a:font script="Knda" typeface="Tunga"/>
+        <a:font script="Guru" typeface="Raavi"/>
+        <a:font script="Cans" typeface="Euphemia"/>
+        <a:font script="Cher" typeface="Plantagenet Cherokee"/>
+        <a:font script="Yiii" typeface="Microsoft Yi Baiti"/>
+        <a:font script="Tibt" typeface="Microsoft Himalaya"/>
+        <a:font script="Thaa" typeface="MV Boli"/>
+        <a:font script="Deva" typeface="Mangal"/>
+        <a:font script="Telu" typeface="Gautami"/>
+        <a:font script="Taml" typeface="Latha"/>
+        <a:font script="Syrc" typeface="Estrangelo Edessa"/>
+        <a:font script="Orya" typeface="Kalinga"/>
+        <a:font script="Mlym" typeface="Kartika"/>
+        <a:font script="Laoo" typeface="DokChampa"/>
+        <a:font script="Sinh" typeface="Iskoola Pota"/>
+        <a:font script="Mong" typeface="Mongolian Baiti"/>
+        <a:font script="Viet" typeface="Arial"/>
+        <a:font script="Uigh" typeface="Microsoft Uighur"/>
+        <a:font script="Geor" typeface="Sylfaen"/>
+      </a:minorFont>
+    </a:fontScheme>
+    <a:fmtScheme name="Office">
+      <a:fillStyleLst>
+        <a:solidFill>
+          <a:schemeClr val="phClr"/>
+        </a:solidFill>
+        <a:gradFill rotWithShape="1">
+          <a:gsLst>
+            <a:gs pos="0">
+              <a:schemeClr val="phClr">
+                <a:tint val="50000"/>
+                <a:satMod val="300000"/>
+              </a:schemeClr>
+            </a:gs>
+            <a:gs pos="35000">
+              <a:schemeClr val="phClr">
+                <a:tint val="37000"/>
+                <a:satMod val="300000"/>
+              </a:schemeClr>
+            </a:gs>
+            <a:gs pos="100000">
+              <a:schemeClr val="phClr">
+                <a:tint val="15000"/>
+                <a:satMod val="350000"/>
+              </a:schemeClr>
+            </a:gs>
+          </a:gsLst>
+          <a:lin ang="16200000" scaled="1"/>
+        </a:gradFill>
+        <a:gradFill rotWithShape="1">
+          <a:gsLst>
+            <a:gs pos="0">
+              <a:schemeClr val="phClr">
+                <a:tint val="100000"/>
+                <a:shade val="100000"/>
+                <a:satMod val="130000"/>
+              </a:schemeClr>
+            </a:gs>
+            <a:gs pos="100000">
+              <a:schemeClr val="phClr">
+                <a:tint val="50000"/>
+                <a:shade val="100000"/>
+                <a:satMod val="350000"/>
+              </a:schemeClr>
+            </a:gs>
+          </a:gsLst>
+          <a:lin ang="16200000" scaled="0"/>
+        </a:gradFill>
+      </a:fillStyleLst>
+      <a:lnStyleLst>
+        <a:ln w="9525" cap="flat" cmpd="sng" algn="ctr">
+          <a:solidFill>
+            <a:schemeClr val="phClr">
+              <a:shade val="95000"/>
+              <a:satMod val="105000"/>
+            </a:schemeClr>
+          </a:solidFill>
+          <a:prstDash val="solid"/>
+        </a:ln>
+        <a:ln w="25400" cap="flat" cmpd="sng" algn="ctr">
+          <a:solidFill>
+            <a:schemeClr val="phClr"/>
+          </a:solidFill>
+          <a:prstDash val="solid"/>
+        </a:ln>
+        <a:ln w="38100" cap="flat" cmpd="sng" algn="ctr">
+          <a:solidFill>
+            <a:schemeClr val="phClr"/>
+          </a:solidFill>
+          <a:prstDash val="solid"/>
+        </a:ln>
+      </a:lnStyleLst>
+      <a:effectStyleLst>
+        <a:effectStyle>
+          <a:effectLst>
+            <a:outerShdw blurRad="40000" dist="20000" dir="5400000" rotWithShape="0">
+              <a:srgbClr val="000000">
+                <a:alpha val="38000"/>
+              </a:srgbClr>
+            </a:outerShdw>
+          </a:effectLst>
+        </a:effectStyle>
+        <a:effectStyle>
+          <a:effectLst>
+            <a:outerShdw blurRad="40000" dist="23000" dir="5400000" rotWithShape="0">
+              <a:srgbClr val="000000">
+                <a:alpha val="35000"/>
+              </a:srgbClr>
+            </a:outerShdw>
+          </a:effectLst>
+        </a:effectStyle>
+        <a:effectStyle>
+          <a:effectLst>
+            <a:outerShdw blurRad="40000" dist="23000" dir="5400000" rotWithShape="0">
+              <a:srgbClr val="000000">
+                <a:alpha val="35000"/>
+              </a:srgbClr>
+            </a:outerShdw>
+          </a:effectLst>
+          <a:scene3d>
+            <a:camera prst="orthographicFront">
+              <a:rot lat="0" lon="0" rev="0"/>
+            </a:camera>
+            <a:lightRig rig="threePt" dir="t">
+              <a:rot lat="0" lon="0" rev="1200000"/>
+            </a:lightRig>
+          </a:scene3d>
+          <a:sp3d>
+            <a:bevelT w="63500" h="25400"/>
+          </a:sp3d>
+        </a:effectStyle>
+      </a:effectStyleLst>
+      <a:bgFillStyleLst>
+        <a:solidFill>
+          <a:schemeClr val="phClr"/>
+        </a:solidFill>
+        <a:gradFill rotWithShape="1">
+          <a:gsLst>
+            <a:gs pos="0">
+              <a:schemeClr val="phClr">
+                <a:tint val="40000"/>
+                <a:satMod val="350000"/>
+              </a:schemeClr>
+            </a:gs>
+            <a:gs pos="40000">
+              <a:schemeClr val="phClr">
+                <a:tint val="45000"/>
+                <a:shade val="99000"/>
+                <a:satMod val="350000"/>
+              </a:schemeClr>
+            </a:gs>
+            <a:gs pos="100000">
+              <a:schemeClr val="phClr">
+                <a:shade val="20000"/>
+                <a:satMod val="255000"/>
+              </a:schemeClr>
+            </a:gs>
+          </a:gsLst>
+          <a:path path="circle">
+            <a:fillToRect l="50000" t="-80000" r="50000" b="180000"/>
+          </a:path>
+        </a:gradFill>
+        <a:gradFill rotWithShape="1">
+          <a:gsLst>
+            <a:gs pos="0">
+              <a:schemeClr val="phClr">
+                <a:tint val="80000"/>
+                <a:satMod val="300000"/>
+              </a:schemeClr>
+            </a:gs>
+            <a:gs pos="100000">
+              <a:schemeClr val="phClr">
+                <a:shade val="30000"/>
+                <a:satMod val="200000"/>
+              </a:schemeClr>
+            </a:gs>
+          </a:gsLst>
+          <a:path path="circle">
+            <a:fillToRect l="50000" t="50000" r="50000" b="50000"/>
+          </a:path>
+        </a:gradFill>
+      </a:bgFillStyleLst>
+    </a:fmtScheme>
+  </a:themeElements>
+  <a:objectDefaults>
+    <a:spDef>
+      <a:spPr/>
+      <a:bodyPr/>
+      <a:lstStyle/>
+      <a:style>
+        <a:lnRef idx="1">
+          <a:schemeClr val="accent1"/>
+        </a:lnRef>
+        <a:fillRef idx="3">
+          <a:schemeClr val="accent1"/>
+        </a:fillRef>
+        <a:effectRef idx="2">
+          <a:schemeClr val="accent1"/>
+        </a:effectRef>
+        <a:fontRef idx="minor">
+          <a:schemeClr val="lt1"/>
+        </a:fontRef>
+      </a:style>
+    </a:spDef>
+    <a:lnDef>
+      <a:spPr/>
+      <a:bodyPr/>
+      <a:lstStyle/>
+      <a:style>
+        <a:lnRef idx="2">
+          <a:schemeClr val="accent1"/>
+        </a:lnRef>
+        <a:fillRef idx="0">
+          <a:schemeClr val="accent1"/>
+        </a:fillRef>
+        <a:effectRef idx="1">
+          <a:schemeClr val="accent1"/>
+        </a:effectRef>
+        <a:fontRef idx="minor">
+          <a:schemeClr val="tx1"/>
+        </a:fontRef>
+      </a:style>
+    </a:lnDef>
+  </a:objectDefaults>
+  <a:extraClrSchemeLst/>
+</a:theme>
 </file>
</xml_diff>

<commit_message>
Add a walkable 3D room study
Three hexagonal cells of the facility in hand-written WebGL2 -- no engine, no
libraries, running offline in any browser. Godot and Blender are not installed and
installing an engine hours before a review is a bad trade; this shows the art
direction concretely and runs anywhere.

- Hex cells whose sides are doorways or walls: the room graph given physical form,
  with side count as the difficulty setting
- Single handheld light with cone and spill, exponential fog, 420x236 internal
  render target, ordered dither, colour quantisation, vignette, scanline
- Explicit floor/ceiling normals and two-sided shading, after mis-wound triangles
  left the floor unlit
- Exposure raised from the original moody tuning so it reads on a projector
- New deck slide (24) and report section 5.11; deck now 29 slides
</commit_message>
<xml_diff>
--- a/docs/PARITY-review-deck.pptx
+++ b/docs/PARITY-review-deck.pptx
@@ -33,6 +33,7 @@
     <p:sldId id="281" r:id="rId32"/>
     <p:sldId id="282" r:id="rId33"/>
     <p:sldId id="283" r:id="rId34"/>
+    <p:sldId id="284" r:id="rId35"/>
   </p:sldIdLst>
   <p:sldSz cx="12191695" cy="6858000" type="screen4x3"/>
   <p:notesSz cx="6858000" cy="9144000"/>
@@ -1719,7 +1720,7 @@
           <a:lstStyle/>
           <a:p>
             <a:r>
-              <a:t>Run the demo. Press auto-play and talk over it. Point at the belief panel, then the live accuracy comparison, then the learned-rule readout, then the counter-move counters.</a:t>
+              <a:t>Walk through it. Say what it is honestly: an art-direction study, not the game — hand-written WebGL so it runs offline on any laptop with no engine installed. Point out that the hexagonal cells ARE the room graph the model plays on, and that side count is the difficulty setting. The whole look is darkness, fog and a post-process pass, chosen because it minimises modelling cost.</a:t>
             </a:r>
           </a:p>
         </p:txBody>
@@ -10935,7 +10936,7 @@
                           </a:solidFill>
                           <a:latin typeface="Arial"/>
                         </a:rPr>
-                        <a:t>Sections 14–24</a:t>
+                        <a:t>Sections 14–25</a:t>
                       </a:r>
                     </a:p>
                   </a:txBody>
@@ -10962,7 +10963,7 @@
                           </a:solidFill>
                           <a:latin typeface="Arial"/>
                         </a:rPr>
-                        <a:t>Ten experiments, 9 invariants, a live demo</a:t>
+                        <a:t>Ten experiments, 9 invariants, two live demos</a:t>
                       </a:r>
                     </a:p>
                   </a:txBody>
@@ -14083,7 +14084,7 @@
                 </a:solidFill>
                 <a:latin typeface="Arial"/>
               </a:rPr>
-              <a:t>24 · ROADMAP</a:t>
+              <a:t>24 · THE LOOK</a:t>
             </a:r>
           </a:p>
         </p:txBody>
@@ -14125,7 +14126,7 @@
                 </a:solidFill>
                 <a:latin typeface="Arial"/>
               </a:rPr>
-              <a:t>Three of nine milestones complete</a:t>
+              <a:t>A walkable room study, running in the browser</a:t>
             </a:r>
           </a:p>
         </p:txBody>
@@ -14174,863 +14175,30 @@
           </a:p>
         </p:txBody>
       </p:sp>
-      <p:graphicFrame>
-        <p:nvGraphicFramePr>
-          <p:cNvPr id="5" name="Table 4"/>
-          <p:cNvGraphicFramePr>
-            <a:graphicFrameLocks noGrp="1"/>
-          </p:cNvGraphicFramePr>
+      <p:pic>
+        <p:nvPicPr>
+          <p:cNvPr id="5" name="Picture 4" descr="fig_room.png"/>
+          <p:cNvPicPr>
+            <a:picLocks noChangeAspect="1"/>
+          </p:cNvPicPr>
           <p:nvPr/>
-        </p:nvGraphicFramePr>
-        <p:xfrm>
-          <a:off x="658368" y="1783080"/>
-          <a:ext cx="10881360" cy="3840480"/>
-        </p:xfrm>
-        <a:graphic>
-          <a:graphicData uri="http://schemas.openxmlformats.org/drawingml/2006/table">
-            <a:tbl>
-              <a:tblPr firstRow="1" bandRow="1">
-                <a:tableStyleId>{5C22544A-7EE6-4342-B048-85BDC9FD1C3A}</a:tableStyleId>
-              </a:tblPr>
-              <a:tblGrid>
-                <a:gridCol w="1188720"/>
-                <a:gridCol w="7680960"/>
-                <a:gridCol w="2011680"/>
-              </a:tblGrid>
-              <a:tr h="384048">
-                <a:tc>
-                  <a:txBody>
-                    <a:bodyPr/>
-                    <a:lstStyle/>
-                    <a:p>
-                      <a:pPr>
-                        <a:lnSpc>
-                          <a:spcPct val="115000"/>
-                        </a:lnSpc>
-                      </a:pPr>
-                      <a:r>
-                        <a:rPr sz="950" b="1">
-                          <a:solidFill>
-                            <a:srgbClr val="6B7178"/>
-                          </a:solidFill>
-                          <a:latin typeface="Arial"/>
-                        </a:rPr>
-                        <a:t>Milestone</a:t>
-                      </a:r>
-                    </a:p>
-                  </a:txBody>
-                  <a:tcPr marL="73152" marR="73152" marT="36576" marB="36576">
-                    <a:solidFill>
-                      <a:srgbClr val="F4F6F8"/>
-                    </a:solidFill>
-                  </a:tcPr>
-                </a:tc>
-                <a:tc>
-                  <a:txBody>
-                    <a:bodyPr/>
-                    <a:lstStyle/>
-                    <a:p>
-                      <a:pPr>
-                        <a:lnSpc>
-                          <a:spcPct val="115000"/>
-                        </a:lnSpc>
-                      </a:pPr>
-                      <a:r>
-                        <a:rPr sz="950" b="1">
-                          <a:solidFill>
-                            <a:srgbClr val="6B7178"/>
-                          </a:solidFill>
-                          <a:latin typeface="Arial"/>
-                        </a:rPr>
-                        <a:t>Deliverable</a:t>
-                      </a:r>
-                    </a:p>
-                  </a:txBody>
-                  <a:tcPr marL="73152" marR="73152" marT="36576" marB="36576">
-                    <a:solidFill>
-                      <a:srgbClr val="F4F6F8"/>
-                    </a:solidFill>
-                  </a:tcPr>
-                </a:tc>
-                <a:tc>
-                  <a:txBody>
-                    <a:bodyPr/>
-                    <a:lstStyle/>
-                    <a:p>
-                      <a:pPr>
-                        <a:lnSpc>
-                          <a:spcPct val="115000"/>
-                        </a:lnSpc>
-                      </a:pPr>
-                      <a:r>
-                        <a:rPr sz="950" b="1">
-                          <a:solidFill>
-                            <a:srgbClr val="6B7178"/>
-                          </a:solidFill>
-                          <a:latin typeface="Arial"/>
-                        </a:rPr>
-                        <a:t>State</a:t>
-                      </a:r>
-                    </a:p>
-                  </a:txBody>
-                  <a:tcPr marL="73152" marR="73152" marT="36576" marB="36576">
-                    <a:solidFill>
-                      <a:srgbClr val="F4F6F8"/>
-                    </a:solidFill>
-                  </a:tcPr>
-                </a:tc>
-              </a:tr>
-              <a:tr h="384048">
-                <a:tc>
-                  <a:txBody>
-                    <a:bodyPr/>
-                    <a:lstStyle/>
-                    <a:p>
-                      <a:pPr>
-                        <a:lnSpc>
-                          <a:spcPct val="115000"/>
-                        </a:lnSpc>
-                      </a:pPr>
-                      <a:r>
-                        <a:rPr sz="1250" b="0">
-                          <a:solidFill>
-                            <a:srgbClr val="16181A"/>
-                          </a:solidFill>
-                          <a:latin typeface="Arial"/>
-                        </a:rPr>
-                        <a:t>M0</a:t>
-                      </a:r>
-                    </a:p>
-                  </a:txBody>
-                  <a:tcPr marL="73152" marR="73152" marT="36576" marB="36576">
-                    <a:solidFill>
-                      <a:srgbClr val="FCFCFB"/>
-                    </a:solidFill>
-                  </a:tcPr>
-                </a:tc>
-                <a:tc>
-                  <a:txBody>
-                    <a:bodyPr/>
-                    <a:lstStyle/>
-                    <a:p>
-                      <a:pPr>
-                        <a:lnSpc>
-                          <a:spcPct val="115000"/>
-                        </a:lnSpc>
-                      </a:pPr>
-                      <a:r>
-                        <a:rPr sz="1250" b="0">
-                          <a:solidFill>
-                            <a:srgbClr val="16181A"/>
-                          </a:solidFill>
-                          <a:latin typeface="Arial"/>
-                        </a:rPr>
-                        <a:t>Headless simulation core, telemetry, bot harness</a:t>
-                      </a:r>
-                    </a:p>
-                  </a:txBody>
-                  <a:tcPr marL="73152" marR="73152" marT="36576" marB="36576">
-                    <a:solidFill>
-                      <a:srgbClr val="FCFCFB"/>
-                    </a:solidFill>
-                  </a:tcPr>
-                </a:tc>
-                <a:tc>
-                  <a:txBody>
-                    <a:bodyPr/>
-                    <a:lstStyle/>
-                    <a:p>
-                      <a:pPr>
-                        <a:lnSpc>
-                          <a:spcPct val="115000"/>
-                        </a:lnSpc>
-                      </a:pPr>
-                      <a:r>
-                        <a:rPr sz="1250" b="0">
-                          <a:solidFill>
-                            <a:srgbClr val="16181A"/>
-                          </a:solidFill>
-                          <a:latin typeface="Arial"/>
-                        </a:rPr>
-                        <a:t>Complete</a:t>
-                      </a:r>
-                    </a:p>
-                  </a:txBody>
-                  <a:tcPr marL="73152" marR="73152" marT="36576" marB="36576">
-                    <a:solidFill>
-                      <a:srgbClr val="FCFCFB"/>
-                    </a:solidFill>
-                  </a:tcPr>
-                </a:tc>
-              </a:tr>
-              <a:tr h="384048">
-                <a:tc>
-                  <a:txBody>
-                    <a:bodyPr/>
-                    <a:lstStyle/>
-                    <a:p>
-                      <a:pPr>
-                        <a:lnSpc>
-                          <a:spcPct val="115000"/>
-                        </a:lnSpc>
-                      </a:pPr>
-                      <a:r>
-                        <a:rPr sz="1250" b="0">
-                          <a:solidFill>
-                            <a:srgbClr val="16181A"/>
-                          </a:solidFill>
-                          <a:latin typeface="Arial"/>
-                        </a:rPr>
-                        <a:t>M1</a:t>
-                      </a:r>
-                    </a:p>
-                  </a:txBody>
-                  <a:tcPr marL="73152" marR="73152" marT="36576" marB="36576">
-                    <a:solidFill>
-                      <a:srgbClr val="FCFCFB"/>
-                    </a:solidFill>
-                  </a:tcPr>
-                </a:tc>
-                <a:tc>
-                  <a:txBody>
-                    <a:bodyPr/>
-                    <a:lstStyle/>
-                    <a:p>
-                      <a:pPr>
-                        <a:lnSpc>
-                          <a:spcPct val="115000"/>
-                        </a:lnSpc>
-                      </a:pPr>
-                      <a:r>
-                        <a:rPr sz="1250" b="0">
-                          <a:solidFill>
-                            <a:srgbClr val="16181A"/>
-                          </a:solidFill>
-                          <a:latin typeface="Arial"/>
-                        </a:rPr>
-                        <a:t>Predictor, baselines, controls, offline metrics and figures</a:t>
-                      </a:r>
-                    </a:p>
-                  </a:txBody>
-                  <a:tcPr marL="73152" marR="73152" marT="36576" marB="36576">
-                    <a:solidFill>
-                      <a:srgbClr val="FCFCFB"/>
-                    </a:solidFill>
-                  </a:tcPr>
-                </a:tc>
-                <a:tc>
-                  <a:txBody>
-                    <a:bodyPr/>
-                    <a:lstStyle/>
-                    <a:p>
-                      <a:pPr>
-                        <a:lnSpc>
-                          <a:spcPct val="115000"/>
-                        </a:lnSpc>
-                      </a:pPr>
-                      <a:r>
-                        <a:rPr sz="1250" b="0">
-                          <a:solidFill>
-                            <a:srgbClr val="16181A"/>
-                          </a:solidFill>
-                          <a:latin typeface="Arial"/>
-                        </a:rPr>
-                        <a:t>Complete</a:t>
-                      </a:r>
-                    </a:p>
-                  </a:txBody>
-                  <a:tcPr marL="73152" marR="73152" marT="36576" marB="36576">
-                    <a:solidFill>
-                      <a:srgbClr val="FCFCFB"/>
-                    </a:solidFill>
-                  </a:tcPr>
-                </a:tc>
-              </a:tr>
-              <a:tr h="384048">
-                <a:tc>
-                  <a:txBody>
-                    <a:bodyPr/>
-                    <a:lstStyle/>
-                    <a:p>
-                      <a:pPr>
-                        <a:lnSpc>
-                          <a:spcPct val="115000"/>
-                        </a:lnSpc>
-                      </a:pPr>
-                      <a:r>
-                        <a:rPr sz="1250" b="0">
-                          <a:solidFill>
-                            <a:srgbClr val="16181A"/>
-                          </a:solidFill>
-                          <a:latin typeface="Arial"/>
-                        </a:rPr>
-                        <a:t>M2</a:t>
-                      </a:r>
-                    </a:p>
-                  </a:txBody>
-                  <a:tcPr marL="73152" marR="73152" marT="36576" marB="36576">
-                    <a:solidFill>
-                      <a:srgbClr val="FCFCFB"/>
-                    </a:solidFill>
-                  </a:tcPr>
-                </a:tc>
-                <a:tc>
-                  <a:txBody>
-                    <a:bodyPr/>
-                    <a:lstStyle/>
-                    <a:p>
-                      <a:pPr>
-                        <a:lnSpc>
-                          <a:spcPct val="115000"/>
-                        </a:lnSpc>
-                      </a:pPr>
-                      <a:r>
-                        <a:rPr sz="1250" b="0">
-                          <a:solidFill>
-                            <a:srgbClr val="16181A"/>
-                          </a:solidFill>
-                          <a:latin typeface="Arial"/>
-                        </a:rPr>
-                        <a:t>Director and counter-moves, validated headless</a:t>
-                      </a:r>
-                    </a:p>
-                  </a:txBody>
-                  <a:tcPr marL="73152" marR="73152" marT="36576" marB="36576">
-                    <a:solidFill>
-                      <a:srgbClr val="FCFCFB"/>
-                    </a:solidFill>
-                  </a:tcPr>
-                </a:tc>
-                <a:tc>
-                  <a:txBody>
-                    <a:bodyPr/>
-                    <a:lstStyle/>
-                    <a:p>
-                      <a:pPr>
-                        <a:lnSpc>
-                          <a:spcPct val="115000"/>
-                        </a:lnSpc>
-                      </a:pPr>
-                      <a:r>
-                        <a:rPr sz="1250" b="0">
-                          <a:solidFill>
-                            <a:srgbClr val="16181A"/>
-                          </a:solidFill>
-                          <a:latin typeface="Arial"/>
-                        </a:rPr>
-                        <a:t>Complete</a:t>
-                      </a:r>
-                    </a:p>
-                  </a:txBody>
-                  <a:tcPr marL="73152" marR="73152" marT="36576" marB="36576">
-                    <a:solidFill>
-                      <a:srgbClr val="FCFCFB"/>
-                    </a:solidFill>
-                  </a:tcPr>
-                </a:tc>
-              </a:tr>
-              <a:tr h="384048">
-                <a:tc>
-                  <a:txBody>
-                    <a:bodyPr/>
-                    <a:lstStyle/>
-                    <a:p>
-                      <a:pPr>
-                        <a:lnSpc>
-                          <a:spcPct val="115000"/>
-                        </a:lnSpc>
-                      </a:pPr>
-                      <a:r>
-                        <a:rPr sz="1250" b="0">
-                          <a:solidFill>
-                            <a:srgbClr val="16181A"/>
-                          </a:solidFill>
-                          <a:latin typeface="Arial"/>
-                        </a:rPr>
-                        <a:t>M3</a:t>
-                      </a:r>
-                    </a:p>
-                  </a:txBody>
-                  <a:tcPr marL="73152" marR="73152" marT="36576" marB="36576">
-                    <a:solidFill>
-                      <a:srgbClr val="FCFCFB"/>
-                    </a:solidFill>
-                  </a:tcPr>
-                </a:tc>
-                <a:tc>
-                  <a:txBody>
-                    <a:bodyPr/>
-                    <a:lstStyle/>
-                    <a:p>
-                      <a:pPr>
-                        <a:lnSpc>
-                          <a:spcPct val="115000"/>
-                        </a:lnSpc>
-                      </a:pPr>
-                      <a:r>
-                        <a:rPr sz="1250" b="0">
-                          <a:solidFill>
-                            <a:srgbClr val="16181A"/>
-                          </a:solidFill>
-                          <a:latin typeface="Arial"/>
-                        </a:rPr>
-                        <a:t>Godot greybox first-person build + live prediction overlay</a:t>
-                      </a:r>
-                    </a:p>
-                  </a:txBody>
-                  <a:tcPr marL="73152" marR="73152" marT="36576" marB="36576">
-                    <a:solidFill>
-                      <a:srgbClr val="FCFCFB"/>
-                    </a:solidFill>
-                  </a:tcPr>
-                </a:tc>
-                <a:tc>
-                  <a:txBody>
-                    <a:bodyPr/>
-                    <a:lstStyle/>
-                    <a:p>
-                      <a:pPr>
-                        <a:lnSpc>
-                          <a:spcPct val="115000"/>
-                        </a:lnSpc>
-                      </a:pPr>
-                      <a:r>
-                        <a:rPr sz="1250" b="0">
-                          <a:solidFill>
-                            <a:srgbClr val="16181A"/>
-                          </a:solidFill>
-                          <a:latin typeface="Arial"/>
-                        </a:rPr>
-                        <a:t>Next</a:t>
-                      </a:r>
-                    </a:p>
-                  </a:txBody>
-                  <a:tcPr marL="73152" marR="73152" marT="36576" marB="36576">
-                    <a:solidFill>
-                      <a:srgbClr val="FCFCFB"/>
-                    </a:solidFill>
-                  </a:tcPr>
-                </a:tc>
-              </a:tr>
-              <a:tr h="384048">
-                <a:tc>
-                  <a:txBody>
-                    <a:bodyPr/>
-                    <a:lstStyle/>
-                    <a:p>
-                      <a:pPr>
-                        <a:lnSpc>
-                          <a:spcPct val="115000"/>
-                        </a:lnSpc>
-                      </a:pPr>
-                      <a:r>
-                        <a:rPr sz="1250" b="0">
-                          <a:solidFill>
-                            <a:srgbClr val="16181A"/>
-                          </a:solidFill>
-                          <a:latin typeface="Arial"/>
-                        </a:rPr>
-                        <a:t>M4</a:t>
-                      </a:r>
-                    </a:p>
-                  </a:txBody>
-                  <a:tcPr marL="73152" marR="73152" marT="36576" marB="36576">
-                    <a:solidFill>
-                      <a:srgbClr val="FCFCFB"/>
-                    </a:solidFill>
-                  </a:tcPr>
-                </a:tc>
-                <a:tc>
-                  <a:txBody>
-                    <a:bodyPr/>
-                    <a:lstStyle/>
-                    <a:p>
-                      <a:pPr>
-                        <a:lnSpc>
-                          <a:spcPct val="115000"/>
-                        </a:lnSpc>
-                      </a:pPr>
-                      <a:r>
-                        <a:rPr sz="1250" b="0">
-                          <a:solidFill>
-                            <a:srgbClr val="16181A"/>
-                          </a:solidFill>
-                          <a:latin typeface="Arial"/>
-                        </a:rPr>
-                        <a:t>Notebook vector editor and persistence</a:t>
-                      </a:r>
-                    </a:p>
-                  </a:txBody>
-                  <a:tcPr marL="73152" marR="73152" marT="36576" marB="36576">
-                    <a:solidFill>
-                      <a:srgbClr val="FCFCFB"/>
-                    </a:solidFill>
-                  </a:tcPr>
-                </a:tc>
-                <a:tc>
-                  <a:txBody>
-                    <a:bodyPr/>
-                    <a:lstStyle/>
-                    <a:p>
-                      <a:pPr>
-                        <a:lnSpc>
-                          <a:spcPct val="115000"/>
-                        </a:lnSpc>
-                      </a:pPr>
-                      <a:r>
-                        <a:rPr sz="1250" b="0">
-                          <a:solidFill>
-                            <a:srgbClr val="16181A"/>
-                          </a:solidFill>
-                          <a:latin typeface="Arial"/>
-                        </a:rPr>
-                        <a:t>Planned</a:t>
-                      </a:r>
-                    </a:p>
-                  </a:txBody>
-                  <a:tcPr marL="73152" marR="73152" marT="36576" marB="36576">
-                    <a:solidFill>
-                      <a:srgbClr val="FCFCFB"/>
-                    </a:solidFill>
-                  </a:tcPr>
-                </a:tc>
-              </a:tr>
-              <a:tr h="384048">
-                <a:tc>
-                  <a:txBody>
-                    <a:bodyPr/>
-                    <a:lstStyle/>
-                    <a:p>
-                      <a:pPr>
-                        <a:lnSpc>
-                          <a:spcPct val="115000"/>
-                        </a:lnSpc>
-                      </a:pPr>
-                      <a:r>
-                        <a:rPr sz="1250" b="0">
-                          <a:solidFill>
-                            <a:srgbClr val="16181A"/>
-                          </a:solidFill>
-                          <a:latin typeface="Arial"/>
-                        </a:rPr>
-                        <a:t>M5</a:t>
-                      </a:r>
-                    </a:p>
-                  </a:txBody>
-                  <a:tcPr marL="73152" marR="73152" marT="36576" marB="36576">
-                    <a:solidFill>
-                      <a:srgbClr val="FCFCFB"/>
-                    </a:solidFill>
-                  </a:tcPr>
-                </a:tc>
-                <a:tc>
-                  <a:txBody>
-                    <a:bodyPr/>
-                    <a:lstStyle/>
-                    <a:p>
-                      <a:pPr>
-                        <a:lnSpc>
-                          <a:spcPct val="115000"/>
-                        </a:lnSpc>
-                      </a:pPr>
-                      <a:r>
-                        <a:rPr sz="1250" b="0">
-                          <a:solidFill>
-                            <a:srgbClr val="16181A"/>
-                          </a:solidFill>
-                          <a:latin typeface="Arial"/>
-                        </a:rPr>
-                        <a:t>Entity polish, atmosphere, audio, human playtest</a:t>
-                      </a:r>
-                    </a:p>
-                  </a:txBody>
-                  <a:tcPr marL="73152" marR="73152" marT="36576" marB="36576">
-                    <a:solidFill>
-                      <a:srgbClr val="FCFCFB"/>
-                    </a:solidFill>
-                  </a:tcPr>
-                </a:tc>
-                <a:tc>
-                  <a:txBody>
-                    <a:bodyPr/>
-                    <a:lstStyle/>
-                    <a:p>
-                      <a:pPr>
-                        <a:lnSpc>
-                          <a:spcPct val="115000"/>
-                        </a:lnSpc>
-                      </a:pPr>
-                      <a:r>
-                        <a:rPr sz="1250" b="0">
-                          <a:solidFill>
-                            <a:srgbClr val="16181A"/>
-                          </a:solidFill>
-                          <a:latin typeface="Arial"/>
-                        </a:rPr>
-                        <a:t>Planned</a:t>
-                      </a:r>
-                    </a:p>
-                  </a:txBody>
-                  <a:tcPr marL="73152" marR="73152" marT="36576" marB="36576">
-                    <a:solidFill>
-                      <a:srgbClr val="FCFCFB"/>
-                    </a:solidFill>
-                  </a:tcPr>
-                </a:tc>
-              </a:tr>
-              <a:tr h="384048">
-                <a:tc>
-                  <a:txBody>
-                    <a:bodyPr/>
-                    <a:lstStyle/>
-                    <a:p>
-                      <a:pPr>
-                        <a:lnSpc>
-                          <a:spcPct val="115000"/>
-                        </a:lnSpc>
-                      </a:pPr>
-                      <a:r>
-                        <a:rPr sz="1250" b="0">
-                          <a:solidFill>
-                            <a:srgbClr val="16181A"/>
-                          </a:solidFill>
-                          <a:latin typeface="Arial"/>
-                        </a:rPr>
-                        <a:t>M6</a:t>
-                      </a:r>
-                    </a:p>
-                  </a:txBody>
-                  <a:tcPr marL="73152" marR="73152" marT="36576" marB="36576">
-                    <a:solidFill>
-                      <a:srgbClr val="FCFCFB"/>
-                    </a:solidFill>
-                  </a:tcPr>
-                </a:tc>
-                <a:tc>
-                  <a:txBody>
-                    <a:bodyPr/>
-                    <a:lstStyle/>
-                    <a:p>
-                      <a:pPr>
-                        <a:lnSpc>
-                          <a:spcPct val="115000"/>
-                        </a:lnSpc>
-                      </a:pPr>
-                      <a:r>
-                        <a:rPr sz="1250" b="0">
-                          <a:solidFill>
-                            <a:srgbClr val="16181A"/>
-                          </a:solidFill>
-                          <a:latin typeface="Arial"/>
-                        </a:rPr>
-                        <a:t>Door motion-sensors — partial observation, so waiting conceals</a:t>
-                      </a:r>
-                    </a:p>
-                  </a:txBody>
-                  <a:tcPr marL="73152" marR="73152" marT="36576" marB="36576">
-                    <a:solidFill>
-                      <a:srgbClr val="FCFCFB"/>
-                    </a:solidFill>
-                  </a:tcPr>
-                </a:tc>
-                <a:tc>
-                  <a:txBody>
-                    <a:bodyPr/>
-                    <a:lstStyle/>
-                    <a:p>
-                      <a:pPr>
-                        <a:lnSpc>
-                          <a:spcPct val="115000"/>
-                        </a:lnSpc>
-                      </a:pPr>
-                      <a:r>
-                        <a:rPr sz="1250" b="0">
-                          <a:solidFill>
-                            <a:srgbClr val="16181A"/>
-                          </a:solidFill>
-                          <a:latin typeface="Arial"/>
-                        </a:rPr>
-                        <a:t>Specified</a:t>
-                      </a:r>
-                    </a:p>
-                  </a:txBody>
-                  <a:tcPr marL="73152" marR="73152" marT="36576" marB="36576">
-                    <a:solidFill>
-                      <a:srgbClr val="FCFCFB"/>
-                    </a:solidFill>
-                  </a:tcPr>
-                </a:tc>
-              </a:tr>
-              <a:tr h="384048">
-                <a:tc>
-                  <a:txBody>
-                    <a:bodyPr/>
-                    <a:lstStyle/>
-                    <a:p>
-                      <a:pPr>
-                        <a:lnSpc>
-                          <a:spcPct val="115000"/>
-                        </a:lnSpc>
-                      </a:pPr>
-                      <a:r>
-                        <a:rPr sz="1250" b="0">
-                          <a:solidFill>
-                            <a:srgbClr val="16181A"/>
-                          </a:solidFill>
-                          <a:latin typeface="Arial"/>
-                        </a:rPr>
-                        <a:t>M7</a:t>
-                      </a:r>
-                    </a:p>
-                  </a:txBody>
-                  <a:tcPr marL="73152" marR="73152" marT="36576" marB="36576">
-                    <a:solidFill>
-                      <a:srgbClr val="FCFCFB"/>
-                    </a:solidFill>
-                  </a:tcPr>
-                </a:tc>
-                <a:tc>
-                  <a:txBody>
-                    <a:bodyPr/>
-                    <a:lstStyle/>
-                    <a:p>
-                      <a:pPr>
-                        <a:lnSpc>
-                          <a:spcPct val="115000"/>
-                        </a:lnSpc>
-                      </a:pPr>
-                      <a:r>
-                        <a:rPr sz="1250" b="0">
-                          <a:solidFill>
-                            <a:srgbClr val="16181A"/>
-                          </a:solidFill>
-                          <a:latin typeface="Arial"/>
-                        </a:rPr>
-                        <a:t>Polygonal room tiles; side count is the difficulty setting</a:t>
-                      </a:r>
-                    </a:p>
-                  </a:txBody>
-                  <a:tcPr marL="73152" marR="73152" marT="36576" marB="36576">
-                    <a:solidFill>
-                      <a:srgbClr val="FCFCFB"/>
-                    </a:solidFill>
-                  </a:tcPr>
-                </a:tc>
-                <a:tc>
-                  <a:txBody>
-                    <a:bodyPr/>
-                    <a:lstStyle/>
-                    <a:p>
-                      <a:pPr>
-                        <a:lnSpc>
-                          <a:spcPct val="115000"/>
-                        </a:lnSpc>
-                      </a:pPr>
-                      <a:r>
-                        <a:rPr sz="1250" b="0">
-                          <a:solidFill>
-                            <a:srgbClr val="16181A"/>
-                          </a:solidFill>
-                          <a:latin typeface="Arial"/>
-                        </a:rPr>
-                        <a:t>Specified</a:t>
-                      </a:r>
-                    </a:p>
-                  </a:txBody>
-                  <a:tcPr marL="73152" marR="73152" marT="36576" marB="36576">
-                    <a:solidFill>
-                      <a:srgbClr val="FCFCFB"/>
-                    </a:solidFill>
-                  </a:tcPr>
-                </a:tc>
-              </a:tr>
-              <a:tr h="384048">
-                <a:tc>
-                  <a:txBody>
-                    <a:bodyPr/>
-                    <a:lstStyle/>
-                    <a:p>
-                      <a:pPr>
-                        <a:lnSpc>
-                          <a:spcPct val="115000"/>
-                        </a:lnSpc>
-                      </a:pPr>
-                      <a:r>
-                        <a:rPr sz="1250" b="0">
-                          <a:solidFill>
-                            <a:srgbClr val="16181A"/>
-                          </a:solidFill>
-                          <a:latin typeface="Arial"/>
-                        </a:rPr>
-                        <a:t>M8</a:t>
-                      </a:r>
-                    </a:p>
-                  </a:txBody>
-                  <a:tcPr marL="73152" marR="73152" marT="36576" marB="36576">
-                    <a:solidFill>
-                      <a:srgbClr val="FCFCFB"/>
-                    </a:solidFill>
-                  </a:tcPr>
-                </a:tc>
-                <a:tc>
-                  <a:txBody>
-                    <a:bodyPr/>
-                    <a:lstStyle/>
-                    <a:p>
-                      <a:pPr>
-                        <a:lnSpc>
-                          <a:spcPct val="115000"/>
-                        </a:lnSpc>
-                      </a:pPr>
-                      <a:r>
-                        <a:rPr sz="1250" b="0">
-                          <a:solidFill>
-                            <a:srgbClr val="16181A"/>
-                          </a:solidFill>
-                          <a:latin typeface="Arial"/>
-                        </a:rPr>
-                        <a:t>Outbound register with pre-send tampering; sensor blackouts</a:t>
-                      </a:r>
-                    </a:p>
-                  </a:txBody>
-                  <a:tcPr marL="73152" marR="73152" marT="36576" marB="36576">
-                    <a:solidFill>
-                      <a:srgbClr val="FCFCFB"/>
-                    </a:solidFill>
-                  </a:tcPr>
-                </a:tc>
-                <a:tc>
-                  <a:txBody>
-                    <a:bodyPr/>
-                    <a:lstStyle/>
-                    <a:p>
-                      <a:pPr>
-                        <a:lnSpc>
-                          <a:spcPct val="115000"/>
-                        </a:lnSpc>
-                      </a:pPr>
-                      <a:r>
-                        <a:rPr sz="1250" b="0">
-                          <a:solidFill>
-                            <a:srgbClr val="16181A"/>
-                          </a:solidFill>
-                          <a:latin typeface="Arial"/>
-                        </a:rPr>
-                        <a:t>Specified</a:t>
-                      </a:r>
-                    </a:p>
-                  </a:txBody>
-                  <a:tcPr marL="73152" marR="73152" marT="36576" marB="36576">
-                    <a:solidFill>
-                      <a:srgbClr val="FCFCFB"/>
-                    </a:solidFill>
-                  </a:tcPr>
-                </a:tc>
-              </a:tr>
-            </a:tbl>
-          </a:graphicData>
-        </a:graphic>
-      </p:graphicFrame>
+        </p:nvPicPr>
+        <p:blipFill>
+          <a:blip r:embed="rId2"/>
+          <a:stretch>
+            <a:fillRect/>
+          </a:stretch>
+        </p:blipFill>
+        <p:spPr>
+          <a:xfrm>
+            <a:off x="2606040" y="1691640"/>
+            <a:ext cx="7040880" cy="3960495"/>
+          </a:xfrm>
+          <a:prstGeom prst="rect">
+            <a:avLst/>
+          </a:prstGeom>
+        </p:spPr>
+      </p:pic>
       <p:sp>
         <p:nvSpPr>
           <p:cNvPr id="6" name="TextBox 5"/>
@@ -15039,8 +14207,8 @@
         </p:nvSpPr>
         <p:spPr>
           <a:xfrm>
-            <a:off x="658368" y="4663440"/>
-            <a:ext cx="10881360" cy="1097280"/>
+            <a:off x="658368" y="5623560"/>
+            <a:ext cx="10881360" cy="960120"/>
           </a:xfrm>
           <a:prstGeom prst="rect">
             <a:avLst/>
@@ -15055,20 +14223,20 @@
           <a:p>
             <a:pPr algn="l">
               <a:lnSpc>
-                <a:spcPct val="135000"/>
+                <a:spcPct val="130000"/>
               </a:lnSpc>
               <a:spcAft>
                 <a:spcPts val="600"/>
               </a:spcAft>
             </a:pPr>
             <a:r>
-              <a:rPr sz="1300" b="0">
+              <a:rPr sz="1250" b="0">
                 <a:solidFill>
                   <a:srgbClr val="6B7178"/>
                 </a:solidFill>
                 <a:latin typeface="Arial"/>
               </a:rPr>
-              <a:t>Art direction for M3 is settled: a low-poly modular brutalist kit instantiated from the room graph, near-total darkness with a flashlight, heavy fog, and a retro post-processing pass — chosen because it minimises modelling cost while staying coherent. Modularity is not a style choice: rooms are rotated, added and removed at runtime, so they must be prefab-instantiated regardless.</a:t>
+              <a:t>Three hexagonal cells built from the same room graph the model plays on — low-poly concrete, a single handheld light, heavy fog, and a retro pass (420x236 internal resolution, ordered dither, colour quantisation, vignette). Hand-written WebGL, no engine and no libraries, so it runs offline in any browser. This is the art-direction target for M3, not the game.</a:t>
             </a:r>
           </a:p>
         </p:txBody>
@@ -15136,7 +14304,7 @@
                 </a:solidFill>
                 <a:latin typeface="Arial"/>
               </a:rPr>
-              <a:t>REFERENCES</a:t>
+              <a:t>25 · ROADMAP</a:t>
             </a:r>
           </a:p>
         </p:txBody>
@@ -15178,7 +14346,7 @@
                 </a:solidFill>
                 <a:latin typeface="Arial"/>
               </a:rPr>
-              <a:t>1 of 2</a:t>
+              <a:t>Three of nine milestones complete</a:t>
             </a:r>
           </a:p>
         </p:txBody>
@@ -15227,6 +14395,1059 @@
           </a:p>
         </p:txBody>
       </p:sp>
+      <p:graphicFrame>
+        <p:nvGraphicFramePr>
+          <p:cNvPr id="5" name="Table 4"/>
+          <p:cNvGraphicFramePr>
+            <a:graphicFrameLocks noGrp="1"/>
+          </p:cNvGraphicFramePr>
+          <p:nvPr/>
+        </p:nvGraphicFramePr>
+        <p:xfrm>
+          <a:off x="658368" y="1783080"/>
+          <a:ext cx="10881360" cy="3840480"/>
+        </p:xfrm>
+        <a:graphic>
+          <a:graphicData uri="http://schemas.openxmlformats.org/drawingml/2006/table">
+            <a:tbl>
+              <a:tblPr firstRow="1" bandRow="1">
+                <a:tableStyleId>{5C22544A-7EE6-4342-B048-85BDC9FD1C3A}</a:tableStyleId>
+              </a:tblPr>
+              <a:tblGrid>
+                <a:gridCol w="1188720"/>
+                <a:gridCol w="7680960"/>
+                <a:gridCol w="2011680"/>
+              </a:tblGrid>
+              <a:tr h="384048">
+                <a:tc>
+                  <a:txBody>
+                    <a:bodyPr/>
+                    <a:lstStyle/>
+                    <a:p>
+                      <a:pPr>
+                        <a:lnSpc>
+                          <a:spcPct val="115000"/>
+                        </a:lnSpc>
+                      </a:pPr>
+                      <a:r>
+                        <a:rPr sz="950" b="1">
+                          <a:solidFill>
+                            <a:srgbClr val="6B7178"/>
+                          </a:solidFill>
+                          <a:latin typeface="Arial"/>
+                        </a:rPr>
+                        <a:t>Milestone</a:t>
+                      </a:r>
+                    </a:p>
+                  </a:txBody>
+                  <a:tcPr marL="73152" marR="73152" marT="36576" marB="36576">
+                    <a:solidFill>
+                      <a:srgbClr val="F4F6F8"/>
+                    </a:solidFill>
+                  </a:tcPr>
+                </a:tc>
+                <a:tc>
+                  <a:txBody>
+                    <a:bodyPr/>
+                    <a:lstStyle/>
+                    <a:p>
+                      <a:pPr>
+                        <a:lnSpc>
+                          <a:spcPct val="115000"/>
+                        </a:lnSpc>
+                      </a:pPr>
+                      <a:r>
+                        <a:rPr sz="950" b="1">
+                          <a:solidFill>
+                            <a:srgbClr val="6B7178"/>
+                          </a:solidFill>
+                          <a:latin typeface="Arial"/>
+                        </a:rPr>
+                        <a:t>Deliverable</a:t>
+                      </a:r>
+                    </a:p>
+                  </a:txBody>
+                  <a:tcPr marL="73152" marR="73152" marT="36576" marB="36576">
+                    <a:solidFill>
+                      <a:srgbClr val="F4F6F8"/>
+                    </a:solidFill>
+                  </a:tcPr>
+                </a:tc>
+                <a:tc>
+                  <a:txBody>
+                    <a:bodyPr/>
+                    <a:lstStyle/>
+                    <a:p>
+                      <a:pPr>
+                        <a:lnSpc>
+                          <a:spcPct val="115000"/>
+                        </a:lnSpc>
+                      </a:pPr>
+                      <a:r>
+                        <a:rPr sz="950" b="1">
+                          <a:solidFill>
+                            <a:srgbClr val="6B7178"/>
+                          </a:solidFill>
+                          <a:latin typeface="Arial"/>
+                        </a:rPr>
+                        <a:t>State</a:t>
+                      </a:r>
+                    </a:p>
+                  </a:txBody>
+                  <a:tcPr marL="73152" marR="73152" marT="36576" marB="36576">
+                    <a:solidFill>
+                      <a:srgbClr val="F4F6F8"/>
+                    </a:solidFill>
+                  </a:tcPr>
+                </a:tc>
+              </a:tr>
+              <a:tr h="384048">
+                <a:tc>
+                  <a:txBody>
+                    <a:bodyPr/>
+                    <a:lstStyle/>
+                    <a:p>
+                      <a:pPr>
+                        <a:lnSpc>
+                          <a:spcPct val="115000"/>
+                        </a:lnSpc>
+                      </a:pPr>
+                      <a:r>
+                        <a:rPr sz="1250" b="0">
+                          <a:solidFill>
+                            <a:srgbClr val="16181A"/>
+                          </a:solidFill>
+                          <a:latin typeface="Arial"/>
+                        </a:rPr>
+                        <a:t>M0</a:t>
+                      </a:r>
+                    </a:p>
+                  </a:txBody>
+                  <a:tcPr marL="73152" marR="73152" marT="36576" marB="36576">
+                    <a:solidFill>
+                      <a:srgbClr val="FCFCFB"/>
+                    </a:solidFill>
+                  </a:tcPr>
+                </a:tc>
+                <a:tc>
+                  <a:txBody>
+                    <a:bodyPr/>
+                    <a:lstStyle/>
+                    <a:p>
+                      <a:pPr>
+                        <a:lnSpc>
+                          <a:spcPct val="115000"/>
+                        </a:lnSpc>
+                      </a:pPr>
+                      <a:r>
+                        <a:rPr sz="1250" b="0">
+                          <a:solidFill>
+                            <a:srgbClr val="16181A"/>
+                          </a:solidFill>
+                          <a:latin typeface="Arial"/>
+                        </a:rPr>
+                        <a:t>Headless simulation core, telemetry, bot harness</a:t>
+                      </a:r>
+                    </a:p>
+                  </a:txBody>
+                  <a:tcPr marL="73152" marR="73152" marT="36576" marB="36576">
+                    <a:solidFill>
+                      <a:srgbClr val="FCFCFB"/>
+                    </a:solidFill>
+                  </a:tcPr>
+                </a:tc>
+                <a:tc>
+                  <a:txBody>
+                    <a:bodyPr/>
+                    <a:lstStyle/>
+                    <a:p>
+                      <a:pPr>
+                        <a:lnSpc>
+                          <a:spcPct val="115000"/>
+                        </a:lnSpc>
+                      </a:pPr>
+                      <a:r>
+                        <a:rPr sz="1250" b="0">
+                          <a:solidFill>
+                            <a:srgbClr val="16181A"/>
+                          </a:solidFill>
+                          <a:latin typeface="Arial"/>
+                        </a:rPr>
+                        <a:t>Complete</a:t>
+                      </a:r>
+                    </a:p>
+                  </a:txBody>
+                  <a:tcPr marL="73152" marR="73152" marT="36576" marB="36576">
+                    <a:solidFill>
+                      <a:srgbClr val="FCFCFB"/>
+                    </a:solidFill>
+                  </a:tcPr>
+                </a:tc>
+              </a:tr>
+              <a:tr h="384048">
+                <a:tc>
+                  <a:txBody>
+                    <a:bodyPr/>
+                    <a:lstStyle/>
+                    <a:p>
+                      <a:pPr>
+                        <a:lnSpc>
+                          <a:spcPct val="115000"/>
+                        </a:lnSpc>
+                      </a:pPr>
+                      <a:r>
+                        <a:rPr sz="1250" b="0">
+                          <a:solidFill>
+                            <a:srgbClr val="16181A"/>
+                          </a:solidFill>
+                          <a:latin typeface="Arial"/>
+                        </a:rPr>
+                        <a:t>M1</a:t>
+                      </a:r>
+                    </a:p>
+                  </a:txBody>
+                  <a:tcPr marL="73152" marR="73152" marT="36576" marB="36576">
+                    <a:solidFill>
+                      <a:srgbClr val="FCFCFB"/>
+                    </a:solidFill>
+                  </a:tcPr>
+                </a:tc>
+                <a:tc>
+                  <a:txBody>
+                    <a:bodyPr/>
+                    <a:lstStyle/>
+                    <a:p>
+                      <a:pPr>
+                        <a:lnSpc>
+                          <a:spcPct val="115000"/>
+                        </a:lnSpc>
+                      </a:pPr>
+                      <a:r>
+                        <a:rPr sz="1250" b="0">
+                          <a:solidFill>
+                            <a:srgbClr val="16181A"/>
+                          </a:solidFill>
+                          <a:latin typeface="Arial"/>
+                        </a:rPr>
+                        <a:t>Predictor, baselines, controls, offline metrics and figures</a:t>
+                      </a:r>
+                    </a:p>
+                  </a:txBody>
+                  <a:tcPr marL="73152" marR="73152" marT="36576" marB="36576">
+                    <a:solidFill>
+                      <a:srgbClr val="FCFCFB"/>
+                    </a:solidFill>
+                  </a:tcPr>
+                </a:tc>
+                <a:tc>
+                  <a:txBody>
+                    <a:bodyPr/>
+                    <a:lstStyle/>
+                    <a:p>
+                      <a:pPr>
+                        <a:lnSpc>
+                          <a:spcPct val="115000"/>
+                        </a:lnSpc>
+                      </a:pPr>
+                      <a:r>
+                        <a:rPr sz="1250" b="0">
+                          <a:solidFill>
+                            <a:srgbClr val="16181A"/>
+                          </a:solidFill>
+                          <a:latin typeface="Arial"/>
+                        </a:rPr>
+                        <a:t>Complete</a:t>
+                      </a:r>
+                    </a:p>
+                  </a:txBody>
+                  <a:tcPr marL="73152" marR="73152" marT="36576" marB="36576">
+                    <a:solidFill>
+                      <a:srgbClr val="FCFCFB"/>
+                    </a:solidFill>
+                  </a:tcPr>
+                </a:tc>
+              </a:tr>
+              <a:tr h="384048">
+                <a:tc>
+                  <a:txBody>
+                    <a:bodyPr/>
+                    <a:lstStyle/>
+                    <a:p>
+                      <a:pPr>
+                        <a:lnSpc>
+                          <a:spcPct val="115000"/>
+                        </a:lnSpc>
+                      </a:pPr>
+                      <a:r>
+                        <a:rPr sz="1250" b="0">
+                          <a:solidFill>
+                            <a:srgbClr val="16181A"/>
+                          </a:solidFill>
+                          <a:latin typeface="Arial"/>
+                        </a:rPr>
+                        <a:t>M2</a:t>
+                      </a:r>
+                    </a:p>
+                  </a:txBody>
+                  <a:tcPr marL="73152" marR="73152" marT="36576" marB="36576">
+                    <a:solidFill>
+                      <a:srgbClr val="FCFCFB"/>
+                    </a:solidFill>
+                  </a:tcPr>
+                </a:tc>
+                <a:tc>
+                  <a:txBody>
+                    <a:bodyPr/>
+                    <a:lstStyle/>
+                    <a:p>
+                      <a:pPr>
+                        <a:lnSpc>
+                          <a:spcPct val="115000"/>
+                        </a:lnSpc>
+                      </a:pPr>
+                      <a:r>
+                        <a:rPr sz="1250" b="0">
+                          <a:solidFill>
+                            <a:srgbClr val="16181A"/>
+                          </a:solidFill>
+                          <a:latin typeface="Arial"/>
+                        </a:rPr>
+                        <a:t>Director and counter-moves, validated headless</a:t>
+                      </a:r>
+                    </a:p>
+                  </a:txBody>
+                  <a:tcPr marL="73152" marR="73152" marT="36576" marB="36576">
+                    <a:solidFill>
+                      <a:srgbClr val="FCFCFB"/>
+                    </a:solidFill>
+                  </a:tcPr>
+                </a:tc>
+                <a:tc>
+                  <a:txBody>
+                    <a:bodyPr/>
+                    <a:lstStyle/>
+                    <a:p>
+                      <a:pPr>
+                        <a:lnSpc>
+                          <a:spcPct val="115000"/>
+                        </a:lnSpc>
+                      </a:pPr>
+                      <a:r>
+                        <a:rPr sz="1250" b="0">
+                          <a:solidFill>
+                            <a:srgbClr val="16181A"/>
+                          </a:solidFill>
+                          <a:latin typeface="Arial"/>
+                        </a:rPr>
+                        <a:t>Complete</a:t>
+                      </a:r>
+                    </a:p>
+                  </a:txBody>
+                  <a:tcPr marL="73152" marR="73152" marT="36576" marB="36576">
+                    <a:solidFill>
+                      <a:srgbClr val="FCFCFB"/>
+                    </a:solidFill>
+                  </a:tcPr>
+                </a:tc>
+              </a:tr>
+              <a:tr h="384048">
+                <a:tc>
+                  <a:txBody>
+                    <a:bodyPr/>
+                    <a:lstStyle/>
+                    <a:p>
+                      <a:pPr>
+                        <a:lnSpc>
+                          <a:spcPct val="115000"/>
+                        </a:lnSpc>
+                      </a:pPr>
+                      <a:r>
+                        <a:rPr sz="1250" b="0">
+                          <a:solidFill>
+                            <a:srgbClr val="16181A"/>
+                          </a:solidFill>
+                          <a:latin typeface="Arial"/>
+                        </a:rPr>
+                        <a:t>M3</a:t>
+                      </a:r>
+                    </a:p>
+                  </a:txBody>
+                  <a:tcPr marL="73152" marR="73152" marT="36576" marB="36576">
+                    <a:solidFill>
+                      <a:srgbClr val="FCFCFB"/>
+                    </a:solidFill>
+                  </a:tcPr>
+                </a:tc>
+                <a:tc>
+                  <a:txBody>
+                    <a:bodyPr/>
+                    <a:lstStyle/>
+                    <a:p>
+                      <a:pPr>
+                        <a:lnSpc>
+                          <a:spcPct val="115000"/>
+                        </a:lnSpc>
+                      </a:pPr>
+                      <a:r>
+                        <a:rPr sz="1250" b="0">
+                          <a:solidFill>
+                            <a:srgbClr val="16181A"/>
+                          </a:solidFill>
+                          <a:latin typeface="Arial"/>
+                        </a:rPr>
+                        <a:t>Godot greybox first-person build + live prediction overlay</a:t>
+                      </a:r>
+                    </a:p>
+                  </a:txBody>
+                  <a:tcPr marL="73152" marR="73152" marT="36576" marB="36576">
+                    <a:solidFill>
+                      <a:srgbClr val="FCFCFB"/>
+                    </a:solidFill>
+                  </a:tcPr>
+                </a:tc>
+                <a:tc>
+                  <a:txBody>
+                    <a:bodyPr/>
+                    <a:lstStyle/>
+                    <a:p>
+                      <a:pPr>
+                        <a:lnSpc>
+                          <a:spcPct val="115000"/>
+                        </a:lnSpc>
+                      </a:pPr>
+                      <a:r>
+                        <a:rPr sz="1250" b="0">
+                          <a:solidFill>
+                            <a:srgbClr val="16181A"/>
+                          </a:solidFill>
+                          <a:latin typeface="Arial"/>
+                        </a:rPr>
+                        <a:t>Next</a:t>
+                      </a:r>
+                    </a:p>
+                  </a:txBody>
+                  <a:tcPr marL="73152" marR="73152" marT="36576" marB="36576">
+                    <a:solidFill>
+                      <a:srgbClr val="FCFCFB"/>
+                    </a:solidFill>
+                  </a:tcPr>
+                </a:tc>
+              </a:tr>
+              <a:tr h="384048">
+                <a:tc>
+                  <a:txBody>
+                    <a:bodyPr/>
+                    <a:lstStyle/>
+                    <a:p>
+                      <a:pPr>
+                        <a:lnSpc>
+                          <a:spcPct val="115000"/>
+                        </a:lnSpc>
+                      </a:pPr>
+                      <a:r>
+                        <a:rPr sz="1250" b="0">
+                          <a:solidFill>
+                            <a:srgbClr val="16181A"/>
+                          </a:solidFill>
+                          <a:latin typeface="Arial"/>
+                        </a:rPr>
+                        <a:t>M4</a:t>
+                      </a:r>
+                    </a:p>
+                  </a:txBody>
+                  <a:tcPr marL="73152" marR="73152" marT="36576" marB="36576">
+                    <a:solidFill>
+                      <a:srgbClr val="FCFCFB"/>
+                    </a:solidFill>
+                  </a:tcPr>
+                </a:tc>
+                <a:tc>
+                  <a:txBody>
+                    <a:bodyPr/>
+                    <a:lstStyle/>
+                    <a:p>
+                      <a:pPr>
+                        <a:lnSpc>
+                          <a:spcPct val="115000"/>
+                        </a:lnSpc>
+                      </a:pPr>
+                      <a:r>
+                        <a:rPr sz="1250" b="0">
+                          <a:solidFill>
+                            <a:srgbClr val="16181A"/>
+                          </a:solidFill>
+                          <a:latin typeface="Arial"/>
+                        </a:rPr>
+                        <a:t>Notebook vector editor and persistence</a:t>
+                      </a:r>
+                    </a:p>
+                  </a:txBody>
+                  <a:tcPr marL="73152" marR="73152" marT="36576" marB="36576">
+                    <a:solidFill>
+                      <a:srgbClr val="FCFCFB"/>
+                    </a:solidFill>
+                  </a:tcPr>
+                </a:tc>
+                <a:tc>
+                  <a:txBody>
+                    <a:bodyPr/>
+                    <a:lstStyle/>
+                    <a:p>
+                      <a:pPr>
+                        <a:lnSpc>
+                          <a:spcPct val="115000"/>
+                        </a:lnSpc>
+                      </a:pPr>
+                      <a:r>
+                        <a:rPr sz="1250" b="0">
+                          <a:solidFill>
+                            <a:srgbClr val="16181A"/>
+                          </a:solidFill>
+                          <a:latin typeface="Arial"/>
+                        </a:rPr>
+                        <a:t>Planned</a:t>
+                      </a:r>
+                    </a:p>
+                  </a:txBody>
+                  <a:tcPr marL="73152" marR="73152" marT="36576" marB="36576">
+                    <a:solidFill>
+                      <a:srgbClr val="FCFCFB"/>
+                    </a:solidFill>
+                  </a:tcPr>
+                </a:tc>
+              </a:tr>
+              <a:tr h="384048">
+                <a:tc>
+                  <a:txBody>
+                    <a:bodyPr/>
+                    <a:lstStyle/>
+                    <a:p>
+                      <a:pPr>
+                        <a:lnSpc>
+                          <a:spcPct val="115000"/>
+                        </a:lnSpc>
+                      </a:pPr>
+                      <a:r>
+                        <a:rPr sz="1250" b="0">
+                          <a:solidFill>
+                            <a:srgbClr val="16181A"/>
+                          </a:solidFill>
+                          <a:latin typeface="Arial"/>
+                        </a:rPr>
+                        <a:t>M5</a:t>
+                      </a:r>
+                    </a:p>
+                  </a:txBody>
+                  <a:tcPr marL="73152" marR="73152" marT="36576" marB="36576">
+                    <a:solidFill>
+                      <a:srgbClr val="FCFCFB"/>
+                    </a:solidFill>
+                  </a:tcPr>
+                </a:tc>
+                <a:tc>
+                  <a:txBody>
+                    <a:bodyPr/>
+                    <a:lstStyle/>
+                    <a:p>
+                      <a:pPr>
+                        <a:lnSpc>
+                          <a:spcPct val="115000"/>
+                        </a:lnSpc>
+                      </a:pPr>
+                      <a:r>
+                        <a:rPr sz="1250" b="0">
+                          <a:solidFill>
+                            <a:srgbClr val="16181A"/>
+                          </a:solidFill>
+                          <a:latin typeface="Arial"/>
+                        </a:rPr>
+                        <a:t>Entity polish, atmosphere, audio, human playtest</a:t>
+                      </a:r>
+                    </a:p>
+                  </a:txBody>
+                  <a:tcPr marL="73152" marR="73152" marT="36576" marB="36576">
+                    <a:solidFill>
+                      <a:srgbClr val="FCFCFB"/>
+                    </a:solidFill>
+                  </a:tcPr>
+                </a:tc>
+                <a:tc>
+                  <a:txBody>
+                    <a:bodyPr/>
+                    <a:lstStyle/>
+                    <a:p>
+                      <a:pPr>
+                        <a:lnSpc>
+                          <a:spcPct val="115000"/>
+                        </a:lnSpc>
+                      </a:pPr>
+                      <a:r>
+                        <a:rPr sz="1250" b="0">
+                          <a:solidFill>
+                            <a:srgbClr val="16181A"/>
+                          </a:solidFill>
+                          <a:latin typeface="Arial"/>
+                        </a:rPr>
+                        <a:t>Planned</a:t>
+                      </a:r>
+                    </a:p>
+                  </a:txBody>
+                  <a:tcPr marL="73152" marR="73152" marT="36576" marB="36576">
+                    <a:solidFill>
+                      <a:srgbClr val="FCFCFB"/>
+                    </a:solidFill>
+                  </a:tcPr>
+                </a:tc>
+              </a:tr>
+              <a:tr h="384048">
+                <a:tc>
+                  <a:txBody>
+                    <a:bodyPr/>
+                    <a:lstStyle/>
+                    <a:p>
+                      <a:pPr>
+                        <a:lnSpc>
+                          <a:spcPct val="115000"/>
+                        </a:lnSpc>
+                      </a:pPr>
+                      <a:r>
+                        <a:rPr sz="1250" b="0">
+                          <a:solidFill>
+                            <a:srgbClr val="16181A"/>
+                          </a:solidFill>
+                          <a:latin typeface="Arial"/>
+                        </a:rPr>
+                        <a:t>M6</a:t>
+                      </a:r>
+                    </a:p>
+                  </a:txBody>
+                  <a:tcPr marL="73152" marR="73152" marT="36576" marB="36576">
+                    <a:solidFill>
+                      <a:srgbClr val="FCFCFB"/>
+                    </a:solidFill>
+                  </a:tcPr>
+                </a:tc>
+                <a:tc>
+                  <a:txBody>
+                    <a:bodyPr/>
+                    <a:lstStyle/>
+                    <a:p>
+                      <a:pPr>
+                        <a:lnSpc>
+                          <a:spcPct val="115000"/>
+                        </a:lnSpc>
+                      </a:pPr>
+                      <a:r>
+                        <a:rPr sz="1250" b="0">
+                          <a:solidFill>
+                            <a:srgbClr val="16181A"/>
+                          </a:solidFill>
+                          <a:latin typeface="Arial"/>
+                        </a:rPr>
+                        <a:t>Door motion-sensors — partial observation, so waiting conceals</a:t>
+                      </a:r>
+                    </a:p>
+                  </a:txBody>
+                  <a:tcPr marL="73152" marR="73152" marT="36576" marB="36576">
+                    <a:solidFill>
+                      <a:srgbClr val="FCFCFB"/>
+                    </a:solidFill>
+                  </a:tcPr>
+                </a:tc>
+                <a:tc>
+                  <a:txBody>
+                    <a:bodyPr/>
+                    <a:lstStyle/>
+                    <a:p>
+                      <a:pPr>
+                        <a:lnSpc>
+                          <a:spcPct val="115000"/>
+                        </a:lnSpc>
+                      </a:pPr>
+                      <a:r>
+                        <a:rPr sz="1250" b="0">
+                          <a:solidFill>
+                            <a:srgbClr val="16181A"/>
+                          </a:solidFill>
+                          <a:latin typeface="Arial"/>
+                        </a:rPr>
+                        <a:t>Specified</a:t>
+                      </a:r>
+                    </a:p>
+                  </a:txBody>
+                  <a:tcPr marL="73152" marR="73152" marT="36576" marB="36576">
+                    <a:solidFill>
+                      <a:srgbClr val="FCFCFB"/>
+                    </a:solidFill>
+                  </a:tcPr>
+                </a:tc>
+              </a:tr>
+              <a:tr h="384048">
+                <a:tc>
+                  <a:txBody>
+                    <a:bodyPr/>
+                    <a:lstStyle/>
+                    <a:p>
+                      <a:pPr>
+                        <a:lnSpc>
+                          <a:spcPct val="115000"/>
+                        </a:lnSpc>
+                      </a:pPr>
+                      <a:r>
+                        <a:rPr sz="1250" b="0">
+                          <a:solidFill>
+                            <a:srgbClr val="16181A"/>
+                          </a:solidFill>
+                          <a:latin typeface="Arial"/>
+                        </a:rPr>
+                        <a:t>M7</a:t>
+                      </a:r>
+                    </a:p>
+                  </a:txBody>
+                  <a:tcPr marL="73152" marR="73152" marT="36576" marB="36576">
+                    <a:solidFill>
+                      <a:srgbClr val="FCFCFB"/>
+                    </a:solidFill>
+                  </a:tcPr>
+                </a:tc>
+                <a:tc>
+                  <a:txBody>
+                    <a:bodyPr/>
+                    <a:lstStyle/>
+                    <a:p>
+                      <a:pPr>
+                        <a:lnSpc>
+                          <a:spcPct val="115000"/>
+                        </a:lnSpc>
+                      </a:pPr>
+                      <a:r>
+                        <a:rPr sz="1250" b="0">
+                          <a:solidFill>
+                            <a:srgbClr val="16181A"/>
+                          </a:solidFill>
+                          <a:latin typeface="Arial"/>
+                        </a:rPr>
+                        <a:t>Polygonal room tiles; side count is the difficulty setting</a:t>
+                      </a:r>
+                    </a:p>
+                  </a:txBody>
+                  <a:tcPr marL="73152" marR="73152" marT="36576" marB="36576">
+                    <a:solidFill>
+                      <a:srgbClr val="FCFCFB"/>
+                    </a:solidFill>
+                  </a:tcPr>
+                </a:tc>
+                <a:tc>
+                  <a:txBody>
+                    <a:bodyPr/>
+                    <a:lstStyle/>
+                    <a:p>
+                      <a:pPr>
+                        <a:lnSpc>
+                          <a:spcPct val="115000"/>
+                        </a:lnSpc>
+                      </a:pPr>
+                      <a:r>
+                        <a:rPr sz="1250" b="0">
+                          <a:solidFill>
+                            <a:srgbClr val="16181A"/>
+                          </a:solidFill>
+                          <a:latin typeface="Arial"/>
+                        </a:rPr>
+                        <a:t>Specified</a:t>
+                      </a:r>
+                    </a:p>
+                  </a:txBody>
+                  <a:tcPr marL="73152" marR="73152" marT="36576" marB="36576">
+                    <a:solidFill>
+                      <a:srgbClr val="FCFCFB"/>
+                    </a:solidFill>
+                  </a:tcPr>
+                </a:tc>
+              </a:tr>
+              <a:tr h="384048">
+                <a:tc>
+                  <a:txBody>
+                    <a:bodyPr/>
+                    <a:lstStyle/>
+                    <a:p>
+                      <a:pPr>
+                        <a:lnSpc>
+                          <a:spcPct val="115000"/>
+                        </a:lnSpc>
+                      </a:pPr>
+                      <a:r>
+                        <a:rPr sz="1250" b="0">
+                          <a:solidFill>
+                            <a:srgbClr val="16181A"/>
+                          </a:solidFill>
+                          <a:latin typeface="Arial"/>
+                        </a:rPr>
+                        <a:t>M8</a:t>
+                      </a:r>
+                    </a:p>
+                  </a:txBody>
+                  <a:tcPr marL="73152" marR="73152" marT="36576" marB="36576">
+                    <a:solidFill>
+                      <a:srgbClr val="FCFCFB"/>
+                    </a:solidFill>
+                  </a:tcPr>
+                </a:tc>
+                <a:tc>
+                  <a:txBody>
+                    <a:bodyPr/>
+                    <a:lstStyle/>
+                    <a:p>
+                      <a:pPr>
+                        <a:lnSpc>
+                          <a:spcPct val="115000"/>
+                        </a:lnSpc>
+                      </a:pPr>
+                      <a:r>
+                        <a:rPr sz="1250" b="0">
+                          <a:solidFill>
+                            <a:srgbClr val="16181A"/>
+                          </a:solidFill>
+                          <a:latin typeface="Arial"/>
+                        </a:rPr>
+                        <a:t>Outbound register with pre-send tampering; sensor blackouts</a:t>
+                      </a:r>
+                    </a:p>
+                  </a:txBody>
+                  <a:tcPr marL="73152" marR="73152" marT="36576" marB="36576">
+                    <a:solidFill>
+                      <a:srgbClr val="FCFCFB"/>
+                    </a:solidFill>
+                  </a:tcPr>
+                </a:tc>
+                <a:tc>
+                  <a:txBody>
+                    <a:bodyPr/>
+                    <a:lstStyle/>
+                    <a:p>
+                      <a:pPr>
+                        <a:lnSpc>
+                          <a:spcPct val="115000"/>
+                        </a:lnSpc>
+                      </a:pPr>
+                      <a:r>
+                        <a:rPr sz="1250" b="0">
+                          <a:solidFill>
+                            <a:srgbClr val="16181A"/>
+                          </a:solidFill>
+                          <a:latin typeface="Arial"/>
+                        </a:rPr>
+                        <a:t>Specified</a:t>
+                      </a:r>
+                    </a:p>
+                  </a:txBody>
+                  <a:tcPr marL="73152" marR="73152" marT="36576" marB="36576">
+                    <a:solidFill>
+                      <a:srgbClr val="FCFCFB"/>
+                    </a:solidFill>
+                  </a:tcPr>
+                </a:tc>
+              </a:tr>
+            </a:tbl>
+          </a:graphicData>
+        </a:graphic>
+      </p:graphicFrame>
+      <p:sp>
+        <p:nvSpPr>
+          <p:cNvPr id="6" name="TextBox 5"/>
+          <p:cNvSpPr txBox="1"/>
+          <p:nvPr/>
+        </p:nvSpPr>
+        <p:spPr>
+          <a:xfrm>
+            <a:off x="658368" y="4663440"/>
+            <a:ext cx="10881360" cy="1097280"/>
+          </a:xfrm>
+          <a:prstGeom prst="rect">
+            <a:avLst/>
+          </a:prstGeom>
+          <a:noFill/>
+        </p:spPr>
+        <p:txBody>
+          <a:bodyPr wrap="square" lIns="0" rIns="0" tIns="0" bIns="0">
+            <a:spAutoFit/>
+          </a:bodyPr>
+          <a:lstStyle/>
+          <a:p>
+            <a:pPr algn="l">
+              <a:lnSpc>
+                <a:spcPct val="135000"/>
+              </a:lnSpc>
+              <a:spcAft>
+                <a:spcPts val="600"/>
+              </a:spcAft>
+            </a:pPr>
+            <a:r>
+              <a:rPr sz="1300" b="0">
+                <a:solidFill>
+                  <a:srgbClr val="6B7178"/>
+                </a:solidFill>
+                <a:latin typeface="Arial"/>
+              </a:rPr>
+              <a:t>Art direction for M3 is settled: a low-poly modular brutalist kit instantiated from the room graph, near-total darkness with a flashlight, heavy fog, and a retro post-processing pass — chosen because it minimises modelling cost while staying coherent. Modularity is not a style choice: rooms are rotated, added and removed at runtime, so they must be prefab-instantiated regardless.</a:t>
+            </a:r>
+          </a:p>
+        </p:txBody>
+      </p:sp>
+    </p:spTree>
+  </p:cSld>
+  <p:clrMapOvr>
+    <a:masterClrMapping/>
+  </p:clrMapOvr>
+</p:sld>
+</file>
+
+<file path=ppt/slides/slide28.xml><?xml version="1.0" encoding="utf-8"?>
+<p:sld xmlns:a="http://schemas.openxmlformats.org/drawingml/2006/main" xmlns:p="http://schemas.openxmlformats.org/presentationml/2006/main" xmlns:r="http://schemas.openxmlformats.org/officeDocument/2006/relationships">
+  <p:cSld>
+    <p:bg>
+      <p:bgPr>
+        <a:solidFill>
+          <a:srgbClr val="FCFCFB"/>
+        </a:solidFill>
+        <a:effectLst/>
+      </p:bgPr>
+    </p:bg>
+    <p:spTree>
+      <p:nvGrpSpPr>
+        <p:cNvPr id="1" name=""/>
+        <p:cNvGrpSpPr/>
+        <p:nvPr/>
+      </p:nvGrpSpPr>
+      <p:grpSpPr/>
+      <p:sp>
+        <p:nvSpPr>
+          <p:cNvPr id="2" name="TextBox 1"/>
+          <p:cNvSpPr txBox="1"/>
+          <p:nvPr/>
+        </p:nvSpPr>
+        <p:spPr>
+          <a:xfrm>
+            <a:off x="658368" y="420624"/>
+            <a:ext cx="10881360" cy="274320"/>
+          </a:xfrm>
+          <a:prstGeom prst="rect">
+            <a:avLst/>
+          </a:prstGeom>
+          <a:noFill/>
+        </p:spPr>
+        <p:txBody>
+          <a:bodyPr wrap="square" lIns="0" rIns="0" tIns="0" bIns="0">
+            <a:spAutoFit/>
+          </a:bodyPr>
+          <a:lstStyle/>
+          <a:p>
+            <a:pPr algn="l">
+              <a:lnSpc>
+                <a:spcPct val="125000"/>
+              </a:lnSpc>
+              <a:spcAft>
+                <a:spcPts val="600"/>
+              </a:spcAft>
+            </a:pPr>
+            <a:r>
+              <a:rPr sz="1050" b="1">
+                <a:solidFill>
+                  <a:srgbClr val="2A78D6"/>
+                </a:solidFill>
+                <a:latin typeface="Arial"/>
+              </a:rPr>
+              <a:t>REFERENCES</a:t>
+            </a:r>
+          </a:p>
+        </p:txBody>
+      </p:sp>
+      <p:sp>
+        <p:nvSpPr>
+          <p:cNvPr id="3" name="TextBox 2"/>
+          <p:cNvSpPr txBox="1"/>
+          <p:nvPr/>
+        </p:nvSpPr>
+        <p:spPr>
+          <a:xfrm>
+            <a:off x="658368" y="749808"/>
+            <a:ext cx="10881360" cy="822960"/>
+          </a:xfrm>
+          <a:prstGeom prst="rect">
+            <a:avLst/>
+          </a:prstGeom>
+          <a:noFill/>
+        </p:spPr>
+        <p:txBody>
+          <a:bodyPr wrap="square" lIns="0" rIns="0" tIns="0" bIns="0">
+            <a:spAutoFit/>
+          </a:bodyPr>
+          <a:lstStyle/>
+          <a:p>
+            <a:pPr algn="l">
+              <a:lnSpc>
+                <a:spcPct val="125000"/>
+              </a:lnSpc>
+              <a:spcAft>
+                <a:spcPts val="600"/>
+              </a:spcAft>
+            </a:pPr>
+            <a:r>
+              <a:rPr sz="2800" b="1">
+                <a:solidFill>
+                  <a:srgbClr val="16181A"/>
+                </a:solidFill>
+                <a:latin typeface="Arial"/>
+              </a:rPr>
+              <a:t>1 of 2</a:t>
+            </a:r>
+          </a:p>
+        </p:txBody>
+      </p:sp>
+      <p:sp>
+        <p:nvSpPr>
+          <p:cNvPr id="4" name="Rectangle 3"/>
+          <p:cNvSpPr/>
+          <p:nvPr/>
+        </p:nvSpPr>
+        <p:spPr>
+          <a:xfrm>
+            <a:off x="658368" y="1481328"/>
+            <a:ext cx="10881360" cy="18288"/>
+          </a:xfrm>
+          <a:prstGeom prst="rect">
+            <a:avLst/>
+          </a:prstGeom>
+          <a:solidFill>
+            <a:srgbClr val="D8DCE0"/>
+          </a:solidFill>
+          <a:ln>
+            <a:noFill/>
+          </a:ln>
+          <a:effectLst/>
+        </p:spPr>
+        <p:style>
+          <a:lnRef idx="1">
+            <a:schemeClr val="accent1"/>
+          </a:lnRef>
+          <a:fillRef idx="3">
+            <a:schemeClr val="accent1"/>
+          </a:fillRef>
+          <a:effectRef idx="2">
+            <a:schemeClr val="accent1"/>
+          </a:effectRef>
+          <a:fontRef idx="minor">
+            <a:schemeClr val="lt1"/>
+          </a:fontRef>
+        </p:style>
+        <p:txBody>
+          <a:bodyPr rtlCol="0" anchor="ctr"/>
+          <a:lstStyle/>
+          <a:p>
+            <a:pPr algn="ctr"/>
+          </a:p>
+        </p:txBody>
+      </p:sp>
       <p:sp>
         <p:nvSpPr>
           <p:cNvPr id="5" name="TextBox 4"/>
@@ -15467,7 +15688,7 @@
 </p:sld>
 </file>
 
-<file path=ppt/slides/slide28.xml><?xml version="1.0" encoding="utf-8"?>
+<file path=ppt/slides/slide29.xml><?xml version="1.0" encoding="utf-8"?>
 <p:sld xmlns:a="http://schemas.openxmlformats.org/drawingml/2006/main" xmlns:p="http://schemas.openxmlformats.org/presentationml/2006/main" xmlns:r="http://schemas.openxmlformats.org/officeDocument/2006/relationships">
   <p:cSld>
     <p:bg>

</xml_diff>